<commit_message>
Add the appendix pages to the submission deck; update the web deck's layout editor card; tests: wait for the status panel, open the folded expert panel
</commit_message>
<xml_diff>
--- a/submission/Tolerance - AI Builder Cup submission.pptx
+++ b/submission/Tolerance - AI Builder Cup submission.pptx
@@ -21,6 +21,11 @@
     <p:sldId id="267" r:id="rId17"/>
     <p:sldId id="268" r:id="rId18"/>
     <p:sldId id="269" r:id="rId19"/>
+    <p:sldId id="272" r:id="rId28"/>
+    <p:sldId id="273" r:id="rId29"/>
+    <p:sldId id="274" r:id="rId30"/>
+    <p:sldId id="275" r:id="rId31"/>
+    <p:sldId id="276" r:id="rId32"/>
     <p:sldId id="271" r:id="rId21"/>
   </p:sldIdLst>
   <p:sldSz cy="5143500" cx="9144000"/>
@@ -11241,6 +11246,4146 @@
 </p:sld>
 </file>
 
+<file path=ppt/slides/slide17.xml><?xml version="1.0" encoding="utf-8"?>
+<p:sld xmlns:a="http://schemas.openxmlformats.org/drawingml/2006/main" xmlns:r="http://schemas.openxmlformats.org/officeDocument/2006/relationships" xmlns:mc="http://schemas.openxmlformats.org/markup-compatibility/2006" xmlns:mv="urn:schemas-microsoft-com:mac:vml" xmlns:p="http://schemas.openxmlformats.org/presentationml/2006/main" xmlns:c="http://schemas.openxmlformats.org/drawingml/2006/chart" xmlns:dgm="http://schemas.openxmlformats.org/drawingml/2006/diagram" xmlns:o="urn:schemas-microsoft-com:office:office" xmlns:v="urn:schemas-microsoft-com:vml" xmlns:pvml="urn:schemas-microsoft-com:office:powerpoint" xmlns:com="http://schemas.openxmlformats.org/drawingml/2006/compatibility" xmlns:p14="http://schemas.microsoft.com/office/powerpoint/2010/main" xmlns:p15="http://schemas.microsoft.com/office/powerpoint/2012/main" xmlns:ahyp="http://schemas.microsoft.com/office/drawing/2018/hyperlinkcolor">
+  <p:cSld>
+    <p:spTree>
+      <p:nvGrpSpPr>
+        <p:cNvPr id="147" name="Shape 147"/>
+        <p:cNvGrpSpPr/>
+        <p:nvPr/>
+      </p:nvGrpSpPr>
+      <p:grpSpPr>
+        <a:xfrm>
+          <a:off x="0" y="0"/>
+          <a:ext cx="0" cy="0"/>
+          <a:chOff x="0" y="0"/>
+          <a:chExt cx="0" cy="0"/>
+        </a:xfrm>
+      </p:grpSpPr>
+      <p:pic>
+        <p:nvPicPr>
+          <p:cNvPr id="148" name="Google Shape;148;p25" title="Frame 144.png"/>
+          <p:cNvPicPr preferRelativeResize="0"/>
+          <p:nvPr/>
+        </p:nvPicPr>
+        <p:blipFill rotWithShape="1">
+          <a:blip r:embed="rId3">
+            <a:alphaModFix/>
+          </a:blip>
+          <a:srcRect b="98001" l="0" r="0" t="0"/>
+          <a:stretch/>
+        </p:blipFill>
+        <p:spPr>
+          <a:xfrm>
+            <a:off x="0" y="5093562"/>
+            <a:ext cx="9144000" cy="54275"/>
+          </a:xfrm>
+          <a:prstGeom prst="rect">
+            <a:avLst/>
+          </a:prstGeom>
+          <a:noFill/>
+          <a:ln>
+            <a:noFill/>
+          </a:ln>
+        </p:spPr>
+      </p:pic>
+      <p:pic>
+        <p:nvPicPr>
+          <p:cNvPr id="149" name="Google Shape;149;p25" title="Group 427319979.png"/>
+          <p:cNvPicPr preferRelativeResize="0"/>
+          <p:nvPr/>
+        </p:nvPicPr>
+        <p:blipFill>
+          <a:blip r:embed="rId4">
+            <a:alphaModFix/>
+          </a:blip>
+          <a:stretch>
+            <a:fillRect/>
+          </a:stretch>
+        </p:blipFill>
+        <p:spPr>
+          <a:xfrm>
+            <a:off x="0" y="1"/>
+            <a:ext cx="9144000" cy="507359"/>
+          </a:xfrm>
+          <a:prstGeom prst="rect">
+            <a:avLst/>
+          </a:prstGeom>
+          <a:noFill/>
+          <a:ln>
+            <a:noFill/>
+          </a:ln>
+        </p:spPr>
+      </p:pic>
+      <p:sp>
+        <p:nvSpPr>
+          <p:cNvPr id="150" name="Google Shape;150;p25"/>
+          <p:cNvSpPr/>
+          <p:nvPr/>
+        </p:nvSpPr>
+        <p:spPr>
+          <a:xfrm>
+            <a:off x="-29250" y="5071875"/>
+            <a:ext cx="9173400" cy="97800"/>
+          </a:xfrm>
+          <a:prstGeom prst="rect">
+            <a:avLst/>
+          </a:prstGeom>
+          <a:solidFill>
+            <a:schemeClr val="dk1"/>
+          </a:solidFill>
+          <a:ln>
+            <a:noFill/>
+          </a:ln>
+        </p:spPr>
+        <p:txBody>
+          <a:bodyPr anchorCtr="0" anchor="ctr" bIns="91425" lIns="91425" spcFirstLastPara="1" rIns="91425" wrap="square" tIns="91425">
+            <a:noAutofit/>
+          </a:bodyPr>
+          <a:lstStyle/>
+          <a:p>
+            <a:pPr indent="0" lvl="0" marL="0" rtl="0" algn="ctr">
+              <a:spcBef>
+                <a:spcPts val="0"/>
+              </a:spcBef>
+              <a:spcAft>
+                <a:spcPts val="0"/>
+              </a:spcAft>
+              <a:buNone/>
+            </a:pPr>
+            <a:r>
+              <a:t/>
+            </a:r>
+            <a:endParaRPr/>
+          </a:p>
+        </p:txBody>
+      </p:sp>
+      <p:sp>
+        <p:nvSpPr>
+          <p:cNvPr id="151" name="Google Shape;151;p25"/>
+          <p:cNvSpPr txBox="1"/>
+          <p:nvPr/>
+        </p:nvSpPr>
+        <p:spPr>
+          <a:xfrm>
+            <a:off x="265350" y="663825"/>
+            <a:ext cx="8943000" cy="502920"/>
+          </a:xfrm>
+          <a:prstGeom prst="rect">
+            <a:avLst/>
+          </a:prstGeom>
+          <a:noFill/>
+          <a:ln>
+            <a:noFill/>
+          </a:ln>
+        </p:spPr>
+        <p:txBody>
+          <a:bodyPr anchorCtr="0" anchor="t" bIns="91425" lIns="91425" spcFirstLastPara="1" rIns="91425" wrap="square" tIns="91425">
+            <a:noAutofit/>
+          </a:bodyPr>
+          <a:lstStyle/>
+          <a:p>
+            <a:pPr indent="0" lvl="0" marL="0" rtl="0" algn="l">
+              <a:spcBef>
+                <a:spcPts val="0"/>
+              </a:spcBef>
+              <a:spcAft>
+                <a:spcPts val="0"/>
+              </a:spcAft>
+              <a:buNone/>
+            </a:pPr>
+            <a:r>
+              <a:rPr lang="en-GB" sz="1600">
+                <a:latin typeface="Google Sans Flex Medium"/>
+                <a:ea typeface="Google Sans Flex Medium"/>
+                <a:cs typeface="Google Sans Flex Medium"/>
+                <a:sym typeface="Google Sans Flex Medium"/>
+              </a:rPr>
+              <a:t>Appendix: the journey, from documents to a decision</a:t>
+            </a:r>
+            <a:endParaRPr sz="1600">
+              <a:latin typeface="Google Sans Flex Medium"/>
+              <a:ea typeface="Google Sans Flex Medium"/>
+              <a:cs typeface="Google Sans Flex Medium"/>
+              <a:sym typeface="Google Sans Flex Medium"/>
+            </a:endParaRPr>
+          </a:p>
+        </p:txBody>
+      </p:sp>
+      <p:pic>
+        <p:nvPicPr>
+          <p:cNvPr id="152" name="Journey diagram" descr="02-demo-journey_crop.png"/>
+          <p:cNvPicPr>
+            <a:picLocks noChangeAspect="1"/>
+          </p:cNvPicPr>
+          <p:nvPr/>
+        </p:nvPicPr>
+        <p:blipFill>
+          <a:blip r:embed="rId2"/>
+          <a:stretch>
+            <a:fillRect/>
+          </a:stretch>
+        </p:blipFill>
+        <p:spPr>
+          <a:xfrm>
+            <a:off x="274320" y="1310968"/>
+            <a:ext cx="5669280" cy="2407263"/>
+          </a:xfrm>
+          <a:prstGeom prst="rect">
+            <a:avLst/>
+          </a:prstGeom>
+        </p:spPr>
+      </p:pic>
+      <p:sp>
+        <p:nvSpPr>
+          <p:cNvPr id="153" name="text"/>
+          <p:cNvSpPr txBox="1"/>
+          <p:nvPr/>
+        </p:nvSpPr>
+        <p:spPr>
+          <a:xfrm>
+            <a:off x="6126480" y="1188720"/>
+            <a:ext cx="2743200" cy="3566160"/>
+          </a:xfrm>
+          <a:prstGeom prst="rect">
+            <a:avLst/>
+          </a:prstGeom>
+          <a:noFill/>
+        </p:spPr>
+        <p:txBody>
+          <a:bodyPr wrap="square" anchor="t" lIns="36576" rIns="36576" tIns="18288" bIns="18288">
+            <a:spAutoFit/>
+          </a:bodyPr>
+          <a:lstStyle/>
+          <a:p>
+            <a:pPr algn="l">
+              <a:spcAft>
+                <a:spcPts val="600"/>
+              </a:spcAft>
+            </a:pPr>
+            <a:r>
+              <a:rPr sz="1200" b="1">
+                <a:solidFill>
+                  <a:srgbClr val="1A73E8"/>
+                </a:solidFill>
+                <a:latin typeface="Google Sans Flex SemiBold"/>
+              </a:rPr>
+              <a:t>Six steps</a:t>
+            </a:r>
+          </a:p>
+          <a:p>
+            <a:pPr algn="l" marL="164592" indent="-164592">
+              <a:spcAft>
+                <a:spcPts val="500"/>
+              </a:spcAft>
+              <a:buChar char="•"/>
+            </a:pPr>
+            <a:r>
+              <a:rPr sz="1050" b="0">
+                <a:solidFill>
+                  <a:srgbClr val="202124"/>
+                </a:solidFill>
+                <a:latin typeface="Google Sans Flex"/>
+              </a:rPr>
+              <a:t>You provide the documents and name the systems that hold the data.</a:t>
+            </a:r>
+          </a:p>
+          <a:p>
+            <a:pPr algn="l" marL="164592" indent="-164592">
+              <a:spcAft>
+                <a:spcPts val="500"/>
+              </a:spcAft>
+              <a:buChar char="•"/>
+            </a:pPr>
+            <a:r>
+              <a:rPr sz="1050" b="0">
+                <a:solidFill>
+                  <a:srgbClr val="202124"/>
+                </a:solidFill>
+                <a:latin typeface="Google Sans Flex"/>
+              </a:rPr>
+              <a:t>The agents read, connect and compile. You confirm what was understood.</a:t>
+            </a:r>
+          </a:p>
+          <a:p>
+            <a:pPr algn="l" marL="164592" indent="-164592">
+              <a:spcAft>
+                <a:spcPts val="500"/>
+              </a:spcAft>
+              <a:buChar char="•"/>
+            </a:pPr>
+            <a:r>
+              <a:rPr sz="1050" b="0">
+                <a:solidFill>
+                  <a:srgbClr val="202124"/>
+                </a:solidFill>
+                <a:latin typeface="Google Sans Flex"/>
+              </a:rPr>
+              <a:t>The plant is built from the checked facts, in 2D and 3D.</a:t>
+            </a:r>
+          </a:p>
+          <a:p>
+            <a:pPr algn="l" marL="164592" indent="-164592">
+              <a:spcAft>
+                <a:spcPts val="400"/>
+              </a:spcAft>
+              <a:buChar char="•"/>
+            </a:pPr>
+            <a:r>
+              <a:rPr sz="1050" b="0">
+                <a:solidFill>
+                  <a:srgbClr val="202124"/>
+                </a:solidFill>
+                <a:latin typeface="Google Sans Flex"/>
+              </a:rPr>
+              <a:t>When a fault is found, the agents gather evidence. The gate decides: it runs alone, or it asks you.</a:t>
+            </a:r>
+          </a:p>
+        </p:txBody>
+      </p:sp>
+      <p:sp>
+        <p:nvSpPr>
+          <p:cNvPr id="154" name="text"/>
+          <p:cNvSpPr txBox="1"/>
+          <p:nvPr/>
+        </p:nvSpPr>
+        <p:spPr>
+          <a:xfrm>
+            <a:off x="274320" y="3840480"/>
+            <a:ext cx="5669280" cy="822960"/>
+          </a:xfrm>
+          <a:prstGeom prst="rect">
+            <a:avLst/>
+          </a:prstGeom>
+          <a:noFill/>
+        </p:spPr>
+        <p:txBody>
+          <a:bodyPr wrap="square" anchor="t" lIns="36576" rIns="36576" tIns="18288" bIns="18288">
+            <a:spAutoFit/>
+          </a:bodyPr>
+          <a:lstStyle/>
+          <a:p>
+            <a:pPr algn="l">
+              <a:spcAft>
+                <a:spcPts val="400"/>
+              </a:spcAft>
+            </a:pPr>
+            <a:r>
+              <a:rPr sz="1000" b="0">
+                <a:solidFill>
+                  <a:srgbClr val="5F6368"/>
+                </a:solidFill>
+                <a:latin typeface="Google Sans Flex"/>
+              </a:rPr>
+              <a:t>Boxes in grey are what you provide, in blue what the agents do, in red a decision.</a:t>
+            </a:r>
+          </a:p>
+        </p:txBody>
+      </p:sp>
+    </p:spTree>
+  </p:cSld>
+  <p:clrMapOvr>
+    <a:masterClrMapping/>
+  </p:clrMapOvr>
+</p:sld>
+</file>
+
+<file path=ppt/slides/slide18.xml><?xml version="1.0" encoding="utf-8"?>
+<p:sld xmlns:a="http://schemas.openxmlformats.org/drawingml/2006/main" xmlns:r="http://schemas.openxmlformats.org/officeDocument/2006/relationships" xmlns:mc="http://schemas.openxmlformats.org/markup-compatibility/2006" xmlns:mv="urn:schemas-microsoft-com:mac:vml" xmlns:p="http://schemas.openxmlformats.org/presentationml/2006/main" xmlns:c="http://schemas.openxmlformats.org/drawingml/2006/chart" xmlns:dgm="http://schemas.openxmlformats.org/drawingml/2006/diagram" xmlns:o="urn:schemas-microsoft-com:office:office" xmlns:v="urn:schemas-microsoft-com:vml" xmlns:pvml="urn:schemas-microsoft-com:office:powerpoint" xmlns:com="http://schemas.openxmlformats.org/drawingml/2006/compatibility" xmlns:p14="http://schemas.microsoft.com/office/powerpoint/2010/main" xmlns:p15="http://schemas.microsoft.com/office/powerpoint/2012/main" xmlns:ahyp="http://schemas.microsoft.com/office/drawing/2018/hyperlinkcolor">
+  <p:cSld>
+    <p:spTree>
+      <p:nvGrpSpPr>
+        <p:cNvPr id="147" name="Shape 147"/>
+        <p:cNvGrpSpPr/>
+        <p:nvPr/>
+      </p:nvGrpSpPr>
+      <p:grpSpPr>
+        <a:xfrm>
+          <a:off x="0" y="0"/>
+          <a:ext cx="0" cy="0"/>
+          <a:chOff x="0" y="0"/>
+          <a:chExt cx="0" cy="0"/>
+        </a:xfrm>
+      </p:grpSpPr>
+      <p:pic>
+        <p:nvPicPr>
+          <p:cNvPr id="148" name="Google Shape;148;p25" title="Frame 144.png"/>
+          <p:cNvPicPr preferRelativeResize="0"/>
+          <p:nvPr/>
+        </p:nvPicPr>
+        <p:blipFill rotWithShape="1">
+          <a:blip r:embed="rId3">
+            <a:alphaModFix/>
+          </a:blip>
+          <a:srcRect b="98001" l="0" r="0" t="0"/>
+          <a:stretch/>
+        </p:blipFill>
+        <p:spPr>
+          <a:xfrm>
+            <a:off x="0" y="5093562"/>
+            <a:ext cx="9144000" cy="54275"/>
+          </a:xfrm>
+          <a:prstGeom prst="rect">
+            <a:avLst/>
+          </a:prstGeom>
+          <a:noFill/>
+          <a:ln>
+            <a:noFill/>
+          </a:ln>
+        </p:spPr>
+      </p:pic>
+      <p:pic>
+        <p:nvPicPr>
+          <p:cNvPr id="149" name="Google Shape;149;p25" title="Group 427319979.png"/>
+          <p:cNvPicPr preferRelativeResize="0"/>
+          <p:nvPr/>
+        </p:nvPicPr>
+        <p:blipFill>
+          <a:blip r:embed="rId4">
+            <a:alphaModFix/>
+          </a:blip>
+          <a:stretch>
+            <a:fillRect/>
+          </a:stretch>
+        </p:blipFill>
+        <p:spPr>
+          <a:xfrm>
+            <a:off x="0" y="1"/>
+            <a:ext cx="9144000" cy="507359"/>
+          </a:xfrm>
+          <a:prstGeom prst="rect">
+            <a:avLst/>
+          </a:prstGeom>
+          <a:noFill/>
+          <a:ln>
+            <a:noFill/>
+          </a:ln>
+        </p:spPr>
+      </p:pic>
+      <p:sp>
+        <p:nvSpPr>
+          <p:cNvPr id="150" name="Google Shape;150;p25"/>
+          <p:cNvSpPr/>
+          <p:nvPr/>
+        </p:nvSpPr>
+        <p:spPr>
+          <a:xfrm>
+            <a:off x="-29250" y="5071875"/>
+            <a:ext cx="9173400" cy="97800"/>
+          </a:xfrm>
+          <a:prstGeom prst="rect">
+            <a:avLst/>
+          </a:prstGeom>
+          <a:solidFill>
+            <a:schemeClr val="dk1"/>
+          </a:solidFill>
+          <a:ln>
+            <a:noFill/>
+          </a:ln>
+        </p:spPr>
+        <p:txBody>
+          <a:bodyPr anchorCtr="0" anchor="ctr" bIns="91425" lIns="91425" spcFirstLastPara="1" rIns="91425" wrap="square" tIns="91425">
+            <a:noAutofit/>
+          </a:bodyPr>
+          <a:lstStyle/>
+          <a:p>
+            <a:pPr indent="0" lvl="0" marL="0" rtl="0" algn="ctr">
+              <a:spcBef>
+                <a:spcPts val="0"/>
+              </a:spcBef>
+              <a:spcAft>
+                <a:spcPts val="0"/>
+              </a:spcAft>
+              <a:buNone/>
+            </a:pPr>
+            <a:r>
+              <a:t/>
+            </a:r>
+            <a:endParaRPr/>
+          </a:p>
+        </p:txBody>
+      </p:sp>
+      <p:sp>
+        <p:nvSpPr>
+          <p:cNvPr id="151" name="Google Shape;151;p25"/>
+          <p:cNvSpPr txBox="1"/>
+          <p:nvPr/>
+        </p:nvSpPr>
+        <p:spPr>
+          <a:xfrm>
+            <a:off x="265350" y="663825"/>
+            <a:ext cx="8943000" cy="502920"/>
+          </a:xfrm>
+          <a:prstGeom prst="rect">
+            <a:avLst/>
+          </a:prstGeom>
+          <a:noFill/>
+          <a:ln>
+            <a:noFill/>
+          </a:ln>
+        </p:spPr>
+        <p:txBody>
+          <a:bodyPr anchorCtr="0" anchor="t" bIns="91425" lIns="91425" spcFirstLastPara="1" rIns="91425" wrap="square" tIns="91425">
+            <a:noAutofit/>
+          </a:bodyPr>
+          <a:lstStyle/>
+          <a:p>
+            <a:pPr indent="0" lvl="0" marL="0" rtl="0" algn="l">
+              <a:spcBef>
+                <a:spcPts val="0"/>
+              </a:spcBef>
+              <a:spcAft>
+                <a:spcPts val="0"/>
+              </a:spcAft>
+              <a:buNone/>
+            </a:pPr>
+            <a:r>
+              <a:rPr lang="en-GB" sz="1600">
+                <a:latin typeface="Google Sans Flex Medium"/>
+                <a:ea typeface="Google Sans Flex Medium"/>
+                <a:cs typeface="Google Sans Flex Medium"/>
+                <a:sym typeface="Google Sans Flex Medium"/>
+              </a:rPr>
+              <a:t>Appendix: the safety gate, limits first and then the score</a:t>
+            </a:r>
+            <a:endParaRPr sz="1600">
+              <a:latin typeface="Google Sans Flex Medium"/>
+              <a:ea typeface="Google Sans Flex Medium"/>
+              <a:cs typeface="Google Sans Flex Medium"/>
+              <a:sym typeface="Google Sans Flex Medium"/>
+            </a:endParaRPr>
+          </a:p>
+        </p:txBody>
+      </p:sp>
+      <p:pic>
+        <p:nvPicPr>
+          <p:cNvPr id="152" name="Safety gate diagram" descr="03-safety-gate_crop.png"/>
+          <p:cNvPicPr>
+            <a:picLocks noChangeAspect="1"/>
+          </p:cNvPicPr>
+          <p:nvPr/>
+        </p:nvPicPr>
+        <p:blipFill>
+          <a:blip r:embed="rId2"/>
+          <a:stretch>
+            <a:fillRect/>
+          </a:stretch>
+        </p:blipFill>
+        <p:spPr>
+          <a:xfrm>
+            <a:off x="274320" y="1212635"/>
+            <a:ext cx="5120640" cy="3426889"/>
+          </a:xfrm>
+          <a:prstGeom prst="rect">
+            <a:avLst/>
+          </a:prstGeom>
+        </p:spPr>
+      </p:pic>
+      <p:sp>
+        <p:nvSpPr>
+          <p:cNvPr id="153" name="text"/>
+          <p:cNvSpPr txBox="1"/>
+          <p:nvPr/>
+        </p:nvSpPr>
+        <p:spPr>
+          <a:xfrm>
+            <a:off x="5577840" y="1188720"/>
+            <a:ext cx="3291840" cy="3566160"/>
+          </a:xfrm>
+          <a:prstGeom prst="rect">
+            <a:avLst/>
+          </a:prstGeom>
+          <a:noFill/>
+        </p:spPr>
+        <p:txBody>
+          <a:bodyPr wrap="square" anchor="t" lIns="36576" rIns="36576" tIns="18288" bIns="18288">
+            <a:spAutoFit/>
+          </a:bodyPr>
+          <a:lstStyle/>
+          <a:p>
+            <a:pPr algn="l">
+              <a:spcAft>
+                <a:spcPts val="600"/>
+              </a:spcAft>
+            </a:pPr>
+            <a:r>
+              <a:rPr sz="1200" b="1">
+                <a:solidFill>
+                  <a:srgbClr val="1A73E8"/>
+                </a:solidFill>
+                <a:latin typeface="Google Sans Flex SemiBold"/>
+              </a:rPr>
+              <a:t>Why this order</a:t>
+            </a:r>
+          </a:p>
+          <a:p>
+            <a:pPr algn="l" marL="164592" indent="-164592">
+              <a:spcAft>
+                <a:spcPts val="500"/>
+              </a:spcAft>
+              <a:buChar char="•"/>
+            </a:pPr>
+            <a:r>
+              <a:rPr sz="1050" b="0">
+                <a:solidFill>
+                  <a:srgbClr val="202124"/>
+                </a:solidFill>
+                <a:latin typeface="Google Sans Flex"/>
+              </a:rPr>
+              <a:t>A hard limit from your documents comes first. A score never overrides it.</a:t>
+            </a:r>
+          </a:p>
+          <a:p>
+            <a:pPr algn="l" marL="164592" indent="-164592">
+              <a:spcAft>
+                <a:spcPts val="500"/>
+              </a:spcAft>
+              <a:buChar char="•"/>
+            </a:pPr>
+            <a:r>
+              <a:rPr sz="1050" b="0">
+                <a:solidFill>
+                  <a:srgbClr val="202124"/>
+                </a:solidFill>
+                <a:latin typeface="Google Sans Flex"/>
+              </a:rPr>
+              <a:t>Warden then scores the action from 0 to 100 on six factors: can it be undone, how much it touches, distance from the limits, strength of the evidence, what people approved before, and the state of the plant.</a:t>
+            </a:r>
+          </a:p>
+          <a:p>
+            <a:pPr algn="l" marL="164592" indent="-164592">
+              <a:spcAft>
+                <a:spcPts val="500"/>
+              </a:spcAft>
+              <a:buChar char="•"/>
+            </a:pPr>
+            <a:r>
+              <a:rPr sz="1050" b="0">
+                <a:solidFill>
+                  <a:srgbClr val="202124"/>
+                </a:solidFill>
+                <a:latin typeface="Google Sans Flex"/>
+              </a:rPr>
+              <a:t>You set the floor and the limit. Below the floor it is refused. In the middle you approve. At or above the limit it runs by itself.</a:t>
+            </a:r>
+          </a:p>
+          <a:p>
+            <a:pPr algn="l" marL="164592" indent="-164592">
+              <a:spcAft>
+                <a:spcPts val="400"/>
+              </a:spcAft>
+              <a:buChar char="•"/>
+            </a:pPr>
+            <a:r>
+              <a:rPr sz="1050" b="0">
+                <a:solidFill>
+                  <a:srgbClr val="202124"/>
+                </a:solidFill>
+                <a:latin typeface="Google Sans Flex"/>
+              </a:rPr>
+              <a:t>You see what your lines would have done on 465 recorded incidents before you trust them.</a:t>
+            </a:r>
+          </a:p>
+        </p:txBody>
+      </p:sp>
+    </p:spTree>
+  </p:cSld>
+  <p:clrMapOvr>
+    <a:masterClrMapping/>
+  </p:clrMapOvr>
+</p:sld>
+</file>
+
+<file path=ppt/slides/slide19.xml><?xml version="1.0" encoding="utf-8"?>
+<p:sld xmlns:a="http://schemas.openxmlformats.org/drawingml/2006/main" xmlns:r="http://schemas.openxmlformats.org/officeDocument/2006/relationships" xmlns:mc="http://schemas.openxmlformats.org/markup-compatibility/2006" xmlns:mv="urn:schemas-microsoft-com:mac:vml" xmlns:p="http://schemas.openxmlformats.org/presentationml/2006/main" xmlns:c="http://schemas.openxmlformats.org/drawingml/2006/chart" xmlns:dgm="http://schemas.openxmlformats.org/drawingml/2006/diagram" xmlns:o="urn:schemas-microsoft-com:office:office" xmlns:v="urn:schemas-microsoft-com:vml" xmlns:pvml="urn:schemas-microsoft-com:office:powerpoint" xmlns:com="http://schemas.openxmlformats.org/drawingml/2006/compatibility" xmlns:p14="http://schemas.microsoft.com/office/powerpoint/2010/main" xmlns:p15="http://schemas.microsoft.com/office/powerpoint/2012/main" xmlns:ahyp="http://schemas.microsoft.com/office/drawing/2018/hyperlinkcolor">
+  <p:cSld>
+    <p:spTree>
+      <p:nvGrpSpPr>
+        <p:cNvPr id="147" name="Shape 147"/>
+        <p:cNvGrpSpPr/>
+        <p:nvPr/>
+      </p:nvGrpSpPr>
+      <p:grpSpPr>
+        <a:xfrm>
+          <a:off x="0" y="0"/>
+          <a:ext cx="0" cy="0"/>
+          <a:chOff x="0" y="0"/>
+          <a:chExt cx="0" cy="0"/>
+        </a:xfrm>
+      </p:grpSpPr>
+      <p:pic>
+        <p:nvPicPr>
+          <p:cNvPr id="148" name="Google Shape;148;p25" title="Frame 144.png"/>
+          <p:cNvPicPr preferRelativeResize="0"/>
+          <p:nvPr/>
+        </p:nvPicPr>
+        <p:blipFill rotWithShape="1">
+          <a:blip r:embed="rId3">
+            <a:alphaModFix/>
+          </a:blip>
+          <a:srcRect b="98001" l="0" r="0" t="0"/>
+          <a:stretch/>
+        </p:blipFill>
+        <p:spPr>
+          <a:xfrm>
+            <a:off x="0" y="5093562"/>
+            <a:ext cx="9144000" cy="54275"/>
+          </a:xfrm>
+          <a:prstGeom prst="rect">
+            <a:avLst/>
+          </a:prstGeom>
+          <a:noFill/>
+          <a:ln>
+            <a:noFill/>
+          </a:ln>
+        </p:spPr>
+      </p:pic>
+      <p:pic>
+        <p:nvPicPr>
+          <p:cNvPr id="149" name="Google Shape;149;p25" title="Group 427319979.png"/>
+          <p:cNvPicPr preferRelativeResize="0"/>
+          <p:nvPr/>
+        </p:nvPicPr>
+        <p:blipFill>
+          <a:blip r:embed="rId4">
+            <a:alphaModFix/>
+          </a:blip>
+          <a:stretch>
+            <a:fillRect/>
+          </a:stretch>
+        </p:blipFill>
+        <p:spPr>
+          <a:xfrm>
+            <a:off x="0" y="1"/>
+            <a:ext cx="9144000" cy="507359"/>
+          </a:xfrm>
+          <a:prstGeom prst="rect">
+            <a:avLst/>
+          </a:prstGeom>
+          <a:noFill/>
+          <a:ln>
+            <a:noFill/>
+          </a:ln>
+        </p:spPr>
+      </p:pic>
+      <p:sp>
+        <p:nvSpPr>
+          <p:cNvPr id="150" name="Google Shape;150;p25"/>
+          <p:cNvSpPr/>
+          <p:nvPr/>
+        </p:nvSpPr>
+        <p:spPr>
+          <a:xfrm>
+            <a:off x="-29250" y="5071875"/>
+            <a:ext cx="9173400" cy="97800"/>
+          </a:xfrm>
+          <a:prstGeom prst="rect">
+            <a:avLst/>
+          </a:prstGeom>
+          <a:solidFill>
+            <a:schemeClr val="dk1"/>
+          </a:solidFill>
+          <a:ln>
+            <a:noFill/>
+          </a:ln>
+        </p:spPr>
+        <p:txBody>
+          <a:bodyPr anchorCtr="0" anchor="ctr" bIns="91425" lIns="91425" spcFirstLastPara="1" rIns="91425" wrap="square" tIns="91425">
+            <a:noAutofit/>
+          </a:bodyPr>
+          <a:lstStyle/>
+          <a:p>
+            <a:pPr indent="0" lvl="0" marL="0" rtl="0" algn="ctr">
+              <a:spcBef>
+                <a:spcPts val="0"/>
+              </a:spcBef>
+              <a:spcAft>
+                <a:spcPts val="0"/>
+              </a:spcAft>
+              <a:buNone/>
+            </a:pPr>
+            <a:r>
+              <a:t/>
+            </a:r>
+            <a:endParaRPr/>
+          </a:p>
+        </p:txBody>
+      </p:sp>
+      <p:sp>
+        <p:nvSpPr>
+          <p:cNvPr id="151" name="Google Shape;151;p25"/>
+          <p:cNvSpPr txBox="1"/>
+          <p:nvPr/>
+        </p:nvSpPr>
+        <p:spPr>
+          <a:xfrm>
+            <a:off x="265350" y="663825"/>
+            <a:ext cx="8943000" cy="502920"/>
+          </a:xfrm>
+          <a:prstGeom prst="rect">
+            <a:avLst/>
+          </a:prstGeom>
+          <a:noFill/>
+          <a:ln>
+            <a:noFill/>
+          </a:ln>
+        </p:spPr>
+        <p:txBody>
+          <a:bodyPr anchorCtr="0" anchor="t" bIns="91425" lIns="91425" spcFirstLastPara="1" rIns="91425" wrap="square" tIns="91425">
+            <a:noAutofit/>
+          </a:bodyPr>
+          <a:lstStyle/>
+          <a:p>
+            <a:pPr indent="0" lvl="0" marL="0" rtl="0" algn="l">
+              <a:spcBef>
+                <a:spcPts val="0"/>
+              </a:spcBef>
+              <a:spcAft>
+                <a:spcPts val="0"/>
+              </a:spcAft>
+              <a:buNone/>
+            </a:pPr>
+            <a:r>
+              <a:rPr lang="en-GB" sz="1600">
+                <a:latin typeface="Google Sans Flex Medium"/>
+                <a:ea typeface="Google Sans Flex Medium"/>
+                <a:cs typeface="Google Sans Flex Medium"/>
+                <a:sym typeface="Google Sans Flex Medium"/>
+              </a:rPr>
+              <a:t>Appendix: the onboarding team, four agents that learn your plant</a:t>
+            </a:r>
+            <a:endParaRPr sz="1600">
+              <a:latin typeface="Google Sans Flex Medium"/>
+              <a:ea typeface="Google Sans Flex Medium"/>
+              <a:cs typeface="Google Sans Flex Medium"/>
+              <a:sym typeface="Google Sans Flex Medium"/>
+            </a:endParaRPr>
+          </a:p>
+        </p:txBody>
+      </p:sp>
+      <p:sp>
+        <p:nvSpPr>
+          <p:cNvPr id="152" name="agent card"/>
+          <p:cNvSpPr/>
+          <p:nvPr/>
+        </p:nvSpPr>
+        <p:spPr>
+          <a:xfrm>
+            <a:off x="274320" y="1097280"/>
+            <a:ext cx="4251960" cy="2240280"/>
+          </a:xfrm>
+          <a:prstGeom prst="roundRect">
+            <a:avLst>
+              <a:gd name="adj" fmla="val 6000"/>
+            </a:avLst>
+          </a:prstGeom>
+          <a:solidFill>
+            <a:srgbClr val="F1F3F4"/>
+          </a:solidFill>
+          <a:ln>
+            <a:noFill/>
+          </a:ln>
+          <a:effectLst/>
+        </p:spPr>
+        <p:style>
+          <a:lnRef idx="1">
+            <a:schemeClr val="accent1"/>
+          </a:lnRef>
+          <a:fillRef idx="3">
+            <a:schemeClr val="accent1"/>
+          </a:fillRef>
+          <a:effectRef idx="2">
+            <a:schemeClr val="accent1"/>
+          </a:effectRef>
+          <a:fontRef idx="minor">
+            <a:schemeClr val="lt1"/>
+          </a:fontRef>
+        </p:style>
+        <p:txBody>
+          <a:bodyPr rtlCol="0" anchor="ctr"/>
+          <a:lstStyle/>
+          <a:p>
+            <a:pPr algn="ctr"/>
+          </a:p>
+        </p:txBody>
+      </p:sp>
+      <p:sp>
+        <p:nvSpPr>
+          <p:cNvPr id="153" name="agent name"/>
+          <p:cNvSpPr txBox="1"/>
+          <p:nvPr/>
+        </p:nvSpPr>
+        <p:spPr>
+          <a:xfrm>
+            <a:off x="365760" y="1143000"/>
+            <a:ext cx="2514600" cy="292608"/>
+          </a:xfrm>
+          <a:prstGeom prst="rect">
+            <a:avLst/>
+          </a:prstGeom>
+          <a:noFill/>
+        </p:spPr>
+        <p:txBody>
+          <a:bodyPr wrap="square" anchor="t" lIns="36576" rIns="36576" tIns="18288" bIns="18288">
+            <a:spAutoFit/>
+          </a:bodyPr>
+          <a:lstStyle/>
+          <a:p>
+            <a:pPr algn="l">
+              <a:spcAft>
+                <a:spcPts val="400"/>
+              </a:spcAft>
+            </a:pPr>
+            <a:r>
+              <a:rPr sz="1300" b="1">
+                <a:solidFill>
+                  <a:srgbClr val="1A73E8"/>
+                </a:solidFill>
+                <a:latin typeface="Google Sans Flex SemiBold"/>
+              </a:rPr>
+              <a:t>Guide</a:t>
+            </a:r>
+          </a:p>
+        </p:txBody>
+      </p:sp>
+      <p:sp>
+        <p:nvSpPr>
+          <p:cNvPr id="154" name="agent mode"/>
+          <p:cNvSpPr txBox="1"/>
+          <p:nvPr/>
+        </p:nvSpPr>
+        <p:spPr>
+          <a:xfrm>
+            <a:off x="2834640" y="1170432"/>
+            <a:ext cx="1600200" cy="237744"/>
+          </a:xfrm>
+          <a:prstGeom prst="rect">
+            <a:avLst/>
+          </a:prstGeom>
+          <a:noFill/>
+        </p:spPr>
+        <p:txBody>
+          <a:bodyPr wrap="square" anchor="t" lIns="36576" rIns="36576" tIns="18288" bIns="18288">
+            <a:spAutoFit/>
+          </a:bodyPr>
+          <a:lstStyle/>
+          <a:p>
+            <a:pPr algn="r">
+              <a:spcAft>
+                <a:spcPts val="400"/>
+              </a:spcAft>
+            </a:pPr>
+            <a:r>
+              <a:rPr sz="850" b="0">
+                <a:solidFill>
+                  <a:srgbClr val="5F6368"/>
+                </a:solidFill>
+                <a:latin typeface="Google Sans Flex"/>
+              </a:rPr>
+              <a:t>Model and rules · Gemini</a:t>
+            </a:r>
+          </a:p>
+        </p:txBody>
+      </p:sp>
+      <p:sp>
+        <p:nvSpPr>
+          <p:cNvPr id="155" name="agent text"/>
+          <p:cNvSpPr txBox="1"/>
+          <p:nvPr/>
+        </p:nvSpPr>
+        <p:spPr>
+          <a:xfrm>
+            <a:off x="365760" y="1463040"/>
+            <a:ext cx="4069080" cy="1828800"/>
+          </a:xfrm>
+          <a:prstGeom prst="rect">
+            <a:avLst/>
+          </a:prstGeom>
+          <a:noFill/>
+        </p:spPr>
+        <p:txBody>
+          <a:bodyPr wrap="square" anchor="t" lIns="36576" rIns="36576" tIns="18288" bIns="18288">
+            <a:spAutoFit/>
+          </a:bodyPr>
+          <a:lstStyle/>
+          <a:p>
+            <a:pPr algn="l">
+              <a:spcAft>
+                <a:spcPts val="300"/>
+              </a:spcAft>
+            </a:pPr>
+            <a:r>
+              <a:rPr sz="900" b="1">
+                <a:solidFill>
+                  <a:srgbClr val="1A73E8"/>
+                </a:solidFill>
+                <a:latin typeface="Google Sans Flex SemiBold"/>
+              </a:rPr>
+              <a:t>Use case: </a:t>
+            </a:r>
+            <a:r>
+              <a:rPr sz="900" b="0">
+                <a:solidFill>
+                  <a:srgbClr val="202124"/>
+                </a:solidFill>
+                <a:latin typeface="Google Sans Flex"/>
+              </a:rPr>
+              <a:t>A plant's documents disagree and have gaps. Only the owner can settle them.</a:t>
+            </a:r>
+          </a:p>
+          <a:p>
+            <a:pPr algn="l">
+              <a:spcAft>
+                <a:spcPts val="300"/>
+              </a:spcAft>
+            </a:pPr>
+            <a:r>
+              <a:rPr sz="900" b="1">
+                <a:solidFill>
+                  <a:srgbClr val="B06000"/>
+                </a:solidFill>
+                <a:latin typeface="Google Sans Flex SemiBold"/>
+              </a:rPr>
+              <a:t>Solution: </a:t>
+            </a:r>
+            <a:r>
+              <a:rPr sz="900" b="0">
+                <a:solidFill>
+                  <a:srgbClr val="202124"/>
+                </a:solidFill>
+                <a:latin typeface="Google Sans Flex"/>
+              </a:rPr>
+              <a:t>Runs the Document Reader, Connector Scout and Plant Modeler, then asks the owner one question at a time. Gemini writes the words and reads free-text answers. Code checks each answer before it changes anything.</a:t>
+            </a:r>
+          </a:p>
+          <a:p>
+            <a:pPr algn="l">
+              <a:spcAft>
+                <a:spcPts val="300"/>
+              </a:spcAft>
+            </a:pPr>
+            <a:r>
+              <a:rPr sz="900" b="1">
+                <a:solidFill>
+                  <a:srgbClr val="188038"/>
+                </a:solidFill>
+                <a:latin typeface="Google Sans Flex SemiBold"/>
+              </a:rPr>
+              <a:t>Outcomes: </a:t>
+            </a:r>
+            <a:r>
+              <a:rPr sz="900" b="0">
+                <a:solidFill>
+                  <a:srgbClr val="202124"/>
+                </a:solidFill>
+                <a:latin typeface="Google Sans Flex"/>
+              </a:rPr>
+              <a:t>Settled conflicts · Confirmed limits · What the plant makes · A confirmed overview · A drawn layout · A tour of the app</a:t>
+            </a:r>
+          </a:p>
+          <a:p>
+            <a:pPr algn="l">
+              <a:spcAft>
+                <a:spcPts val="400"/>
+              </a:spcAft>
+            </a:pPr>
+            <a:r>
+              <a:rPr sz="900" b="1">
+                <a:solidFill>
+                  <a:srgbClr val="C5221F"/>
+                </a:solidFill>
+                <a:latin typeface="Google Sans Flex SemiBold"/>
+              </a:rPr>
+              <a:t>Must never: </a:t>
+            </a:r>
+            <a:r>
+              <a:rPr sz="900" b="0">
+                <a:solidFill>
+                  <a:srgbClr val="5F6368"/>
+                </a:solidFill>
+                <a:latin typeface="Google Sans Flex"/>
+              </a:rPr>
+              <a:t>Apply an answer that does not match an open question; Write to the plant; Obey instructions found inside documents</a:t>
+            </a:r>
+          </a:p>
+        </p:txBody>
+      </p:sp>
+      <p:sp>
+        <p:nvSpPr>
+          <p:cNvPr id="156" name="agent card"/>
+          <p:cNvSpPr/>
+          <p:nvPr/>
+        </p:nvSpPr>
+        <p:spPr>
+          <a:xfrm>
+            <a:off x="4617720" y="1097280"/>
+            <a:ext cx="4251960" cy="2240280"/>
+          </a:xfrm>
+          <a:prstGeom prst="roundRect">
+            <a:avLst>
+              <a:gd name="adj" fmla="val 6000"/>
+            </a:avLst>
+          </a:prstGeom>
+          <a:solidFill>
+            <a:srgbClr val="F1F3F4"/>
+          </a:solidFill>
+          <a:ln>
+            <a:noFill/>
+          </a:ln>
+          <a:effectLst/>
+        </p:spPr>
+        <p:style>
+          <a:lnRef idx="1">
+            <a:schemeClr val="accent1"/>
+          </a:lnRef>
+          <a:fillRef idx="3">
+            <a:schemeClr val="accent1"/>
+          </a:fillRef>
+          <a:effectRef idx="2">
+            <a:schemeClr val="accent1"/>
+          </a:effectRef>
+          <a:fontRef idx="minor">
+            <a:schemeClr val="lt1"/>
+          </a:fontRef>
+        </p:style>
+        <p:txBody>
+          <a:bodyPr rtlCol="0" anchor="ctr"/>
+          <a:lstStyle/>
+          <a:p>
+            <a:pPr algn="ctr"/>
+          </a:p>
+        </p:txBody>
+      </p:sp>
+      <p:sp>
+        <p:nvSpPr>
+          <p:cNvPr id="157" name="agent name"/>
+          <p:cNvSpPr txBox="1"/>
+          <p:nvPr/>
+        </p:nvSpPr>
+        <p:spPr>
+          <a:xfrm>
+            <a:off x="4709159" y="1143000"/>
+            <a:ext cx="2514600" cy="292608"/>
+          </a:xfrm>
+          <a:prstGeom prst="rect">
+            <a:avLst/>
+          </a:prstGeom>
+          <a:noFill/>
+        </p:spPr>
+        <p:txBody>
+          <a:bodyPr wrap="square" anchor="t" lIns="36576" rIns="36576" tIns="18288" bIns="18288">
+            <a:spAutoFit/>
+          </a:bodyPr>
+          <a:lstStyle/>
+          <a:p>
+            <a:pPr algn="l">
+              <a:spcAft>
+                <a:spcPts val="400"/>
+              </a:spcAft>
+            </a:pPr>
+            <a:r>
+              <a:rPr sz="1300" b="1">
+                <a:solidFill>
+                  <a:srgbClr val="1A73E8"/>
+                </a:solidFill>
+                <a:latin typeface="Google Sans Flex SemiBold"/>
+              </a:rPr>
+              <a:t>Document Reader</a:t>
+            </a:r>
+          </a:p>
+        </p:txBody>
+      </p:sp>
+      <p:sp>
+        <p:nvSpPr>
+          <p:cNvPr id="158" name="agent mode"/>
+          <p:cNvSpPr txBox="1"/>
+          <p:nvPr/>
+        </p:nvSpPr>
+        <p:spPr>
+          <a:xfrm>
+            <a:off x="7178040" y="1170432"/>
+            <a:ext cx="1600200" cy="237744"/>
+          </a:xfrm>
+          <a:prstGeom prst="rect">
+            <a:avLst/>
+          </a:prstGeom>
+          <a:noFill/>
+        </p:spPr>
+        <p:txBody>
+          <a:bodyPr wrap="square" anchor="t" lIns="36576" rIns="36576" tIns="18288" bIns="18288">
+            <a:spAutoFit/>
+          </a:bodyPr>
+          <a:lstStyle/>
+          <a:p>
+            <a:pPr algn="r">
+              <a:spcAft>
+                <a:spcPts val="400"/>
+              </a:spcAft>
+            </a:pPr>
+            <a:r>
+              <a:rPr sz="850" b="0">
+                <a:solidFill>
+                  <a:srgbClr val="5F6368"/>
+                </a:solidFill>
+                <a:latin typeface="Google Sans Flex"/>
+              </a:rPr>
+              <a:t>Model and rules · Gemini</a:t>
+            </a:r>
+          </a:p>
+        </p:txBody>
+      </p:sp>
+      <p:sp>
+        <p:nvSpPr>
+          <p:cNvPr id="159" name="agent text"/>
+          <p:cNvSpPr txBox="1"/>
+          <p:nvPr/>
+        </p:nvSpPr>
+        <p:spPr>
+          <a:xfrm>
+            <a:off x="4709159" y="1463040"/>
+            <a:ext cx="4069080" cy="1828800"/>
+          </a:xfrm>
+          <a:prstGeom prst="rect">
+            <a:avLst/>
+          </a:prstGeom>
+          <a:noFill/>
+        </p:spPr>
+        <p:txBody>
+          <a:bodyPr wrap="square" anchor="t" lIns="36576" rIns="36576" tIns="18288" bIns="18288">
+            <a:spAutoFit/>
+          </a:bodyPr>
+          <a:lstStyle/>
+          <a:p>
+            <a:pPr algn="l">
+              <a:spcAft>
+                <a:spcPts val="300"/>
+              </a:spcAft>
+            </a:pPr>
+            <a:r>
+              <a:rPr sz="900" b="1">
+                <a:solidFill>
+                  <a:srgbClr val="1A73E8"/>
+                </a:solidFill>
+                <a:latin typeface="Google Sans Flex SemiBold"/>
+              </a:rPr>
+              <a:t>Use case: </a:t>
+            </a:r>
+            <a:r>
+              <a:rPr sz="900" b="0">
+                <a:solidFill>
+                  <a:srgbClr val="202124"/>
+                </a:solidFill>
+                <a:latin typeface="Google Sans Flex"/>
+              </a:rPr>
+              <a:t>Manuals, work instructions and safety sheets hold the limits and the structure of the plant.</a:t>
+            </a:r>
+          </a:p>
+          <a:p>
+            <a:pPr algn="l">
+              <a:spcAft>
+                <a:spcPts val="300"/>
+              </a:spcAft>
+            </a:pPr>
+            <a:r>
+              <a:rPr sz="900" b="1">
+                <a:solidFill>
+                  <a:srgbClr val="B06000"/>
+                </a:solidFill>
+                <a:latin typeface="Google Sans Flex SemiBold"/>
+              </a:rPr>
+              <a:t>Solution: </a:t>
+            </a:r>
+            <a:r>
+              <a:rPr sz="900" b="0">
+                <a:solidFill>
+                  <a:srgbClr val="202124"/>
+                </a:solidFill>
+                <a:latin typeface="Google Sans Flex"/>
+              </a:rPr>
+              <a:t>Gemini extracts claims; code checks every quote against the page; instructions hidden in documents are removed first.</a:t>
+            </a:r>
+          </a:p>
+          <a:p>
+            <a:pPr algn="l">
+              <a:spcAft>
+                <a:spcPts val="300"/>
+              </a:spcAft>
+            </a:pPr>
+            <a:r>
+              <a:rPr sz="900" b="1">
+                <a:solidFill>
+                  <a:srgbClr val="188038"/>
+                </a:solidFill>
+                <a:latin typeface="Google Sans Flex SemiBold"/>
+              </a:rPr>
+              <a:t>Outcomes: </a:t>
+            </a:r>
+            <a:r>
+              <a:rPr sz="900" b="0">
+                <a:solidFill>
+                  <a:srgbClr val="202124"/>
+                </a:solidFill>
+                <a:latin typeface="Google Sans Flex"/>
+              </a:rPr>
+              <a:t>Claims with quotes · Conflicts between documents · Missing facts · Hidden instructions flagged</a:t>
+            </a:r>
+          </a:p>
+          <a:p>
+            <a:pPr algn="l">
+              <a:spcAft>
+                <a:spcPts val="400"/>
+              </a:spcAft>
+            </a:pPr>
+            <a:r>
+              <a:rPr sz="900" b="1">
+                <a:solidFill>
+                  <a:srgbClr val="C5221F"/>
+                </a:solidFill>
+                <a:latin typeface="Google Sans Flex SemiBold"/>
+              </a:rPr>
+              <a:t>Must never: </a:t>
+            </a:r>
+            <a:r>
+              <a:rPr sz="900" b="0">
+                <a:solidFill>
+                  <a:srgbClr val="5F6368"/>
+                </a:solidFill>
+                <a:latin typeface="Google Sans Flex"/>
+              </a:rPr>
+              <a:t>Obey instructions found inside documents; Write to the plant</a:t>
+            </a:r>
+          </a:p>
+        </p:txBody>
+      </p:sp>
+      <p:sp>
+        <p:nvSpPr>
+          <p:cNvPr id="160" name="agent card"/>
+          <p:cNvSpPr/>
+          <p:nvPr/>
+        </p:nvSpPr>
+        <p:spPr>
+          <a:xfrm>
+            <a:off x="274320" y="3410712"/>
+            <a:ext cx="4251960" cy="1554480"/>
+          </a:xfrm>
+          <a:prstGeom prst="roundRect">
+            <a:avLst>
+              <a:gd name="adj" fmla="val 6000"/>
+            </a:avLst>
+          </a:prstGeom>
+          <a:solidFill>
+            <a:srgbClr val="F1F3F4"/>
+          </a:solidFill>
+          <a:ln>
+            <a:noFill/>
+          </a:ln>
+          <a:effectLst/>
+        </p:spPr>
+        <p:style>
+          <a:lnRef idx="1">
+            <a:schemeClr val="accent1"/>
+          </a:lnRef>
+          <a:fillRef idx="3">
+            <a:schemeClr val="accent1"/>
+          </a:fillRef>
+          <a:effectRef idx="2">
+            <a:schemeClr val="accent1"/>
+          </a:effectRef>
+          <a:fontRef idx="minor">
+            <a:schemeClr val="lt1"/>
+          </a:fontRef>
+        </p:style>
+        <p:txBody>
+          <a:bodyPr rtlCol="0" anchor="ctr"/>
+          <a:lstStyle/>
+          <a:p>
+            <a:pPr algn="ctr"/>
+          </a:p>
+        </p:txBody>
+      </p:sp>
+      <p:sp>
+        <p:nvSpPr>
+          <p:cNvPr id="161" name="agent name"/>
+          <p:cNvSpPr txBox="1"/>
+          <p:nvPr/>
+        </p:nvSpPr>
+        <p:spPr>
+          <a:xfrm>
+            <a:off x="365760" y="3456432"/>
+            <a:ext cx="2514600" cy="292608"/>
+          </a:xfrm>
+          <a:prstGeom prst="rect">
+            <a:avLst/>
+          </a:prstGeom>
+          <a:noFill/>
+        </p:spPr>
+        <p:txBody>
+          <a:bodyPr wrap="square" anchor="t" lIns="36576" rIns="36576" tIns="18288" bIns="18288">
+            <a:spAutoFit/>
+          </a:bodyPr>
+          <a:lstStyle/>
+          <a:p>
+            <a:pPr algn="l">
+              <a:spcAft>
+                <a:spcPts val="400"/>
+              </a:spcAft>
+            </a:pPr>
+            <a:r>
+              <a:rPr sz="1300" b="1">
+                <a:solidFill>
+                  <a:srgbClr val="1A73E8"/>
+                </a:solidFill>
+                <a:latin typeface="Google Sans Flex SemiBold"/>
+              </a:rPr>
+              <a:t>Connector Scout</a:t>
+            </a:r>
+          </a:p>
+        </p:txBody>
+      </p:sp>
+      <p:sp>
+        <p:nvSpPr>
+          <p:cNvPr id="162" name="agent mode"/>
+          <p:cNvSpPr txBox="1"/>
+          <p:nvPr/>
+        </p:nvSpPr>
+        <p:spPr>
+          <a:xfrm>
+            <a:off x="2834640" y="3483864"/>
+            <a:ext cx="1600200" cy="237744"/>
+          </a:xfrm>
+          <a:prstGeom prst="rect">
+            <a:avLst/>
+          </a:prstGeom>
+          <a:noFill/>
+        </p:spPr>
+        <p:txBody>
+          <a:bodyPr wrap="square" anchor="t" lIns="36576" rIns="36576" tIns="18288" bIns="18288">
+            <a:spAutoFit/>
+          </a:bodyPr>
+          <a:lstStyle/>
+          <a:p>
+            <a:pPr algn="r">
+              <a:spcAft>
+                <a:spcPts val="400"/>
+              </a:spcAft>
+            </a:pPr>
+            <a:r>
+              <a:rPr sz="850" b="0">
+                <a:solidFill>
+                  <a:srgbClr val="5F6368"/>
+                </a:solidFill>
+                <a:latin typeface="Google Sans Flex"/>
+              </a:rPr>
+              <a:t>Model-driven · Gemini</a:t>
+            </a:r>
+          </a:p>
+        </p:txBody>
+      </p:sp>
+      <p:sp>
+        <p:nvSpPr>
+          <p:cNvPr id="163" name="agent text"/>
+          <p:cNvSpPr txBox="1"/>
+          <p:nvPr/>
+        </p:nvSpPr>
+        <p:spPr>
+          <a:xfrm>
+            <a:off x="365760" y="3776472"/>
+            <a:ext cx="4069080" cy="1143000"/>
+          </a:xfrm>
+          <a:prstGeom prst="rect">
+            <a:avLst/>
+          </a:prstGeom>
+          <a:noFill/>
+        </p:spPr>
+        <p:txBody>
+          <a:bodyPr wrap="square" anchor="t" lIns="36576" rIns="36576" tIns="18288" bIns="18288">
+            <a:spAutoFit/>
+          </a:bodyPr>
+          <a:lstStyle/>
+          <a:p>
+            <a:pPr algn="l">
+              <a:spcAft>
+                <a:spcPts val="300"/>
+              </a:spcAft>
+            </a:pPr>
+            <a:r>
+              <a:rPr sz="900" b="1">
+                <a:solidFill>
+                  <a:srgbClr val="1A73E8"/>
+                </a:solidFill>
+                <a:latin typeface="Google Sans Flex SemiBold"/>
+              </a:rPr>
+              <a:t>Use case: </a:t>
+            </a:r>
+            <a:r>
+              <a:rPr sz="900" b="0">
+                <a:solidFill>
+                  <a:srgbClr val="202124"/>
+                </a:solidFill>
+                <a:latin typeface="Google Sans Flex"/>
+              </a:rPr>
+              <a:t>A plant has ERP, MES, PLC and file data. Someone must say which is which.</a:t>
+            </a:r>
+          </a:p>
+          <a:p>
+            <a:pPr algn="l">
+              <a:spcAft>
+                <a:spcPts val="300"/>
+              </a:spcAft>
+            </a:pPr>
+            <a:r>
+              <a:rPr sz="900" b="1">
+                <a:solidFill>
+                  <a:srgbClr val="B06000"/>
+                </a:solidFill>
+                <a:latin typeface="Google Sans Flex SemiBold"/>
+              </a:rPr>
+              <a:t>Solution: </a:t>
+            </a:r>
+            <a:r>
+              <a:rPr sz="900" b="0">
+                <a:solidFill>
+                  <a:srgbClr val="202124"/>
+                </a:solidFill>
+                <a:latin typeface="Google Sans Flex"/>
+              </a:rPr>
+              <a:t>MCP servers list sources and tables. Gemini names the role of each table from its columns.</a:t>
+            </a:r>
+          </a:p>
+          <a:p>
+            <a:pPr algn="l">
+              <a:spcAft>
+                <a:spcPts val="300"/>
+              </a:spcAft>
+            </a:pPr>
+            <a:r>
+              <a:rPr sz="900" b="1">
+                <a:solidFill>
+                  <a:srgbClr val="188038"/>
+                </a:solidFill>
+                <a:latin typeface="Google Sans Flex SemiBold"/>
+              </a:rPr>
+              <a:t>Outcomes: </a:t>
+            </a:r>
+            <a:r>
+              <a:rPr sz="900" b="0">
+                <a:solidFill>
+                  <a:srgbClr val="202124"/>
+                </a:solidFill>
+                <a:latin typeface="Google Sans Flex"/>
+              </a:rPr>
+              <a:t>Role of each table · Which sources are live · What data is missing</a:t>
+            </a:r>
+          </a:p>
+          <a:p>
+            <a:pPr algn="l">
+              <a:spcAft>
+                <a:spcPts val="400"/>
+              </a:spcAft>
+            </a:pPr>
+            <a:r>
+              <a:rPr sz="900" b="1">
+                <a:solidFill>
+                  <a:srgbClr val="C5221F"/>
+                </a:solidFill>
+                <a:latin typeface="Google Sans Flex SemiBold"/>
+              </a:rPr>
+              <a:t>Must never: </a:t>
+            </a:r>
+            <a:r>
+              <a:rPr sz="900" b="0">
+                <a:solidFill>
+                  <a:srgbClr val="5F6368"/>
+                </a:solidFill>
+                <a:latin typeface="Google Sans Flex"/>
+              </a:rPr>
+              <a:t>Write to the plant; Read rows outside SELECT</a:t>
+            </a:r>
+          </a:p>
+        </p:txBody>
+      </p:sp>
+      <p:sp>
+        <p:nvSpPr>
+          <p:cNvPr id="164" name="agent card"/>
+          <p:cNvSpPr/>
+          <p:nvPr/>
+        </p:nvSpPr>
+        <p:spPr>
+          <a:xfrm>
+            <a:off x="4617720" y="3410712"/>
+            <a:ext cx="4251960" cy="1554480"/>
+          </a:xfrm>
+          <a:prstGeom prst="roundRect">
+            <a:avLst>
+              <a:gd name="adj" fmla="val 6000"/>
+            </a:avLst>
+          </a:prstGeom>
+          <a:solidFill>
+            <a:srgbClr val="F1F3F4"/>
+          </a:solidFill>
+          <a:ln>
+            <a:noFill/>
+          </a:ln>
+          <a:effectLst/>
+        </p:spPr>
+        <p:style>
+          <a:lnRef idx="1">
+            <a:schemeClr val="accent1"/>
+          </a:lnRef>
+          <a:fillRef idx="3">
+            <a:schemeClr val="accent1"/>
+          </a:fillRef>
+          <a:effectRef idx="2">
+            <a:schemeClr val="accent1"/>
+          </a:effectRef>
+          <a:fontRef idx="minor">
+            <a:schemeClr val="lt1"/>
+          </a:fontRef>
+        </p:style>
+        <p:txBody>
+          <a:bodyPr rtlCol="0" anchor="ctr"/>
+          <a:lstStyle/>
+          <a:p>
+            <a:pPr algn="ctr"/>
+          </a:p>
+        </p:txBody>
+      </p:sp>
+      <p:sp>
+        <p:nvSpPr>
+          <p:cNvPr id="165" name="agent name"/>
+          <p:cNvSpPr txBox="1"/>
+          <p:nvPr/>
+        </p:nvSpPr>
+        <p:spPr>
+          <a:xfrm>
+            <a:off x="4709159" y="3456432"/>
+            <a:ext cx="2514600" cy="292608"/>
+          </a:xfrm>
+          <a:prstGeom prst="rect">
+            <a:avLst/>
+          </a:prstGeom>
+          <a:noFill/>
+        </p:spPr>
+        <p:txBody>
+          <a:bodyPr wrap="square" anchor="t" lIns="36576" rIns="36576" tIns="18288" bIns="18288">
+            <a:spAutoFit/>
+          </a:bodyPr>
+          <a:lstStyle/>
+          <a:p>
+            <a:pPr algn="l">
+              <a:spcAft>
+                <a:spcPts val="400"/>
+              </a:spcAft>
+            </a:pPr>
+            <a:r>
+              <a:rPr sz="1300" b="1">
+                <a:solidFill>
+                  <a:srgbClr val="1A73E8"/>
+                </a:solidFill>
+                <a:latin typeface="Google Sans Flex SemiBold"/>
+              </a:rPr>
+              <a:t>Plant Modeler</a:t>
+            </a:r>
+          </a:p>
+        </p:txBody>
+      </p:sp>
+      <p:sp>
+        <p:nvSpPr>
+          <p:cNvPr id="166" name="agent mode"/>
+          <p:cNvSpPr txBox="1"/>
+          <p:nvPr/>
+        </p:nvSpPr>
+        <p:spPr>
+          <a:xfrm>
+            <a:off x="7178040" y="3483864"/>
+            <a:ext cx="1600200" cy="237744"/>
+          </a:xfrm>
+          <a:prstGeom prst="rect">
+            <a:avLst/>
+          </a:prstGeom>
+          <a:noFill/>
+        </p:spPr>
+        <p:txBody>
+          <a:bodyPr wrap="square" anchor="t" lIns="36576" rIns="36576" tIns="18288" bIns="18288">
+            <a:spAutoFit/>
+          </a:bodyPr>
+          <a:lstStyle/>
+          <a:p>
+            <a:pPr algn="r">
+              <a:spcAft>
+                <a:spcPts val="400"/>
+              </a:spcAft>
+            </a:pPr>
+            <a:r>
+              <a:rPr sz="850" b="0">
+                <a:solidFill>
+                  <a:srgbClr val="5F6368"/>
+                </a:solidFill>
+                <a:latin typeface="Google Sans Flex"/>
+              </a:rPr>
+              <a:t>Model and rules · Gemini</a:t>
+            </a:r>
+          </a:p>
+        </p:txBody>
+      </p:sp>
+      <p:sp>
+        <p:nvSpPr>
+          <p:cNvPr id="167" name="agent text"/>
+          <p:cNvSpPr txBox="1"/>
+          <p:nvPr/>
+        </p:nvSpPr>
+        <p:spPr>
+          <a:xfrm>
+            <a:off x="4709159" y="3776472"/>
+            <a:ext cx="4069080" cy="1143000"/>
+          </a:xfrm>
+          <a:prstGeom prst="rect">
+            <a:avLst/>
+          </a:prstGeom>
+          <a:noFill/>
+        </p:spPr>
+        <p:txBody>
+          <a:bodyPr wrap="square" anchor="t" lIns="36576" rIns="36576" tIns="18288" bIns="18288">
+            <a:spAutoFit/>
+          </a:bodyPr>
+          <a:lstStyle/>
+          <a:p>
+            <a:pPr algn="l">
+              <a:spcAft>
+                <a:spcPts val="300"/>
+              </a:spcAft>
+            </a:pPr>
+            <a:r>
+              <a:rPr sz="900" b="1">
+                <a:solidFill>
+                  <a:srgbClr val="1A73E8"/>
+                </a:solidFill>
+                <a:latin typeface="Google Sans Flex SemiBold"/>
+              </a:rPr>
+              <a:t>Use case: </a:t>
+            </a:r>
+            <a:r>
+              <a:rPr sz="900" b="0">
+                <a:solidFill>
+                  <a:srgbClr val="202124"/>
+                </a:solidFill>
+                <a:latin typeface="Google Sans Flex"/>
+              </a:rPr>
+              <a:t>The 3D model must come from facts a person has checked.</a:t>
+            </a:r>
+          </a:p>
+          <a:p>
+            <a:pPr algn="l">
+              <a:spcAft>
+                <a:spcPts val="300"/>
+              </a:spcAft>
+            </a:pPr>
+            <a:r>
+              <a:rPr sz="900" b="1">
+                <a:solidFill>
+                  <a:srgbClr val="B06000"/>
+                </a:solidFill>
+                <a:latin typeface="Google Sans Flex SemiBold"/>
+              </a:rPr>
+              <a:t>Solution: </a:t>
+            </a:r>
+            <a:r>
+              <a:rPr sz="900" b="0">
+                <a:solidFill>
+                  <a:srgbClr val="202124"/>
+                </a:solidFill>
+                <a:latin typeface="Google Sans Flex"/>
+              </a:rPr>
+              <a:t>Stations from data, material flow from the documents, limits from the documents. Gemini writes the overview and each sentence cites its source.</a:t>
+            </a:r>
+          </a:p>
+          <a:p>
+            <a:pPr algn="l">
+              <a:spcAft>
+                <a:spcPts val="300"/>
+              </a:spcAft>
+            </a:pPr>
+            <a:r>
+              <a:rPr sz="900" b="1">
+                <a:solidFill>
+                  <a:srgbClr val="188038"/>
+                </a:solidFill>
+                <a:latin typeface="Google Sans Flex SemiBold"/>
+              </a:rPr>
+              <a:t>Outcomes: </a:t>
+            </a:r>
+            <a:r>
+              <a:rPr sz="900" b="0">
+                <a:solidFill>
+                  <a:srgbClr val="202124"/>
+                </a:solidFill>
+                <a:latin typeface="Google Sans Flex"/>
+              </a:rPr>
+              <a:t>Written overview · 2D plan · Limits list · Confirmation gate</a:t>
+            </a:r>
+          </a:p>
+          <a:p>
+            <a:pPr algn="l">
+              <a:spcAft>
+                <a:spcPts val="400"/>
+              </a:spcAft>
+            </a:pPr>
+            <a:r>
+              <a:rPr sz="900" b="1">
+                <a:solidFill>
+                  <a:srgbClr val="C5221F"/>
+                </a:solidFill>
+                <a:latin typeface="Google Sans Flex SemiBold"/>
+              </a:rPr>
+              <a:t>Must never: </a:t>
+            </a:r>
+            <a:r>
+              <a:rPr sz="900" b="0">
+                <a:solidFill>
+                  <a:srgbClr val="5F6368"/>
+                </a:solidFill>
+                <a:latin typeface="Google Sans Flex"/>
+              </a:rPr>
+              <a:t>Build the 3D before a person confirms</a:t>
+            </a:r>
+          </a:p>
+        </p:txBody>
+      </p:sp>
+    </p:spTree>
+  </p:cSld>
+  <p:clrMapOvr>
+    <a:masterClrMapping/>
+  </p:clrMapOvr>
+</p:sld>
+</file>
+
+<file path=ppt/slides/slide20.xml><?xml version="1.0" encoding="utf-8"?>
+<p:sld xmlns:a="http://schemas.openxmlformats.org/drawingml/2006/main" xmlns:r="http://schemas.openxmlformats.org/officeDocument/2006/relationships" xmlns:mc="http://schemas.openxmlformats.org/markup-compatibility/2006" xmlns:mv="urn:schemas-microsoft-com:mac:vml" xmlns:p="http://schemas.openxmlformats.org/presentationml/2006/main" xmlns:c="http://schemas.openxmlformats.org/drawingml/2006/chart" xmlns:dgm="http://schemas.openxmlformats.org/drawingml/2006/diagram" xmlns:o="urn:schemas-microsoft-com:office:office" xmlns:v="urn:schemas-microsoft-com:vml" xmlns:pvml="urn:schemas-microsoft-com:office:powerpoint" xmlns:com="http://schemas.openxmlformats.org/drawingml/2006/compatibility" xmlns:p14="http://schemas.microsoft.com/office/powerpoint/2010/main" xmlns:p15="http://schemas.microsoft.com/office/powerpoint/2012/main" xmlns:ahyp="http://schemas.microsoft.com/office/drawing/2018/hyperlinkcolor">
+  <p:cSld>
+    <p:spTree>
+      <p:nvGrpSpPr>
+        <p:cNvPr id="147" name="Shape 147"/>
+        <p:cNvGrpSpPr/>
+        <p:nvPr/>
+      </p:nvGrpSpPr>
+      <p:grpSpPr>
+        <a:xfrm>
+          <a:off x="0" y="0"/>
+          <a:ext cx="0" cy="0"/>
+          <a:chOff x="0" y="0"/>
+          <a:chExt cx="0" cy="0"/>
+        </a:xfrm>
+      </p:grpSpPr>
+      <p:pic>
+        <p:nvPicPr>
+          <p:cNvPr id="148" name="Google Shape;148;p25" title="Frame 144.png"/>
+          <p:cNvPicPr preferRelativeResize="0"/>
+          <p:nvPr/>
+        </p:nvPicPr>
+        <p:blipFill rotWithShape="1">
+          <a:blip r:embed="rId3">
+            <a:alphaModFix/>
+          </a:blip>
+          <a:srcRect b="98001" l="0" r="0" t="0"/>
+          <a:stretch/>
+        </p:blipFill>
+        <p:spPr>
+          <a:xfrm>
+            <a:off x="0" y="5093562"/>
+            <a:ext cx="9144000" cy="54275"/>
+          </a:xfrm>
+          <a:prstGeom prst="rect">
+            <a:avLst/>
+          </a:prstGeom>
+          <a:noFill/>
+          <a:ln>
+            <a:noFill/>
+          </a:ln>
+        </p:spPr>
+      </p:pic>
+      <p:pic>
+        <p:nvPicPr>
+          <p:cNvPr id="149" name="Google Shape;149;p25" title="Group 427319979.png"/>
+          <p:cNvPicPr preferRelativeResize="0"/>
+          <p:nvPr/>
+        </p:nvPicPr>
+        <p:blipFill>
+          <a:blip r:embed="rId4">
+            <a:alphaModFix/>
+          </a:blip>
+          <a:stretch>
+            <a:fillRect/>
+          </a:stretch>
+        </p:blipFill>
+        <p:spPr>
+          <a:xfrm>
+            <a:off x="0" y="1"/>
+            <a:ext cx="9144000" cy="507359"/>
+          </a:xfrm>
+          <a:prstGeom prst="rect">
+            <a:avLst/>
+          </a:prstGeom>
+          <a:noFill/>
+          <a:ln>
+            <a:noFill/>
+          </a:ln>
+        </p:spPr>
+      </p:pic>
+      <p:sp>
+        <p:nvSpPr>
+          <p:cNvPr id="150" name="Google Shape;150;p25"/>
+          <p:cNvSpPr/>
+          <p:nvPr/>
+        </p:nvSpPr>
+        <p:spPr>
+          <a:xfrm>
+            <a:off x="-29250" y="5071875"/>
+            <a:ext cx="9173400" cy="97800"/>
+          </a:xfrm>
+          <a:prstGeom prst="rect">
+            <a:avLst/>
+          </a:prstGeom>
+          <a:solidFill>
+            <a:schemeClr val="dk1"/>
+          </a:solidFill>
+          <a:ln>
+            <a:noFill/>
+          </a:ln>
+        </p:spPr>
+        <p:txBody>
+          <a:bodyPr anchorCtr="0" anchor="ctr" bIns="91425" lIns="91425" spcFirstLastPara="1" rIns="91425" wrap="square" tIns="91425">
+            <a:noAutofit/>
+          </a:bodyPr>
+          <a:lstStyle/>
+          <a:p>
+            <a:pPr indent="0" lvl="0" marL="0" rtl="0" algn="ctr">
+              <a:spcBef>
+                <a:spcPts val="0"/>
+              </a:spcBef>
+              <a:spcAft>
+                <a:spcPts val="0"/>
+              </a:spcAft>
+              <a:buNone/>
+            </a:pPr>
+            <a:r>
+              <a:t/>
+            </a:r>
+            <a:endParaRPr/>
+          </a:p>
+        </p:txBody>
+      </p:sp>
+      <p:sp>
+        <p:nvSpPr>
+          <p:cNvPr id="151" name="Google Shape;151;p25"/>
+          <p:cNvSpPr txBox="1"/>
+          <p:nvPr/>
+        </p:nvSpPr>
+        <p:spPr>
+          <a:xfrm>
+            <a:off x="265350" y="663825"/>
+            <a:ext cx="8943000" cy="502920"/>
+          </a:xfrm>
+          <a:prstGeom prst="rect">
+            <a:avLst/>
+          </a:prstGeom>
+          <a:noFill/>
+          <a:ln>
+            <a:noFill/>
+          </a:ln>
+        </p:spPr>
+        <p:txBody>
+          <a:bodyPr anchorCtr="0" anchor="t" bIns="91425" lIns="91425" spcFirstLastPara="1" rIns="91425" wrap="square" tIns="91425">
+            <a:noAutofit/>
+          </a:bodyPr>
+          <a:lstStyle/>
+          <a:p>
+            <a:pPr indent="0" lvl="0" marL="0" rtl="0" algn="l">
+              <a:spcBef>
+                <a:spcPts val="0"/>
+              </a:spcBef>
+              <a:spcAft>
+                <a:spcPts val="0"/>
+              </a:spcAft>
+              <a:buNone/>
+            </a:pPr>
+            <a:r>
+              <a:rPr lang="en-GB" sz="1600">
+                <a:latin typeface="Google Sans Flex Medium"/>
+                <a:ea typeface="Google Sans Flex Medium"/>
+                <a:cs typeface="Google Sans Flex Medium"/>
+                <a:sym typeface="Google Sans Flex Medium"/>
+              </a:rPr>
+              <a:t>Appendix: the operations team, four agents that keep it running</a:t>
+            </a:r>
+            <a:endParaRPr sz="1600">
+              <a:latin typeface="Google Sans Flex Medium"/>
+              <a:ea typeface="Google Sans Flex Medium"/>
+              <a:cs typeface="Google Sans Flex Medium"/>
+              <a:sym typeface="Google Sans Flex Medium"/>
+            </a:endParaRPr>
+          </a:p>
+        </p:txBody>
+      </p:sp>
+      <p:sp>
+        <p:nvSpPr>
+          <p:cNvPr id="152" name="agent card"/>
+          <p:cNvSpPr/>
+          <p:nvPr/>
+        </p:nvSpPr>
+        <p:spPr>
+          <a:xfrm>
+            <a:off x="274320" y="1097280"/>
+            <a:ext cx="4251960" cy="1874519"/>
+          </a:xfrm>
+          <a:prstGeom prst="roundRect">
+            <a:avLst>
+              <a:gd name="adj" fmla="val 6000"/>
+            </a:avLst>
+          </a:prstGeom>
+          <a:solidFill>
+            <a:srgbClr val="F1F3F4"/>
+          </a:solidFill>
+          <a:ln>
+            <a:noFill/>
+          </a:ln>
+          <a:effectLst/>
+        </p:spPr>
+        <p:style>
+          <a:lnRef idx="1">
+            <a:schemeClr val="accent1"/>
+          </a:lnRef>
+          <a:fillRef idx="3">
+            <a:schemeClr val="accent1"/>
+          </a:fillRef>
+          <a:effectRef idx="2">
+            <a:schemeClr val="accent1"/>
+          </a:effectRef>
+          <a:fontRef idx="minor">
+            <a:schemeClr val="lt1"/>
+          </a:fontRef>
+        </p:style>
+        <p:txBody>
+          <a:bodyPr rtlCol="0" anchor="ctr"/>
+          <a:lstStyle/>
+          <a:p>
+            <a:pPr algn="ctr"/>
+          </a:p>
+        </p:txBody>
+      </p:sp>
+      <p:sp>
+        <p:nvSpPr>
+          <p:cNvPr id="153" name="agent name"/>
+          <p:cNvSpPr txBox="1"/>
+          <p:nvPr/>
+        </p:nvSpPr>
+        <p:spPr>
+          <a:xfrm>
+            <a:off x="365760" y="1143000"/>
+            <a:ext cx="2514600" cy="292608"/>
+          </a:xfrm>
+          <a:prstGeom prst="rect">
+            <a:avLst/>
+          </a:prstGeom>
+          <a:noFill/>
+        </p:spPr>
+        <p:txBody>
+          <a:bodyPr wrap="square" anchor="t" lIns="36576" rIns="36576" tIns="18288" bIns="18288">
+            <a:spAutoFit/>
+          </a:bodyPr>
+          <a:lstStyle/>
+          <a:p>
+            <a:pPr algn="l">
+              <a:spcAft>
+                <a:spcPts val="400"/>
+              </a:spcAft>
+            </a:pPr>
+            <a:r>
+              <a:rPr sz="1300" b="1">
+                <a:solidFill>
+                  <a:srgbClr val="1A73E8"/>
+                </a:solidFill>
+                <a:latin typeface="Google Sans Flex SemiBold"/>
+              </a:rPr>
+              <a:t>Diagnosis</a:t>
+            </a:r>
+          </a:p>
+        </p:txBody>
+      </p:sp>
+      <p:sp>
+        <p:nvSpPr>
+          <p:cNvPr id="154" name="agent mode"/>
+          <p:cNvSpPr txBox="1"/>
+          <p:nvPr/>
+        </p:nvSpPr>
+        <p:spPr>
+          <a:xfrm>
+            <a:off x="2834640" y="1170432"/>
+            <a:ext cx="1600200" cy="237744"/>
+          </a:xfrm>
+          <a:prstGeom prst="rect">
+            <a:avLst/>
+          </a:prstGeom>
+          <a:noFill/>
+        </p:spPr>
+        <p:txBody>
+          <a:bodyPr wrap="square" anchor="t" lIns="36576" rIns="36576" tIns="18288" bIns="18288">
+            <a:spAutoFit/>
+          </a:bodyPr>
+          <a:lstStyle/>
+          <a:p>
+            <a:pPr algn="r">
+              <a:spcAft>
+                <a:spcPts val="400"/>
+              </a:spcAft>
+            </a:pPr>
+            <a:r>
+              <a:rPr sz="850" b="0">
+                <a:solidFill>
+                  <a:srgbClr val="5F6368"/>
+                </a:solidFill>
+                <a:latin typeface="Google Sans Flex"/>
+              </a:rPr>
+              <a:t>Model-driven · Gemini</a:t>
+            </a:r>
+          </a:p>
+        </p:txBody>
+      </p:sp>
+      <p:sp>
+        <p:nvSpPr>
+          <p:cNvPr id="155" name="agent text"/>
+          <p:cNvSpPr txBox="1"/>
+          <p:nvPr/>
+        </p:nvSpPr>
+        <p:spPr>
+          <a:xfrm>
+            <a:off x="365760" y="1463040"/>
+            <a:ext cx="4069080" cy="1463039"/>
+          </a:xfrm>
+          <a:prstGeom prst="rect">
+            <a:avLst/>
+          </a:prstGeom>
+          <a:noFill/>
+        </p:spPr>
+        <p:txBody>
+          <a:bodyPr wrap="square" anchor="t" lIns="36576" rIns="36576" tIns="18288" bIns="18288">
+            <a:spAutoFit/>
+          </a:bodyPr>
+          <a:lstStyle/>
+          <a:p>
+            <a:pPr algn="l">
+              <a:spcAft>
+                <a:spcPts val="300"/>
+              </a:spcAft>
+            </a:pPr>
+            <a:r>
+              <a:rPr sz="900" b="1">
+                <a:solidFill>
+                  <a:srgbClr val="1A73E8"/>
+                </a:solidFill>
+                <a:latin typeface="Google Sans Flex SemiBold"/>
+              </a:rPr>
+              <a:t>Use case: </a:t>
+            </a:r>
+            <a:r>
+              <a:rPr sz="900" b="0">
+                <a:solidFill>
+                  <a:srgbClr val="202124"/>
+                </a:solidFill>
+                <a:latin typeface="Google Sans Flex"/>
+              </a:rPr>
+              <a:t>A station stopped. Someone must say why, fast.</a:t>
+            </a:r>
+          </a:p>
+          <a:p>
+            <a:pPr algn="l">
+              <a:spcAft>
+                <a:spcPts val="300"/>
+              </a:spcAft>
+            </a:pPr>
+            <a:r>
+              <a:rPr sz="900" b="1">
+                <a:solidFill>
+                  <a:srgbClr val="B06000"/>
+                </a:solidFill>
+                <a:latin typeface="Google Sans Flex SemiBold"/>
+              </a:rPr>
+              <a:t>Solution: </a:t>
+            </a:r>
+            <a:r>
+              <a:rPr sz="900" b="0">
+                <a:solidFill>
+                  <a:srgbClr val="202124"/>
+                </a:solidFill>
+                <a:latin typeface="Google Sans Flex"/>
+              </a:rPr>
+              <a:t>Gemini picks MCP tools, reads the results and submits a cause with evidence. Cedar allows each call.</a:t>
+            </a:r>
+          </a:p>
+          <a:p>
+            <a:pPr algn="l">
+              <a:spcAft>
+                <a:spcPts val="300"/>
+              </a:spcAft>
+            </a:pPr>
+            <a:r>
+              <a:rPr sz="900" b="1">
+                <a:solidFill>
+                  <a:srgbClr val="188038"/>
+                </a:solidFill>
+                <a:latin typeface="Google Sans Flex SemiBold"/>
+              </a:rPr>
+              <a:t>Outcomes: </a:t>
+            </a:r>
+            <a:r>
+              <a:rPr sz="900" b="0">
+                <a:solidFill>
+                  <a:srgbClr val="202124"/>
+                </a:solidFill>
+                <a:latin typeface="Google Sans Flex"/>
+              </a:rPr>
+              <a:t>Cause · Evidence per claim · Tool trace</a:t>
+            </a:r>
+          </a:p>
+          <a:p>
+            <a:pPr algn="l">
+              <a:spcAft>
+                <a:spcPts val="400"/>
+              </a:spcAft>
+            </a:pPr>
+            <a:r>
+              <a:rPr sz="900" b="1">
+                <a:solidFill>
+                  <a:srgbClr val="C5221F"/>
+                </a:solidFill>
+                <a:latin typeface="Google Sans Flex SemiBold"/>
+              </a:rPr>
+              <a:t>Must never: </a:t>
+            </a:r>
+            <a:r>
+              <a:rPr sz="900" b="0">
+                <a:solidFill>
+                  <a:srgbClr val="5F6368"/>
+                </a:solidFill>
+                <a:latin typeface="Google Sans Flex"/>
+              </a:rPr>
+              <a:t>Write to the plant; Call a tool Cedar denies</a:t>
+            </a:r>
+          </a:p>
+        </p:txBody>
+      </p:sp>
+      <p:sp>
+        <p:nvSpPr>
+          <p:cNvPr id="156" name="agent card"/>
+          <p:cNvSpPr/>
+          <p:nvPr/>
+        </p:nvSpPr>
+        <p:spPr>
+          <a:xfrm>
+            <a:off x="4617720" y="1097280"/>
+            <a:ext cx="4251960" cy="1874519"/>
+          </a:xfrm>
+          <a:prstGeom prst="roundRect">
+            <a:avLst>
+              <a:gd name="adj" fmla="val 6000"/>
+            </a:avLst>
+          </a:prstGeom>
+          <a:solidFill>
+            <a:srgbClr val="F1F3F4"/>
+          </a:solidFill>
+          <a:ln>
+            <a:noFill/>
+          </a:ln>
+          <a:effectLst/>
+        </p:spPr>
+        <p:style>
+          <a:lnRef idx="1">
+            <a:schemeClr val="accent1"/>
+          </a:lnRef>
+          <a:fillRef idx="3">
+            <a:schemeClr val="accent1"/>
+          </a:fillRef>
+          <a:effectRef idx="2">
+            <a:schemeClr val="accent1"/>
+          </a:effectRef>
+          <a:fontRef idx="minor">
+            <a:schemeClr val="lt1"/>
+          </a:fontRef>
+        </p:style>
+        <p:txBody>
+          <a:bodyPr rtlCol="0" anchor="ctr"/>
+          <a:lstStyle/>
+          <a:p>
+            <a:pPr algn="ctr"/>
+          </a:p>
+        </p:txBody>
+      </p:sp>
+      <p:sp>
+        <p:nvSpPr>
+          <p:cNvPr id="157" name="agent name"/>
+          <p:cNvSpPr txBox="1"/>
+          <p:nvPr/>
+        </p:nvSpPr>
+        <p:spPr>
+          <a:xfrm>
+            <a:off x="4709159" y="1143000"/>
+            <a:ext cx="2514600" cy="292608"/>
+          </a:xfrm>
+          <a:prstGeom prst="rect">
+            <a:avLst/>
+          </a:prstGeom>
+          <a:noFill/>
+        </p:spPr>
+        <p:txBody>
+          <a:bodyPr wrap="square" anchor="t" lIns="36576" rIns="36576" tIns="18288" bIns="18288">
+            <a:spAutoFit/>
+          </a:bodyPr>
+          <a:lstStyle/>
+          <a:p>
+            <a:pPr algn="l">
+              <a:spcAft>
+                <a:spcPts val="400"/>
+              </a:spcAft>
+            </a:pPr>
+            <a:r>
+              <a:rPr sz="1300" b="1">
+                <a:solidFill>
+                  <a:srgbClr val="1A73E8"/>
+                </a:solidFill>
+                <a:latin typeface="Google Sans Flex SemiBold"/>
+              </a:rPr>
+              <a:t>Verifier</a:t>
+            </a:r>
+          </a:p>
+        </p:txBody>
+      </p:sp>
+      <p:sp>
+        <p:nvSpPr>
+          <p:cNvPr id="158" name="agent mode"/>
+          <p:cNvSpPr txBox="1"/>
+          <p:nvPr/>
+        </p:nvSpPr>
+        <p:spPr>
+          <a:xfrm>
+            <a:off x="7178040" y="1170432"/>
+            <a:ext cx="1600200" cy="237744"/>
+          </a:xfrm>
+          <a:prstGeom prst="rect">
+            <a:avLst/>
+          </a:prstGeom>
+          <a:noFill/>
+        </p:spPr>
+        <p:txBody>
+          <a:bodyPr wrap="square" anchor="t" lIns="36576" rIns="36576" tIns="18288" bIns="18288">
+            <a:spAutoFit/>
+          </a:bodyPr>
+          <a:lstStyle/>
+          <a:p>
+            <a:pPr algn="r">
+              <a:spcAft>
+                <a:spcPts val="400"/>
+              </a:spcAft>
+            </a:pPr>
+            <a:r>
+              <a:rPr sz="850" b="0">
+                <a:solidFill>
+                  <a:srgbClr val="5F6368"/>
+                </a:solidFill>
+                <a:latin typeface="Google Sans Flex"/>
+              </a:rPr>
+              <a:t>Model and rules · Gemini</a:t>
+            </a:r>
+          </a:p>
+        </p:txBody>
+      </p:sp>
+      <p:sp>
+        <p:nvSpPr>
+          <p:cNvPr id="159" name="agent text"/>
+          <p:cNvSpPr txBox="1"/>
+          <p:nvPr/>
+        </p:nvSpPr>
+        <p:spPr>
+          <a:xfrm>
+            <a:off x="4709159" y="1463040"/>
+            <a:ext cx="4069080" cy="1463039"/>
+          </a:xfrm>
+          <a:prstGeom prst="rect">
+            <a:avLst/>
+          </a:prstGeom>
+          <a:noFill/>
+        </p:spPr>
+        <p:txBody>
+          <a:bodyPr wrap="square" anchor="t" lIns="36576" rIns="36576" tIns="18288" bIns="18288">
+            <a:spAutoFit/>
+          </a:bodyPr>
+          <a:lstStyle/>
+          <a:p>
+            <a:pPr algn="l">
+              <a:spcAft>
+                <a:spcPts val="300"/>
+              </a:spcAft>
+            </a:pPr>
+            <a:r>
+              <a:rPr sz="900" b="1">
+                <a:solidFill>
+                  <a:srgbClr val="1A73E8"/>
+                </a:solidFill>
+                <a:latin typeface="Google Sans Flex SemiBold"/>
+              </a:rPr>
+              <a:t>Use case: </a:t>
+            </a:r>
+            <a:r>
+              <a:rPr sz="900" b="0">
+                <a:solidFill>
+                  <a:srgbClr val="202124"/>
+                </a:solidFill>
+                <a:latin typeface="Google Sans Flex"/>
+              </a:rPr>
+              <a:t>A model can sound sure and be wrong.</a:t>
+            </a:r>
+          </a:p>
+          <a:p>
+            <a:pPr algn="l">
+              <a:spcAft>
+                <a:spcPts val="300"/>
+              </a:spcAft>
+            </a:pPr>
+            <a:r>
+              <a:rPr sz="900" b="1">
+                <a:solidFill>
+                  <a:srgbClr val="B06000"/>
+                </a:solidFill>
+                <a:latin typeface="Google Sans Flex SemiBold"/>
+              </a:rPr>
+              <a:t>Solution: </a:t>
+            </a:r>
+            <a:r>
+              <a:rPr sz="900" b="0">
+                <a:solidFill>
+                  <a:srgbClr val="202124"/>
+                </a:solidFill>
+                <a:latin typeface="Google Sans Flex"/>
+              </a:rPr>
+              <a:t>Rule checks recompute every cited number from the tool results. Gemini then reviews the argument. A hard check cannot be talked away.</a:t>
+            </a:r>
+          </a:p>
+          <a:p>
+            <a:pPr algn="l">
+              <a:spcAft>
+                <a:spcPts val="300"/>
+              </a:spcAft>
+            </a:pPr>
+            <a:r>
+              <a:rPr sz="900" b="1">
+                <a:solidFill>
+                  <a:srgbClr val="188038"/>
+                </a:solidFill>
+                <a:latin typeface="Google Sans Flex SemiBold"/>
+              </a:rPr>
+              <a:t>Outcomes: </a:t>
+            </a:r>
+            <a:r>
+              <a:rPr sz="900" b="0">
+                <a:solidFill>
+                  <a:srgbClr val="202124"/>
+                </a:solidFill>
+                <a:latin typeface="Google Sans Flex"/>
+              </a:rPr>
+              <a:t>Supported or not · Issues list · Evidence score</a:t>
+            </a:r>
+          </a:p>
+          <a:p>
+            <a:pPr algn="l">
+              <a:spcAft>
+                <a:spcPts val="400"/>
+              </a:spcAft>
+            </a:pPr>
+            <a:r>
+              <a:rPr sz="900" b="1">
+                <a:solidFill>
+                  <a:srgbClr val="C5221F"/>
+                </a:solidFill>
+                <a:latin typeface="Google Sans Flex SemiBold"/>
+              </a:rPr>
+              <a:t>Must never: </a:t>
+            </a:r>
+            <a:r>
+              <a:rPr sz="900" b="0">
+                <a:solidFill>
+                  <a:srgbClr val="5F6368"/>
+                </a:solidFill>
+                <a:latin typeface="Google Sans Flex"/>
+              </a:rPr>
+              <a:t>Approve a claim whose numbers do not match</a:t>
+            </a:r>
+          </a:p>
+        </p:txBody>
+      </p:sp>
+      <p:sp>
+        <p:nvSpPr>
+          <p:cNvPr id="160" name="agent card"/>
+          <p:cNvSpPr/>
+          <p:nvPr/>
+        </p:nvSpPr>
+        <p:spPr>
+          <a:xfrm>
+            <a:off x="274320" y="3044952"/>
+            <a:ext cx="4251960" cy="1874519"/>
+          </a:xfrm>
+          <a:prstGeom prst="roundRect">
+            <a:avLst>
+              <a:gd name="adj" fmla="val 6000"/>
+            </a:avLst>
+          </a:prstGeom>
+          <a:solidFill>
+            <a:srgbClr val="F1F3F4"/>
+          </a:solidFill>
+          <a:ln>
+            <a:noFill/>
+          </a:ln>
+          <a:effectLst/>
+        </p:spPr>
+        <p:style>
+          <a:lnRef idx="1">
+            <a:schemeClr val="accent1"/>
+          </a:lnRef>
+          <a:fillRef idx="3">
+            <a:schemeClr val="accent1"/>
+          </a:fillRef>
+          <a:effectRef idx="2">
+            <a:schemeClr val="accent1"/>
+          </a:effectRef>
+          <a:fontRef idx="minor">
+            <a:schemeClr val="lt1"/>
+          </a:fontRef>
+        </p:style>
+        <p:txBody>
+          <a:bodyPr rtlCol="0" anchor="ctr"/>
+          <a:lstStyle/>
+          <a:p>
+            <a:pPr algn="ctr"/>
+          </a:p>
+        </p:txBody>
+      </p:sp>
+      <p:sp>
+        <p:nvSpPr>
+          <p:cNvPr id="161" name="agent name"/>
+          <p:cNvSpPr txBox="1"/>
+          <p:nvPr/>
+        </p:nvSpPr>
+        <p:spPr>
+          <a:xfrm>
+            <a:off x="365760" y="3090672"/>
+            <a:ext cx="2514600" cy="292608"/>
+          </a:xfrm>
+          <a:prstGeom prst="rect">
+            <a:avLst/>
+          </a:prstGeom>
+          <a:noFill/>
+        </p:spPr>
+        <p:txBody>
+          <a:bodyPr wrap="square" anchor="t" lIns="36576" rIns="36576" tIns="18288" bIns="18288">
+            <a:spAutoFit/>
+          </a:bodyPr>
+          <a:lstStyle/>
+          <a:p>
+            <a:pPr algn="l">
+              <a:spcAft>
+                <a:spcPts val="400"/>
+              </a:spcAft>
+            </a:pPr>
+            <a:r>
+              <a:rPr sz="1300" b="1">
+                <a:solidFill>
+                  <a:srgbClr val="1A73E8"/>
+                </a:solidFill>
+                <a:latin typeface="Google Sans Flex SemiBold"/>
+              </a:rPr>
+              <a:t>Remediation Planner</a:t>
+            </a:r>
+          </a:p>
+        </p:txBody>
+      </p:sp>
+      <p:sp>
+        <p:nvSpPr>
+          <p:cNvPr id="162" name="agent mode"/>
+          <p:cNvSpPr txBox="1"/>
+          <p:nvPr/>
+        </p:nvSpPr>
+        <p:spPr>
+          <a:xfrm>
+            <a:off x="2834640" y="3118104"/>
+            <a:ext cx="1600200" cy="237744"/>
+          </a:xfrm>
+          <a:prstGeom prst="rect">
+            <a:avLst/>
+          </a:prstGeom>
+          <a:noFill/>
+        </p:spPr>
+        <p:txBody>
+          <a:bodyPr wrap="square" anchor="t" lIns="36576" rIns="36576" tIns="18288" bIns="18288">
+            <a:spAutoFit/>
+          </a:bodyPr>
+          <a:lstStyle/>
+          <a:p>
+            <a:pPr algn="r">
+              <a:spcAft>
+                <a:spcPts val="400"/>
+              </a:spcAft>
+            </a:pPr>
+            <a:r>
+              <a:rPr sz="850" b="0">
+                <a:solidFill>
+                  <a:srgbClr val="5F6368"/>
+                </a:solidFill>
+                <a:latin typeface="Google Sans Flex"/>
+              </a:rPr>
+              <a:t>Model-driven · Gemini</a:t>
+            </a:r>
+          </a:p>
+        </p:txBody>
+      </p:sp>
+      <p:sp>
+        <p:nvSpPr>
+          <p:cNvPr id="163" name="agent text"/>
+          <p:cNvSpPr txBox="1"/>
+          <p:nvPr/>
+        </p:nvSpPr>
+        <p:spPr>
+          <a:xfrm>
+            <a:off x="365760" y="3410712"/>
+            <a:ext cx="4069080" cy="1463039"/>
+          </a:xfrm>
+          <a:prstGeom prst="rect">
+            <a:avLst/>
+          </a:prstGeom>
+          <a:noFill/>
+        </p:spPr>
+        <p:txBody>
+          <a:bodyPr wrap="square" anchor="t" lIns="36576" rIns="36576" tIns="18288" bIns="18288">
+            <a:spAutoFit/>
+          </a:bodyPr>
+          <a:lstStyle/>
+          <a:p>
+            <a:pPr algn="l">
+              <a:spcAft>
+                <a:spcPts val="300"/>
+              </a:spcAft>
+            </a:pPr>
+            <a:r>
+              <a:rPr sz="900" b="1">
+                <a:solidFill>
+                  <a:srgbClr val="1A73E8"/>
+                </a:solidFill>
+                <a:latin typeface="Google Sans Flex SemiBold"/>
+              </a:rPr>
+              <a:t>Use case: </a:t>
+            </a:r>
+            <a:r>
+              <a:rPr sz="900" b="0">
+                <a:solidFill>
+                  <a:srgbClr val="202124"/>
+                </a:solidFill>
+                <a:latin typeface="Google Sans Flex"/>
+              </a:rPr>
+              <a:t>After a cause is known, someone must choose a fix that respects the plant's limits.</a:t>
+            </a:r>
+          </a:p>
+          <a:p>
+            <a:pPr algn="l">
+              <a:spcAft>
+                <a:spcPts val="300"/>
+              </a:spcAft>
+            </a:pPr>
+            <a:r>
+              <a:rPr sz="900" b="1">
+                <a:solidFill>
+                  <a:srgbClr val="B06000"/>
+                </a:solidFill>
+                <a:latin typeface="Google Sans Flex SemiBold"/>
+              </a:rPr>
+              <a:t>Solution: </a:t>
+            </a:r>
+            <a:r>
+              <a:rPr sz="900" b="0">
+                <a:solidFill>
+                  <a:srgbClr val="202124"/>
+                </a:solidFill>
+                <a:latin typeface="Google Sans Flex"/>
+              </a:rPr>
+              <a:t>Gemini proposes actions from the diagnosis and the limits. Warden scores each. Nothing is applied here.</a:t>
+            </a:r>
+          </a:p>
+          <a:p>
+            <a:pPr algn="l">
+              <a:spcAft>
+                <a:spcPts val="300"/>
+              </a:spcAft>
+            </a:pPr>
+            <a:r>
+              <a:rPr sz="900" b="1">
+                <a:solidFill>
+                  <a:srgbClr val="188038"/>
+                </a:solidFill>
+                <a:latin typeface="Google Sans Flex SemiBold"/>
+              </a:rPr>
+              <a:t>Outcomes: </a:t>
+            </a:r>
+            <a:r>
+              <a:rPr sz="900" b="0">
+                <a:solidFill>
+                  <a:srgbClr val="202124"/>
+                </a:solidFill>
+                <a:latin typeface="Google Sans Flex"/>
+              </a:rPr>
+              <a:t>Action list · Exact settings · Why this action</a:t>
+            </a:r>
+          </a:p>
+          <a:p>
+            <a:pPr algn="l">
+              <a:spcAft>
+                <a:spcPts val="400"/>
+              </a:spcAft>
+            </a:pPr>
+            <a:r>
+              <a:rPr sz="900" b="1">
+                <a:solidFill>
+                  <a:srgbClr val="C5221F"/>
+                </a:solidFill>
+                <a:latin typeface="Google Sans Flex SemiBold"/>
+              </a:rPr>
+              <a:t>Must never: </a:t>
+            </a:r>
+            <a:r>
+              <a:rPr sz="900" b="0">
+                <a:solidFill>
+                  <a:srgbClr val="5F6368"/>
+                </a:solidFill>
+                <a:latin typeface="Google Sans Flex"/>
+              </a:rPr>
+              <a:t>Write to the plant; Propose a setting above a hard limit as the first choice</a:t>
+            </a:r>
+          </a:p>
+        </p:txBody>
+      </p:sp>
+      <p:sp>
+        <p:nvSpPr>
+          <p:cNvPr id="164" name="agent card"/>
+          <p:cNvSpPr/>
+          <p:nvPr/>
+        </p:nvSpPr>
+        <p:spPr>
+          <a:xfrm>
+            <a:off x="4617720" y="3044952"/>
+            <a:ext cx="4251960" cy="1874519"/>
+          </a:xfrm>
+          <a:prstGeom prst="roundRect">
+            <a:avLst>
+              <a:gd name="adj" fmla="val 6000"/>
+            </a:avLst>
+          </a:prstGeom>
+          <a:solidFill>
+            <a:srgbClr val="F1F3F4"/>
+          </a:solidFill>
+          <a:ln>
+            <a:noFill/>
+          </a:ln>
+          <a:effectLst/>
+        </p:spPr>
+        <p:style>
+          <a:lnRef idx="1">
+            <a:schemeClr val="accent1"/>
+          </a:lnRef>
+          <a:fillRef idx="3">
+            <a:schemeClr val="accent1"/>
+          </a:fillRef>
+          <a:effectRef idx="2">
+            <a:schemeClr val="accent1"/>
+          </a:effectRef>
+          <a:fontRef idx="minor">
+            <a:schemeClr val="lt1"/>
+          </a:fontRef>
+        </p:style>
+        <p:txBody>
+          <a:bodyPr rtlCol="0" anchor="ctr"/>
+          <a:lstStyle/>
+          <a:p>
+            <a:pPr algn="ctr"/>
+          </a:p>
+        </p:txBody>
+      </p:sp>
+      <p:sp>
+        <p:nvSpPr>
+          <p:cNvPr id="165" name="agent name"/>
+          <p:cNvSpPr txBox="1"/>
+          <p:nvPr/>
+        </p:nvSpPr>
+        <p:spPr>
+          <a:xfrm>
+            <a:off x="4709159" y="3090672"/>
+            <a:ext cx="2514600" cy="292608"/>
+          </a:xfrm>
+          <a:prstGeom prst="rect">
+            <a:avLst/>
+          </a:prstGeom>
+          <a:noFill/>
+        </p:spPr>
+        <p:txBody>
+          <a:bodyPr wrap="square" anchor="t" lIns="36576" rIns="36576" tIns="18288" bIns="18288">
+            <a:spAutoFit/>
+          </a:bodyPr>
+          <a:lstStyle/>
+          <a:p>
+            <a:pPr algn="l">
+              <a:spcAft>
+                <a:spcPts val="400"/>
+              </a:spcAft>
+            </a:pPr>
+            <a:r>
+              <a:rPr sz="1300" b="1">
+                <a:solidFill>
+                  <a:srgbClr val="1A73E8"/>
+                </a:solidFill>
+                <a:latin typeface="Google Sans Flex SemiBold"/>
+              </a:rPr>
+              <a:t>Warden</a:t>
+            </a:r>
+          </a:p>
+        </p:txBody>
+      </p:sp>
+      <p:sp>
+        <p:nvSpPr>
+          <p:cNvPr id="166" name="agent mode"/>
+          <p:cNvSpPr txBox="1"/>
+          <p:nvPr/>
+        </p:nvSpPr>
+        <p:spPr>
+          <a:xfrm>
+            <a:off x="7178040" y="3118104"/>
+            <a:ext cx="1600200" cy="237744"/>
+          </a:xfrm>
+          <a:prstGeom prst="rect">
+            <a:avLst/>
+          </a:prstGeom>
+          <a:noFill/>
+        </p:spPr>
+        <p:txBody>
+          <a:bodyPr wrap="square" anchor="t" lIns="36576" rIns="36576" tIns="18288" bIns="18288">
+            <a:spAutoFit/>
+          </a:bodyPr>
+          <a:lstStyle/>
+          <a:p>
+            <a:pPr algn="r">
+              <a:spcAft>
+                <a:spcPts val="400"/>
+              </a:spcAft>
+            </a:pPr>
+            <a:r>
+              <a:rPr sz="850" b="0">
+                <a:solidFill>
+                  <a:srgbClr val="5F6368"/>
+                </a:solidFill>
+                <a:latin typeface="Google Sans Flex"/>
+              </a:rPr>
+              <a:t>Rule-driven · Gemini</a:t>
+            </a:r>
+          </a:p>
+        </p:txBody>
+      </p:sp>
+      <p:sp>
+        <p:nvSpPr>
+          <p:cNvPr id="167" name="agent text"/>
+          <p:cNvSpPr txBox="1"/>
+          <p:nvPr/>
+        </p:nvSpPr>
+        <p:spPr>
+          <a:xfrm>
+            <a:off x="4709159" y="3410712"/>
+            <a:ext cx="4069080" cy="1463039"/>
+          </a:xfrm>
+          <a:prstGeom prst="rect">
+            <a:avLst/>
+          </a:prstGeom>
+          <a:noFill/>
+        </p:spPr>
+        <p:txBody>
+          <a:bodyPr wrap="square" anchor="t" lIns="36576" rIns="36576" tIns="18288" bIns="18288">
+            <a:spAutoFit/>
+          </a:bodyPr>
+          <a:lstStyle/>
+          <a:p>
+            <a:pPr algn="l">
+              <a:spcAft>
+                <a:spcPts val="300"/>
+              </a:spcAft>
+            </a:pPr>
+            <a:r>
+              <a:rPr sz="900" b="1">
+                <a:solidFill>
+                  <a:srgbClr val="1A73E8"/>
+                </a:solidFill>
+                <a:latin typeface="Google Sans Flex SemiBold"/>
+              </a:rPr>
+              <a:t>Use case: </a:t>
+            </a:r>
+            <a:r>
+              <a:rPr sz="900" b="0">
+                <a:solidFill>
+                  <a:srgbClr val="202124"/>
+                </a:solidFill>
+                <a:latin typeface="Google Sans Flex"/>
+              </a:rPr>
+              <a:t>Some fixes are small and some can stop a line. The user decides how far the system may go alone.</a:t>
+            </a:r>
+          </a:p>
+          <a:p>
+            <a:pPr algn="l">
+              <a:spcAft>
+                <a:spcPts val="300"/>
+              </a:spcAft>
+            </a:pPr>
+            <a:r>
+              <a:rPr sz="900" b="1">
+                <a:solidFill>
+                  <a:srgbClr val="B06000"/>
+                </a:solidFill>
+                <a:latin typeface="Google Sans Flex SemiBold"/>
+              </a:rPr>
+              <a:t>Solution: </a:t>
+            </a:r>
+            <a:r>
+              <a:rPr sz="900" b="0">
+                <a:solidFill>
+                  <a:srgbClr val="202124"/>
+                </a:solidFill>
+                <a:latin typeface="Google Sans Flex"/>
+              </a:rPr>
+              <a:t>Six factors give a score from 0 to 100. The user sets a floor and a limit. Cedar enforces them at the Action Broker.</a:t>
+            </a:r>
+          </a:p>
+          <a:p>
+            <a:pPr algn="l">
+              <a:spcAft>
+                <a:spcPts val="300"/>
+              </a:spcAft>
+            </a:pPr>
+            <a:r>
+              <a:rPr sz="900" b="1">
+                <a:solidFill>
+                  <a:srgbClr val="188038"/>
+                </a:solidFill>
+                <a:latin typeface="Google Sans Flex SemiBold"/>
+              </a:rPr>
+              <a:t>Outcomes: </a:t>
+            </a:r>
+            <a:r>
+              <a:rPr sz="900" b="0">
+                <a:solidFill>
+                  <a:srgbClr val="202124"/>
+                </a:solidFill>
+                <a:latin typeface="Google Sans Flex"/>
+              </a:rPr>
+              <a:t>Score with factors · Auto, approve or refuse · Backtest on past incidents</a:t>
+            </a:r>
+          </a:p>
+          <a:p>
+            <a:pPr algn="l">
+              <a:spcAft>
+                <a:spcPts val="400"/>
+              </a:spcAft>
+            </a:pPr>
+            <a:r>
+              <a:rPr sz="900" b="1">
+                <a:solidFill>
+                  <a:srgbClr val="C5221F"/>
+                </a:solidFill>
+                <a:latin typeface="Google Sans Flex SemiBold"/>
+              </a:rPr>
+              <a:t>Must never: </a:t>
+            </a:r>
+            <a:r>
+              <a:rPr sz="900" b="0">
+                <a:solidFill>
+                  <a:srgbClr val="5F6368"/>
+                </a:solidFill>
+                <a:latin typeface="Google Sans Flex"/>
+              </a:rPr>
+              <a:t>Let a high score override a hard limit</a:t>
+            </a:r>
+          </a:p>
+        </p:txBody>
+      </p:sp>
+    </p:spTree>
+  </p:cSld>
+  <p:clrMapOvr>
+    <a:masterClrMapping/>
+  </p:clrMapOvr>
+</p:sld>
+</file>
+
+<file path=ppt/slides/slide21.xml><?xml version="1.0" encoding="utf-8"?>
+<p:sld xmlns:a="http://schemas.openxmlformats.org/drawingml/2006/main" xmlns:r="http://schemas.openxmlformats.org/officeDocument/2006/relationships" xmlns:mc="http://schemas.openxmlformats.org/markup-compatibility/2006" xmlns:mv="urn:schemas-microsoft-com:mac:vml" xmlns:p="http://schemas.openxmlformats.org/presentationml/2006/main" xmlns:c="http://schemas.openxmlformats.org/drawingml/2006/chart" xmlns:dgm="http://schemas.openxmlformats.org/drawingml/2006/diagram" xmlns:o="urn:schemas-microsoft-com:office:office" xmlns:v="urn:schemas-microsoft-com:vml" xmlns:pvml="urn:schemas-microsoft-com:office:powerpoint" xmlns:com="http://schemas.openxmlformats.org/drawingml/2006/compatibility" xmlns:p14="http://schemas.microsoft.com/office/powerpoint/2010/main" xmlns:p15="http://schemas.microsoft.com/office/powerpoint/2012/main" xmlns:ahyp="http://schemas.microsoft.com/office/drawing/2018/hyperlinkcolor">
+  <p:cSld>
+    <p:spTree>
+      <p:nvGrpSpPr>
+        <p:cNvPr id="147" name="Shape 147"/>
+        <p:cNvGrpSpPr/>
+        <p:nvPr/>
+      </p:nvGrpSpPr>
+      <p:grpSpPr>
+        <a:xfrm>
+          <a:off x="0" y="0"/>
+          <a:ext cx="0" cy="0"/>
+          <a:chOff x="0" y="0"/>
+          <a:chExt cx="0" cy="0"/>
+        </a:xfrm>
+      </p:grpSpPr>
+      <p:pic>
+        <p:nvPicPr>
+          <p:cNvPr id="148" name="Google Shape;148;p25" title="Frame 144.png"/>
+          <p:cNvPicPr preferRelativeResize="0"/>
+          <p:nvPr/>
+        </p:nvPicPr>
+        <p:blipFill rotWithShape="1">
+          <a:blip r:embed="rId3">
+            <a:alphaModFix/>
+          </a:blip>
+          <a:srcRect b="98001" l="0" r="0" t="0"/>
+          <a:stretch/>
+        </p:blipFill>
+        <p:spPr>
+          <a:xfrm>
+            <a:off x="0" y="5093562"/>
+            <a:ext cx="9144000" cy="54275"/>
+          </a:xfrm>
+          <a:prstGeom prst="rect">
+            <a:avLst/>
+          </a:prstGeom>
+          <a:noFill/>
+          <a:ln>
+            <a:noFill/>
+          </a:ln>
+        </p:spPr>
+      </p:pic>
+      <p:pic>
+        <p:nvPicPr>
+          <p:cNvPr id="149" name="Google Shape;149;p25" title="Group 427319979.png"/>
+          <p:cNvPicPr preferRelativeResize="0"/>
+          <p:nvPr/>
+        </p:nvPicPr>
+        <p:blipFill>
+          <a:blip r:embed="rId4">
+            <a:alphaModFix/>
+          </a:blip>
+          <a:stretch>
+            <a:fillRect/>
+          </a:stretch>
+        </p:blipFill>
+        <p:spPr>
+          <a:xfrm>
+            <a:off x="0" y="1"/>
+            <a:ext cx="9144000" cy="507359"/>
+          </a:xfrm>
+          <a:prstGeom prst="rect">
+            <a:avLst/>
+          </a:prstGeom>
+          <a:noFill/>
+          <a:ln>
+            <a:noFill/>
+          </a:ln>
+        </p:spPr>
+      </p:pic>
+      <p:sp>
+        <p:nvSpPr>
+          <p:cNvPr id="150" name="Google Shape;150;p25"/>
+          <p:cNvSpPr/>
+          <p:nvPr/>
+        </p:nvSpPr>
+        <p:spPr>
+          <a:xfrm>
+            <a:off x="-29250" y="5071875"/>
+            <a:ext cx="9173400" cy="97800"/>
+          </a:xfrm>
+          <a:prstGeom prst="rect">
+            <a:avLst/>
+          </a:prstGeom>
+          <a:solidFill>
+            <a:schemeClr val="dk1"/>
+          </a:solidFill>
+          <a:ln>
+            <a:noFill/>
+          </a:ln>
+        </p:spPr>
+        <p:txBody>
+          <a:bodyPr anchorCtr="0" anchor="ctr" bIns="91425" lIns="91425" spcFirstLastPara="1" rIns="91425" wrap="square" tIns="91425">
+            <a:noAutofit/>
+          </a:bodyPr>
+          <a:lstStyle/>
+          <a:p>
+            <a:pPr indent="0" lvl="0" marL="0" rtl="0" algn="ctr">
+              <a:spcBef>
+                <a:spcPts val="0"/>
+              </a:spcBef>
+              <a:spcAft>
+                <a:spcPts val="0"/>
+              </a:spcAft>
+              <a:buNone/>
+            </a:pPr>
+            <a:r>
+              <a:t/>
+            </a:r>
+            <a:endParaRPr/>
+          </a:p>
+        </p:txBody>
+      </p:sp>
+      <p:sp>
+        <p:nvSpPr>
+          <p:cNvPr id="151" name="Google Shape;151;p25"/>
+          <p:cNvSpPr txBox="1"/>
+          <p:nvPr/>
+        </p:nvSpPr>
+        <p:spPr>
+          <a:xfrm>
+            <a:off x="265350" y="663825"/>
+            <a:ext cx="8943000" cy="502920"/>
+          </a:xfrm>
+          <a:prstGeom prst="rect">
+            <a:avLst/>
+          </a:prstGeom>
+          <a:noFill/>
+          <a:ln>
+            <a:noFill/>
+          </a:ln>
+        </p:spPr>
+        <p:txBody>
+          <a:bodyPr anchorCtr="0" anchor="t" bIns="91425" lIns="91425" spcFirstLastPara="1" rIns="91425" wrap="square" tIns="91425">
+            <a:noAutofit/>
+          </a:bodyPr>
+          <a:lstStyle/>
+          <a:p>
+            <a:pPr indent="0" lvl="0" marL="0" rtl="0" algn="l">
+              <a:spcBef>
+                <a:spcPts val="0"/>
+              </a:spcBef>
+              <a:spcAft>
+                <a:spcPts val="0"/>
+              </a:spcAft>
+              <a:buNone/>
+            </a:pPr>
+            <a:r>
+              <a:rPr lang="en-GB" sz="1600">
+                <a:latin typeface="Google Sans Flex Medium"/>
+                <a:ea typeface="Google Sans Flex Medium"/>
+                <a:cs typeface="Google Sans Flex Medium"/>
+                <a:sym typeface="Google Sans Flex Medium"/>
+              </a:rPr>
+              <a:t>Appendix: plain rules, your playbooks, your channels</a:t>
+            </a:r>
+            <a:endParaRPr sz="1600">
+              <a:latin typeface="Google Sans Flex Medium"/>
+              <a:ea typeface="Google Sans Flex Medium"/>
+              <a:cs typeface="Google Sans Flex Medium"/>
+              <a:sym typeface="Google Sans Flex Medium"/>
+            </a:endParaRPr>
+          </a:p>
+        </p:txBody>
+      </p:sp>
+      <p:sp>
+        <p:nvSpPr>
+          <p:cNvPr id="152" name="agent card"/>
+          <p:cNvSpPr/>
+          <p:nvPr/>
+        </p:nvSpPr>
+        <p:spPr>
+          <a:xfrm>
+            <a:off x="274320" y="1097280"/>
+            <a:ext cx="4251960" cy="2240280"/>
+          </a:xfrm>
+          <a:prstGeom prst="roundRect">
+            <a:avLst>
+              <a:gd name="adj" fmla="val 6000"/>
+            </a:avLst>
+          </a:prstGeom>
+          <a:solidFill>
+            <a:srgbClr val="F1F3F4"/>
+          </a:solidFill>
+          <a:ln>
+            <a:noFill/>
+          </a:ln>
+          <a:effectLst/>
+        </p:spPr>
+        <p:style>
+          <a:lnRef idx="1">
+            <a:schemeClr val="accent1"/>
+          </a:lnRef>
+          <a:fillRef idx="3">
+            <a:schemeClr val="accent1"/>
+          </a:fillRef>
+          <a:effectRef idx="2">
+            <a:schemeClr val="accent1"/>
+          </a:effectRef>
+          <a:fontRef idx="minor">
+            <a:schemeClr val="lt1"/>
+          </a:fontRef>
+        </p:style>
+        <p:txBody>
+          <a:bodyPr rtlCol="0" anchor="ctr"/>
+          <a:lstStyle/>
+          <a:p>
+            <a:pPr algn="ctr"/>
+          </a:p>
+        </p:txBody>
+      </p:sp>
+      <p:sp>
+        <p:nvSpPr>
+          <p:cNvPr id="153" name="agent name"/>
+          <p:cNvSpPr txBox="1"/>
+          <p:nvPr/>
+        </p:nvSpPr>
+        <p:spPr>
+          <a:xfrm>
+            <a:off x="365760" y="1143000"/>
+            <a:ext cx="2514600" cy="292608"/>
+          </a:xfrm>
+          <a:prstGeom prst="rect">
+            <a:avLst/>
+          </a:prstGeom>
+          <a:noFill/>
+        </p:spPr>
+        <p:txBody>
+          <a:bodyPr wrap="square" anchor="t" lIns="36576" rIns="36576" tIns="18288" bIns="18288">
+            <a:spAutoFit/>
+          </a:bodyPr>
+          <a:lstStyle/>
+          <a:p>
+            <a:pPr algn="l">
+              <a:spcAft>
+                <a:spcPts val="400"/>
+              </a:spcAft>
+            </a:pPr>
+            <a:r>
+              <a:rPr sz="1300" b="1">
+                <a:solidFill>
+                  <a:srgbClr val="1A73E8"/>
+                </a:solidFill>
+                <a:latin typeface="Google Sans Flex SemiBold"/>
+              </a:rPr>
+              <a:t>Sentinel</a:t>
+            </a:r>
+          </a:p>
+        </p:txBody>
+      </p:sp>
+      <p:sp>
+        <p:nvSpPr>
+          <p:cNvPr id="154" name="agent mode"/>
+          <p:cNvSpPr txBox="1"/>
+          <p:nvPr/>
+        </p:nvSpPr>
+        <p:spPr>
+          <a:xfrm>
+            <a:off x="2834640" y="1170432"/>
+            <a:ext cx="1600200" cy="237744"/>
+          </a:xfrm>
+          <a:prstGeom prst="rect">
+            <a:avLst/>
+          </a:prstGeom>
+          <a:noFill/>
+        </p:spPr>
+        <p:txBody>
+          <a:bodyPr wrap="square" anchor="t" lIns="36576" rIns="36576" tIns="18288" bIns="18288">
+            <a:spAutoFit/>
+          </a:bodyPr>
+          <a:lstStyle/>
+          <a:p>
+            <a:pPr algn="r">
+              <a:spcAft>
+                <a:spcPts val="400"/>
+              </a:spcAft>
+            </a:pPr>
+            <a:r>
+              <a:rPr sz="850" b="0">
+                <a:solidFill>
+                  <a:srgbClr val="5F6368"/>
+                </a:solidFill>
+                <a:latin typeface="Google Sans Flex"/>
+              </a:rPr>
+              <a:t>Model and rules · Gemini</a:t>
+            </a:r>
+          </a:p>
+        </p:txBody>
+      </p:sp>
+      <p:sp>
+        <p:nvSpPr>
+          <p:cNvPr id="155" name="agent text"/>
+          <p:cNvSpPr txBox="1"/>
+          <p:nvPr/>
+        </p:nvSpPr>
+        <p:spPr>
+          <a:xfrm>
+            <a:off x="365760" y="1463040"/>
+            <a:ext cx="4069080" cy="1828800"/>
+          </a:xfrm>
+          <a:prstGeom prst="rect">
+            <a:avLst/>
+          </a:prstGeom>
+          <a:noFill/>
+        </p:spPr>
+        <p:txBody>
+          <a:bodyPr wrap="square" anchor="t" lIns="36576" rIns="36576" tIns="18288" bIns="18288">
+            <a:spAutoFit/>
+          </a:bodyPr>
+          <a:lstStyle/>
+          <a:p>
+            <a:pPr algn="l">
+              <a:spcAft>
+                <a:spcPts val="300"/>
+              </a:spcAft>
+            </a:pPr>
+            <a:r>
+              <a:rPr sz="900" b="1">
+                <a:solidFill>
+                  <a:srgbClr val="1A73E8"/>
+                </a:solidFill>
+                <a:latin typeface="Google Sans Flex SemiBold"/>
+              </a:rPr>
+              <a:t>Use case: </a:t>
+            </a:r>
+            <a:r>
+              <a:rPr sz="900" b="0">
+                <a:solidFill>
+                  <a:srgbClr val="202124"/>
+                </a:solidFill>
+                <a:latin typeface="Google Sans Flex"/>
+              </a:rPr>
+              <a:t>A plant's IT side fails quietly: a feed stops, a column changes, a service is slow. A model should not be the judge of that.</a:t>
+            </a:r>
+          </a:p>
+          <a:p>
+            <a:pPr algn="l">
+              <a:spcAft>
+                <a:spcPts val="300"/>
+              </a:spcAft>
+            </a:pPr>
+            <a:r>
+              <a:rPr sz="900" b="1">
+                <a:solidFill>
+                  <a:srgbClr val="B06000"/>
+                </a:solidFill>
+                <a:latin typeface="Google Sans Flex SemiBold"/>
+              </a:rPr>
+              <a:t>Solution: </a:t>
+            </a:r>
+            <a:r>
+              <a:rPr sz="900" b="0">
+                <a:solidFill>
+                  <a:srgbClr val="202124"/>
+                </a:solidFill>
+                <a:latin typeface="Google Sans Flex"/>
+              </a:rPr>
+              <a:t>Plain rules check a field against a value on your data tables, a web address, a port, a service or a certificate. A schedule runs them, maintenance windows keep planned work quiet, and an impact map shows which stations lose data. A rule that fails or recovers tells your channels.</a:t>
+            </a:r>
+          </a:p>
+          <a:p>
+            <a:pPr algn="l">
+              <a:spcAft>
+                <a:spcPts val="300"/>
+              </a:spcAft>
+            </a:pPr>
+            <a:r>
+              <a:rPr sz="900" b="1">
+                <a:solidFill>
+                  <a:srgbClr val="188038"/>
+                </a:solidFill>
+                <a:latin typeface="Google Sans Flex SemiBold"/>
+              </a:rPr>
+              <a:t>Outcomes: </a:t>
+            </a:r>
+            <a:r>
+              <a:rPr sz="900" b="0">
+                <a:solidFill>
+                  <a:srgbClr val="202124"/>
+                </a:solidFill>
+                <a:latin typeface="Google Sans Flex"/>
+              </a:rPr>
+              <a:t>Pass or fail for each rule · The stations that lose data · A message when a rule fails or recovers</a:t>
+            </a:r>
+          </a:p>
+          <a:p>
+            <a:pPr algn="l">
+              <a:spcAft>
+                <a:spcPts val="400"/>
+              </a:spcAft>
+            </a:pPr>
+            <a:r>
+              <a:rPr sz="900" b="1">
+                <a:solidFill>
+                  <a:srgbClr val="C5221F"/>
+                </a:solidFill>
+                <a:latin typeface="Google Sans Flex SemiBold"/>
+              </a:rPr>
+              <a:t>Must never: </a:t>
+            </a:r>
+            <a:r>
+              <a:rPr sz="900" b="0">
+                <a:solidFill>
+                  <a:srgbClr val="5F6368"/>
+                </a:solidFill>
+                <a:latin typeface="Google Sans Flex"/>
+              </a:rPr>
+              <a:t>Write to the plant; Let a model say pass or fail; Reach a private network address</a:t>
+            </a:r>
+          </a:p>
+        </p:txBody>
+      </p:sp>
+      <p:sp>
+        <p:nvSpPr>
+          <p:cNvPr id="156" name="agent card"/>
+          <p:cNvSpPr/>
+          <p:nvPr/>
+        </p:nvSpPr>
+        <p:spPr>
+          <a:xfrm>
+            <a:off x="4617720" y="1097280"/>
+            <a:ext cx="4251960" cy="2240280"/>
+          </a:xfrm>
+          <a:prstGeom prst="roundRect">
+            <a:avLst>
+              <a:gd name="adj" fmla="val 6000"/>
+            </a:avLst>
+          </a:prstGeom>
+          <a:solidFill>
+            <a:srgbClr val="F1F3F4"/>
+          </a:solidFill>
+          <a:ln>
+            <a:noFill/>
+          </a:ln>
+          <a:effectLst/>
+        </p:spPr>
+        <p:style>
+          <a:lnRef idx="1">
+            <a:schemeClr val="accent1"/>
+          </a:lnRef>
+          <a:fillRef idx="3">
+            <a:schemeClr val="accent1"/>
+          </a:fillRef>
+          <a:effectRef idx="2">
+            <a:schemeClr val="accent1"/>
+          </a:effectRef>
+          <a:fontRef idx="minor">
+            <a:schemeClr val="lt1"/>
+          </a:fontRef>
+        </p:style>
+        <p:txBody>
+          <a:bodyPr rtlCol="0" anchor="ctr"/>
+          <a:lstStyle/>
+          <a:p>
+            <a:pPr algn="ctr"/>
+          </a:p>
+        </p:txBody>
+      </p:sp>
+      <p:sp>
+        <p:nvSpPr>
+          <p:cNvPr id="157" name="agent name"/>
+          <p:cNvSpPr txBox="1"/>
+          <p:nvPr/>
+        </p:nvSpPr>
+        <p:spPr>
+          <a:xfrm>
+            <a:off x="4709159" y="1143000"/>
+            <a:ext cx="2514600" cy="292608"/>
+          </a:xfrm>
+          <a:prstGeom prst="rect">
+            <a:avLst/>
+          </a:prstGeom>
+          <a:noFill/>
+        </p:spPr>
+        <p:txBody>
+          <a:bodyPr wrap="square" anchor="t" lIns="36576" rIns="36576" tIns="18288" bIns="18288">
+            <a:spAutoFit/>
+          </a:bodyPr>
+          <a:lstStyle/>
+          <a:p>
+            <a:pPr algn="l">
+              <a:spcAft>
+                <a:spcPts val="400"/>
+              </a:spcAft>
+            </a:pPr>
+            <a:r>
+              <a:rPr sz="1300" b="1">
+                <a:solidFill>
+                  <a:srgbClr val="1A73E8"/>
+                </a:solidFill>
+                <a:latin typeface="Google Sans Flex SemiBold"/>
+              </a:rPr>
+              <a:t>Playbooks</a:t>
+            </a:r>
+          </a:p>
+        </p:txBody>
+      </p:sp>
+      <p:sp>
+        <p:nvSpPr>
+          <p:cNvPr id="158" name="agent mode"/>
+          <p:cNvSpPr txBox="1"/>
+          <p:nvPr/>
+        </p:nvSpPr>
+        <p:spPr>
+          <a:xfrm>
+            <a:off x="7178040" y="1170432"/>
+            <a:ext cx="1600200" cy="237744"/>
+          </a:xfrm>
+          <a:prstGeom prst="rect">
+            <a:avLst/>
+          </a:prstGeom>
+          <a:noFill/>
+        </p:spPr>
+        <p:txBody>
+          <a:bodyPr wrap="square" anchor="t" lIns="36576" rIns="36576" tIns="18288" bIns="18288">
+            <a:spAutoFit/>
+          </a:bodyPr>
+          <a:lstStyle/>
+          <a:p>
+            <a:pPr algn="r">
+              <a:spcAft>
+                <a:spcPts val="400"/>
+              </a:spcAft>
+            </a:pPr>
+            <a:r>
+              <a:rPr sz="850" b="0">
+                <a:solidFill>
+                  <a:srgbClr val="5F6368"/>
+                </a:solidFill>
+                <a:latin typeface="Google Sans Flex"/>
+              </a:rPr>
+              <a:t>Rule-driven</a:t>
+            </a:r>
+          </a:p>
+        </p:txBody>
+      </p:sp>
+      <p:sp>
+        <p:nvSpPr>
+          <p:cNvPr id="159" name="agent text"/>
+          <p:cNvSpPr txBox="1"/>
+          <p:nvPr/>
+        </p:nvSpPr>
+        <p:spPr>
+          <a:xfrm>
+            <a:off x="4709159" y="1463040"/>
+            <a:ext cx="4069080" cy="1828800"/>
+          </a:xfrm>
+          <a:prstGeom prst="rect">
+            <a:avLst/>
+          </a:prstGeom>
+          <a:noFill/>
+        </p:spPr>
+        <p:txBody>
+          <a:bodyPr wrap="square" anchor="t" lIns="36576" rIns="36576" tIns="18288" bIns="18288">
+            <a:spAutoFit/>
+          </a:bodyPr>
+          <a:lstStyle/>
+          <a:p>
+            <a:pPr algn="l">
+              <a:spcAft>
+                <a:spcPts val="300"/>
+              </a:spcAft>
+            </a:pPr>
+            <a:r>
+              <a:rPr sz="900" b="1">
+                <a:solidFill>
+                  <a:srgbClr val="1A73E8"/>
+                </a:solidFill>
+                <a:latin typeface="Google Sans Flex SemiBold"/>
+              </a:rPr>
+              <a:t>Use case: </a:t>
+            </a:r>
+            <a:r>
+              <a:rPr sz="900" b="0">
+                <a:solidFill>
+                  <a:srgbClr val="202124"/>
+                </a:solidFill>
+                <a:latin typeface="Google Sans Flex"/>
+              </a:rPr>
+              <a:t>Each plant reacts to a failure in its own way.</a:t>
+            </a:r>
+          </a:p>
+          <a:p>
+            <a:pPr algn="l">
+              <a:spcAft>
+                <a:spcPts val="300"/>
+              </a:spcAft>
+            </a:pPr>
+            <a:r>
+              <a:rPr sz="900" b="1">
+                <a:solidFill>
+                  <a:srgbClr val="B06000"/>
+                </a:solidFill>
+                <a:latin typeface="Google Sans Flex SemiBold"/>
+              </a:rPr>
+              <a:t>Solution: </a:t>
+            </a:r>
+            <a:r>
+              <a:rPr sz="900" b="0">
+                <a:solidFill>
+                  <a:srgbClr val="202124"/>
+                </a:solidFill>
+                <a:latin typeface="Google Sans Flex"/>
+              </a:rPr>
+              <a:t>The owner draws a trigger, checks, a decision and actions on a canvas. Code walks it. Warden scores any action that changes the plant.</a:t>
+            </a:r>
+          </a:p>
+          <a:p>
+            <a:pPr algn="l">
+              <a:spcAft>
+                <a:spcPts val="300"/>
+              </a:spcAft>
+            </a:pPr>
+            <a:r>
+              <a:rPr sz="900" b="1">
+                <a:solidFill>
+                  <a:srgbClr val="188038"/>
+                </a:solidFill>
+                <a:latin typeface="Google Sans Flex SemiBold"/>
+              </a:rPr>
+              <a:t>Outcomes: </a:t>
+            </a:r>
+            <a:r>
+              <a:rPr sz="900" b="0">
+                <a:solidFill>
+                  <a:srgbClr val="202124"/>
+                </a:solidFill>
+                <a:latin typeface="Google Sans Flex"/>
+              </a:rPr>
+              <a:t>A trace of every block · Actions scored by Warden</a:t>
+            </a:r>
+          </a:p>
+          <a:p>
+            <a:pPr algn="l">
+              <a:spcAft>
+                <a:spcPts val="400"/>
+              </a:spcAft>
+            </a:pPr>
+            <a:r>
+              <a:rPr sz="900" b="1">
+                <a:solidFill>
+                  <a:srgbClr val="C5221F"/>
+                </a:solidFill>
+                <a:latin typeface="Google Sans Flex SemiBold"/>
+              </a:rPr>
+              <a:t>Must never: </a:t>
+            </a:r>
+            <a:r>
+              <a:rPr sz="900" b="0">
+                <a:solidFill>
+                  <a:srgbClr val="5F6368"/>
+                </a:solidFill>
+                <a:latin typeface="Google Sans Flex"/>
+              </a:rPr>
+              <a:t>Skip Warden for an action that changes the plant</a:t>
+            </a:r>
+          </a:p>
+        </p:txBody>
+      </p:sp>
+      <p:sp>
+        <p:nvSpPr>
+          <p:cNvPr id="160" name="agent card"/>
+          <p:cNvSpPr/>
+          <p:nvPr/>
+        </p:nvSpPr>
+        <p:spPr>
+          <a:xfrm>
+            <a:off x="274320" y="3410712"/>
+            <a:ext cx="4251960" cy="1508760"/>
+          </a:xfrm>
+          <a:prstGeom prst="roundRect">
+            <a:avLst>
+              <a:gd name="adj" fmla="val 6000"/>
+            </a:avLst>
+          </a:prstGeom>
+          <a:solidFill>
+            <a:srgbClr val="F1F3F4"/>
+          </a:solidFill>
+          <a:ln>
+            <a:noFill/>
+          </a:ln>
+          <a:effectLst/>
+        </p:spPr>
+        <p:style>
+          <a:lnRef idx="1">
+            <a:schemeClr val="accent1"/>
+          </a:lnRef>
+          <a:fillRef idx="3">
+            <a:schemeClr val="accent1"/>
+          </a:fillRef>
+          <a:effectRef idx="2">
+            <a:schemeClr val="accent1"/>
+          </a:effectRef>
+          <a:fontRef idx="minor">
+            <a:schemeClr val="lt1"/>
+          </a:fontRef>
+        </p:style>
+        <p:txBody>
+          <a:bodyPr rtlCol="0" anchor="ctr"/>
+          <a:lstStyle/>
+          <a:p>
+            <a:pPr algn="ctr"/>
+          </a:p>
+        </p:txBody>
+      </p:sp>
+      <p:sp>
+        <p:nvSpPr>
+          <p:cNvPr id="161" name="agent name"/>
+          <p:cNvSpPr txBox="1"/>
+          <p:nvPr/>
+        </p:nvSpPr>
+        <p:spPr>
+          <a:xfrm>
+            <a:off x="365760" y="3456432"/>
+            <a:ext cx="2514600" cy="292608"/>
+          </a:xfrm>
+          <a:prstGeom prst="rect">
+            <a:avLst/>
+          </a:prstGeom>
+          <a:noFill/>
+        </p:spPr>
+        <p:txBody>
+          <a:bodyPr wrap="square" anchor="t" lIns="36576" rIns="36576" tIns="18288" bIns="18288">
+            <a:spAutoFit/>
+          </a:bodyPr>
+          <a:lstStyle/>
+          <a:p>
+            <a:pPr algn="l">
+              <a:spcAft>
+                <a:spcPts val="400"/>
+              </a:spcAft>
+            </a:pPr>
+            <a:r>
+              <a:rPr sz="1300" b="1">
+                <a:solidFill>
+                  <a:srgbClr val="1A73E8"/>
+                </a:solidFill>
+                <a:latin typeface="Google Sans Flex SemiBold"/>
+              </a:rPr>
+              <a:t>Channels</a:t>
+            </a:r>
+          </a:p>
+        </p:txBody>
+      </p:sp>
+      <p:sp>
+        <p:nvSpPr>
+          <p:cNvPr id="162" name="agent mode"/>
+          <p:cNvSpPr txBox="1"/>
+          <p:nvPr/>
+        </p:nvSpPr>
+        <p:spPr>
+          <a:xfrm>
+            <a:off x="2834640" y="3483864"/>
+            <a:ext cx="1600200" cy="237744"/>
+          </a:xfrm>
+          <a:prstGeom prst="rect">
+            <a:avLst/>
+          </a:prstGeom>
+          <a:noFill/>
+        </p:spPr>
+        <p:txBody>
+          <a:bodyPr wrap="square" anchor="t" lIns="36576" rIns="36576" tIns="18288" bIns="18288">
+            <a:spAutoFit/>
+          </a:bodyPr>
+          <a:lstStyle/>
+          <a:p>
+            <a:pPr algn="r">
+              <a:spcAft>
+                <a:spcPts val="400"/>
+              </a:spcAft>
+            </a:pPr>
+            <a:r>
+              <a:rPr sz="850" b="0">
+                <a:solidFill>
+                  <a:srgbClr val="5F6368"/>
+                </a:solidFill>
+                <a:latin typeface="Google Sans Flex"/>
+              </a:rPr>
+              <a:t>Rule-driven</a:t>
+            </a:r>
+          </a:p>
+        </p:txBody>
+      </p:sp>
+      <p:sp>
+        <p:nvSpPr>
+          <p:cNvPr id="163" name="agent text"/>
+          <p:cNvSpPr txBox="1"/>
+          <p:nvPr/>
+        </p:nvSpPr>
+        <p:spPr>
+          <a:xfrm>
+            <a:off x="365760" y="3776472"/>
+            <a:ext cx="4069080" cy="1097280"/>
+          </a:xfrm>
+          <a:prstGeom prst="rect">
+            <a:avLst/>
+          </a:prstGeom>
+          <a:noFill/>
+        </p:spPr>
+        <p:txBody>
+          <a:bodyPr wrap="square" anchor="t" lIns="36576" rIns="36576" tIns="18288" bIns="18288">
+            <a:spAutoFit/>
+          </a:bodyPr>
+          <a:lstStyle/>
+          <a:p>
+            <a:pPr algn="l">
+              <a:spcAft>
+                <a:spcPts val="300"/>
+              </a:spcAft>
+            </a:pPr>
+            <a:r>
+              <a:rPr sz="900" b="1">
+                <a:solidFill>
+                  <a:srgbClr val="1A73E8"/>
+                </a:solidFill>
+                <a:latin typeface="Google Sans Flex SemiBold"/>
+              </a:rPr>
+              <a:t>Use case: </a:t>
+            </a:r>
+            <a:r>
+              <a:rPr sz="900" b="0">
+                <a:solidFill>
+                  <a:srgbClr val="202124"/>
+                </a:solidFill>
+                <a:latin typeface="Google Sans Flex"/>
+              </a:rPr>
+              <a:t>A person who is not in the app must still know when to approve.</a:t>
+            </a:r>
+          </a:p>
+          <a:p>
+            <a:pPr algn="l">
+              <a:spcAft>
+                <a:spcPts val="300"/>
+              </a:spcAft>
+            </a:pPr>
+            <a:r>
+              <a:rPr sz="900" b="1">
+                <a:solidFill>
+                  <a:srgbClr val="B06000"/>
+                </a:solidFill>
+                <a:latin typeface="Google Sans Flex SemiBold"/>
+              </a:rPr>
+              <a:t>Solution: </a:t>
+            </a:r>
+            <a:r>
+              <a:rPr sz="900" b="0">
+                <a:solidFill>
+                  <a:srgbClr val="202124"/>
+                </a:solidFill>
+                <a:latin typeface="Google Sans Flex"/>
+              </a:rPr>
+              <a:t>Warden messages Slack, Teams, Discord, Telegram or a webhook. Addresses stay on the server. Private addresses are refused.</a:t>
+            </a:r>
+          </a:p>
+          <a:p>
+            <a:pPr algn="l">
+              <a:spcAft>
+                <a:spcPts val="300"/>
+              </a:spcAft>
+            </a:pPr>
+            <a:r>
+              <a:rPr sz="900" b="1">
+                <a:solidFill>
+                  <a:srgbClr val="188038"/>
+                </a:solidFill>
+                <a:latin typeface="Google Sans Flex SemiBold"/>
+              </a:rPr>
+              <a:t>Outcomes: </a:t>
+            </a:r>
+            <a:r>
+              <a:rPr sz="900" b="0">
+                <a:solidFill>
+                  <a:srgbClr val="202124"/>
+                </a:solidFill>
+                <a:latin typeface="Google Sans Flex"/>
+              </a:rPr>
+              <a:t>Approval requests · Blocked actions · Failing rules</a:t>
+            </a:r>
+          </a:p>
+          <a:p>
+            <a:pPr algn="l">
+              <a:spcAft>
+                <a:spcPts val="400"/>
+              </a:spcAft>
+            </a:pPr>
+            <a:r>
+              <a:rPr sz="900" b="1">
+                <a:solidFill>
+                  <a:srgbClr val="C5221F"/>
+                </a:solidFill>
+                <a:latin typeface="Google Sans Flex SemiBold"/>
+              </a:rPr>
+              <a:t>Must never: </a:t>
+            </a:r>
+            <a:r>
+              <a:rPr sz="900" b="0">
+                <a:solidFill>
+                  <a:srgbClr val="5F6368"/>
+                </a:solidFill>
+                <a:latin typeface="Google Sans Flex"/>
+              </a:rPr>
+              <a:t>Send to a private network address; Show an address back in the app</a:t>
+            </a:r>
+          </a:p>
+        </p:txBody>
+      </p:sp>
+      <p:sp>
+        <p:nvSpPr>
+          <p:cNvPr id="164" name="agent card"/>
+          <p:cNvSpPr/>
+          <p:nvPr/>
+        </p:nvSpPr>
+        <p:spPr>
+          <a:xfrm>
+            <a:off x="4617720" y="3410712"/>
+            <a:ext cx="4251960" cy="1508760"/>
+          </a:xfrm>
+          <a:prstGeom prst="roundRect">
+            <a:avLst>
+              <a:gd name="adj" fmla="val 6000"/>
+            </a:avLst>
+          </a:prstGeom>
+          <a:solidFill>
+            <a:srgbClr val="F1F3F4"/>
+          </a:solidFill>
+          <a:ln>
+            <a:noFill/>
+          </a:ln>
+          <a:effectLst/>
+        </p:spPr>
+        <p:style>
+          <a:lnRef idx="1">
+            <a:schemeClr val="accent1"/>
+          </a:lnRef>
+          <a:fillRef idx="3">
+            <a:schemeClr val="accent1"/>
+          </a:fillRef>
+          <a:effectRef idx="2">
+            <a:schemeClr val="accent1"/>
+          </a:effectRef>
+          <a:fontRef idx="minor">
+            <a:schemeClr val="lt1"/>
+          </a:fontRef>
+        </p:style>
+        <p:txBody>
+          <a:bodyPr rtlCol="0" anchor="ctr"/>
+          <a:lstStyle/>
+          <a:p>
+            <a:pPr algn="ctr"/>
+          </a:p>
+        </p:txBody>
+      </p:sp>
+      <p:sp>
+        <p:nvSpPr>
+          <p:cNvPr id="165" name="agent name"/>
+          <p:cNvSpPr txBox="1"/>
+          <p:nvPr/>
+        </p:nvSpPr>
+        <p:spPr>
+          <a:xfrm>
+            <a:off x="4709159" y="3456432"/>
+            <a:ext cx="2514600" cy="292608"/>
+          </a:xfrm>
+          <a:prstGeom prst="rect">
+            <a:avLst/>
+          </a:prstGeom>
+          <a:noFill/>
+        </p:spPr>
+        <p:txBody>
+          <a:bodyPr wrap="square" anchor="t" lIns="36576" rIns="36576" tIns="18288" bIns="18288">
+            <a:spAutoFit/>
+          </a:bodyPr>
+          <a:lstStyle/>
+          <a:p>
+            <a:pPr algn="l">
+              <a:spcAft>
+                <a:spcPts val="400"/>
+              </a:spcAft>
+            </a:pPr>
+            <a:r>
+              <a:rPr sz="1300" b="1">
+                <a:solidFill>
+                  <a:srgbClr val="1A73E8"/>
+                </a:solidFill>
+                <a:latin typeface="Google Sans Flex SemiBold"/>
+              </a:rPr>
+              <a:t>Layout editor</a:t>
+            </a:r>
+          </a:p>
+        </p:txBody>
+      </p:sp>
+      <p:sp>
+        <p:nvSpPr>
+          <p:cNvPr id="166" name="agent mode"/>
+          <p:cNvSpPr txBox="1"/>
+          <p:nvPr/>
+        </p:nvSpPr>
+        <p:spPr>
+          <a:xfrm>
+            <a:off x="7178040" y="3483864"/>
+            <a:ext cx="1600200" cy="237744"/>
+          </a:xfrm>
+          <a:prstGeom prst="rect">
+            <a:avLst/>
+          </a:prstGeom>
+          <a:noFill/>
+        </p:spPr>
+        <p:txBody>
+          <a:bodyPr wrap="square" anchor="t" lIns="36576" rIns="36576" tIns="18288" bIns="18288">
+            <a:spAutoFit/>
+          </a:bodyPr>
+          <a:lstStyle/>
+          <a:p>
+            <a:pPr algn="r">
+              <a:spcAft>
+                <a:spcPts val="400"/>
+              </a:spcAft>
+            </a:pPr>
+            <a:r>
+              <a:rPr sz="850" b="0">
+                <a:solidFill>
+                  <a:srgbClr val="5F6368"/>
+                </a:solidFill>
+                <a:latin typeface="Google Sans Flex"/>
+              </a:rPr>
+              <a:t>Rule-driven</a:t>
+            </a:r>
+          </a:p>
+        </p:txBody>
+      </p:sp>
+      <p:sp>
+        <p:nvSpPr>
+          <p:cNvPr id="167" name="agent text"/>
+          <p:cNvSpPr txBox="1"/>
+          <p:nvPr/>
+        </p:nvSpPr>
+        <p:spPr>
+          <a:xfrm>
+            <a:off x="4709159" y="3776472"/>
+            <a:ext cx="4069080" cy="1097280"/>
+          </a:xfrm>
+          <a:prstGeom prst="rect">
+            <a:avLst/>
+          </a:prstGeom>
+          <a:noFill/>
+        </p:spPr>
+        <p:txBody>
+          <a:bodyPr wrap="square" anchor="t" lIns="36576" rIns="36576" tIns="18288" bIns="18288">
+            <a:spAutoFit/>
+          </a:bodyPr>
+          <a:lstStyle/>
+          <a:p>
+            <a:pPr algn="l">
+              <a:spcAft>
+                <a:spcPts val="300"/>
+              </a:spcAft>
+            </a:pPr>
+            <a:r>
+              <a:rPr sz="900" b="1">
+                <a:solidFill>
+                  <a:srgbClr val="1A73E8"/>
+                </a:solidFill>
+                <a:latin typeface="Google Sans Flex SemiBold"/>
+              </a:rPr>
+              <a:t>Use case: </a:t>
+            </a:r>
+            <a:r>
+              <a:rPr sz="900" b="0">
+                <a:solidFill>
+                  <a:srgbClr val="202124"/>
+                </a:solidFill>
+                <a:latin typeface="Google Sans Flex"/>
+              </a:rPr>
+              <a:t>The drawn floor is never exactly right.</a:t>
+            </a:r>
+          </a:p>
+          <a:p>
+            <a:pPr algn="l">
+              <a:spcAft>
+                <a:spcPts val="300"/>
+              </a:spcAft>
+            </a:pPr>
+            <a:r>
+              <a:rPr sz="900" b="1">
+                <a:solidFill>
+                  <a:srgbClr val="B06000"/>
+                </a:solidFill>
+                <a:latin typeface="Google Sans Flex SemiBold"/>
+              </a:rPr>
+              <a:t>Solution: </a:t>
+            </a:r>
+            <a:r>
+              <a:rPr sz="900" b="0">
+                <a:solidFill>
+                  <a:srgbClr val="202124"/>
+                </a:solidFill>
+                <a:latin typeface="Google Sans Flex"/>
+              </a:rPr>
+              <a:t>A node canvas next to the live floor: move, add and delete stations, rename them, and draw how parts flow. Every change is saved at once and the plan and 3D view follow.</a:t>
+            </a:r>
+          </a:p>
+          <a:p>
+            <a:pPr algn="l">
+              <a:spcAft>
+                <a:spcPts val="300"/>
+              </a:spcAft>
+            </a:pPr>
+            <a:r>
+              <a:rPr sz="900" b="1">
+                <a:solidFill>
+                  <a:srgbClr val="188038"/>
+                </a:solidFill>
+                <a:latin typeface="Google Sans Flex SemiBold"/>
+              </a:rPr>
+              <a:t>Outcomes: </a:t>
+            </a:r>
+            <a:r>
+              <a:rPr sz="900" b="0">
+                <a:solidFill>
+                  <a:srgbClr val="202124"/>
+                </a:solidFill>
+                <a:latin typeface="Google Sans Flex"/>
+              </a:rPr>
+              <a:t>Moved, added or deleted stations · Part flows between stations</a:t>
+            </a:r>
+          </a:p>
+          <a:p>
+            <a:pPr algn="l">
+              <a:spcAft>
+                <a:spcPts val="400"/>
+              </a:spcAft>
+            </a:pPr>
+            <a:r>
+              <a:rPr sz="900" b="1">
+                <a:solidFill>
+                  <a:srgbClr val="C5221F"/>
+                </a:solidFill>
+                <a:latin typeface="Google Sans Flex SemiBold"/>
+              </a:rPr>
+              <a:t>Must never: </a:t>
+            </a:r>
+            <a:r>
+              <a:rPr sz="900" b="0">
+                <a:solidFill>
+                  <a:srgbClr val="5F6368"/>
+                </a:solidFill>
+                <a:latin typeface="Google Sans Flex"/>
+              </a:rPr>
+              <a:t>Change data or limits</a:t>
+            </a:r>
+          </a:p>
+        </p:txBody>
+      </p:sp>
+    </p:spTree>
+  </p:cSld>
+  <p:clrMapOvr>
+    <a:masterClrMapping/>
+  </p:clrMapOvr>
+</p:sld>
+</file>
+
 <file path=ppt/slides/slide3.xml><?xml version="1.0" encoding="utf-8"?>
 <p:sld xmlns:a="http://schemas.openxmlformats.org/drawingml/2006/main" xmlns:r="http://schemas.openxmlformats.org/officeDocument/2006/relationships" xmlns:mc="http://schemas.openxmlformats.org/markup-compatibility/2006" xmlns:mv="urn:schemas-microsoft-com:mac:vml" xmlns:p="http://schemas.openxmlformats.org/presentationml/2006/main" xmlns:c="http://schemas.openxmlformats.org/drawingml/2006/chart" xmlns:dgm="http://schemas.openxmlformats.org/drawingml/2006/diagram" xmlns:o="urn:schemas-microsoft-com:office:office" xmlns:v="urn:schemas-microsoft-com:vml" xmlns:pvml="urn:schemas-microsoft-com:office:powerpoint" xmlns:com="http://schemas.openxmlformats.org/drawingml/2006/compatibility" xmlns:p14="http://schemas.microsoft.com/office/powerpoint/2010/main" xmlns:p15="http://schemas.microsoft.com/office/powerpoint/2012/main" xmlns:ahyp="http://schemas.microsoft.com/office/drawing/2018/hyperlinkcolor">
   <p:cSld>

</xml_diff>

<commit_message>
Submission deck: new 2D and 3D shots of the demo plant, larger snapshot layout
</commit_message>
<xml_diff>
--- a/submission/Tolerance - AI Builder Cup submission.pptx
+++ b/submission/Tolerance - AI Builder Cup submission.pptx
@@ -8187,7 +8187,7 @@
       </p:sp>
       <p:pic>
         <p:nvPicPr>
-          <p:cNvPr id="136" name="screen" descr="floor_plan.png"/>
+          <p:cNvPr id="136" name="Floor in 2D" descr="floor_plan.png"/>
           <p:cNvPicPr>
             <a:picLocks noChangeAspect="1"/>
           </p:cNvPicPr>
@@ -8201,8 +8201,8 @@
         </p:blipFill>
         <p:spPr>
           <a:xfrm>
-            <a:off x="416773" y="1143000"/>
-            <a:ext cx="2504012" cy="1572768"/>
+            <a:off x="616007" y="1097280"/>
+            <a:ext cx="3568585" cy="2331720"/>
           </a:xfrm>
           <a:prstGeom prst="rect">
             <a:avLst/>
@@ -8222,8 +8222,8 @@
         </p:nvSpPr>
         <p:spPr>
           <a:xfrm>
-            <a:off x="274320" y="2734056"/>
-            <a:ext cx="2788920" cy="274320"/>
+            <a:off x="274320" y="3456432"/>
+            <a:ext cx="4251960" cy="274320"/>
           </a:xfrm>
           <a:prstGeom prst="rect">
             <a:avLst/>
@@ -8248,14 +8248,14 @@
                 </a:solidFill>
                 <a:latin typeface="Google Sans Flex"/>
               </a:rPr>
-              <a:t>The floor in 2D with its data feeds</a:t>
+              <a:t>The demo plant in 2D: data feeds, name tags and the status panel</a:t>
             </a:r>
           </a:p>
         </p:txBody>
       </p:sp>
       <p:pic>
         <p:nvPicPr>
-          <p:cNvPr id="138" name="screen" descr="floor_3d.png"/>
+          <p:cNvPr id="138" name="Floor in 3D" descr="floor_3d.png"/>
           <p:cNvPicPr>
             <a:picLocks noChangeAspect="1"/>
           </p:cNvPicPr>
@@ -8269,8 +8269,8 @@
         </p:blipFill>
         <p:spPr>
           <a:xfrm>
-            <a:off x="3251355" y="1143000"/>
-            <a:ext cx="2632145" cy="1572768"/>
+            <a:off x="4667011" y="1097280"/>
+            <a:ext cx="4153376" cy="2331720"/>
           </a:xfrm>
           <a:prstGeom prst="rect">
             <a:avLst/>
@@ -8290,8 +8290,8 @@
         </p:nvSpPr>
         <p:spPr>
           <a:xfrm>
-            <a:off x="3172968" y="2734056"/>
-            <a:ext cx="2788920" cy="274320"/>
+            <a:off x="4617720" y="3456432"/>
+            <a:ext cx="4251960" cy="274320"/>
           </a:xfrm>
           <a:prstGeom prst="rect">
             <a:avLst/>
@@ -8316,14 +8316,14 @@
                 </a:solidFill>
                 <a:latin typeface="Google Sans Flex"/>
               </a:rPr>
-              <a:t>The same plant in 3D</a:t>
+              <a:t>The same plant in 3D, with its data flows</a:t>
             </a:r>
           </a:p>
         </p:txBody>
       </p:sp>
       <p:pic>
         <p:nvPicPr>
-          <p:cNvPr id="140" name="screen" descr="layout_editor.png"/>
+          <p:cNvPr id="140" name="screen" descr="layout_editor_crop.png"/>
           <p:cNvPicPr>
             <a:picLocks noChangeAspect="1"/>
           </p:cNvPicPr>
@@ -8337,8 +8337,8 @@
         </p:blipFill>
         <p:spPr>
           <a:xfrm>
-            <a:off x="6214069" y="1143000"/>
-            <a:ext cx="2504012" cy="1572768"/>
+            <a:off x="875853" y="3767328"/>
+            <a:ext cx="1585853" cy="960120"/>
           </a:xfrm>
           <a:prstGeom prst="rect">
             <a:avLst/>
@@ -8358,7 +8358,7 @@
         </p:nvSpPr>
         <p:spPr>
           <a:xfrm>
-            <a:off x="6071616" y="2734056"/>
+            <a:off x="274320" y="4736592"/>
             <a:ext cx="2788920" cy="274320"/>
           </a:xfrm>
           <a:prstGeom prst="rect">
@@ -8405,8 +8405,8 @@
         </p:blipFill>
         <p:spPr>
           <a:xfrm>
-            <a:off x="274320" y="3121352"/>
-            <a:ext cx="2788920" cy="1456542"/>
+            <a:off x="3648231" y="3767328"/>
+            <a:ext cx="1838393" cy="960120"/>
           </a:xfrm>
           <a:prstGeom prst="rect">
             <a:avLst/>
@@ -8426,7 +8426,7 @@
         </p:nvSpPr>
         <p:spPr>
           <a:xfrm>
-            <a:off x="274320" y="4654296"/>
+            <a:off x="3172968" y="4736592"/>
             <a:ext cx="2788920" cy="274320"/>
           </a:xfrm>
           <a:prstGeom prst="rect">
@@ -8473,8 +8473,8 @@
         </p:blipFill>
         <p:spPr>
           <a:xfrm>
-            <a:off x="3315421" y="3063240"/>
-            <a:ext cx="2504012" cy="1572768"/>
+            <a:off x="6701769" y="3767328"/>
+            <a:ext cx="1528612" cy="960120"/>
           </a:xfrm>
           <a:prstGeom prst="rect">
             <a:avLst/>
@@ -8494,7 +8494,7 @@
         </p:nvSpPr>
         <p:spPr>
           <a:xfrm>
-            <a:off x="3172968" y="4654296"/>
+            <a:off x="6071616" y="4736592"/>
             <a:ext cx="2788920" cy="274320"/>
           </a:xfrm>
           <a:prstGeom prst="rect">
@@ -8521,74 +8521,6 @@
                 <a:latin typeface="Google Sans Flex"/>
               </a:rPr>
               <a:t>Sentinel rules</a:t>
-            </a:r>
-          </a:p>
-        </p:txBody>
-      </p:sp>
-      <p:pic>
-        <p:nvPicPr>
-          <p:cNvPr id="146" name="screen" descr="agents.png"/>
-          <p:cNvPicPr>
-            <a:picLocks noChangeAspect="1"/>
-          </p:cNvPicPr>
-          <p:nvPr/>
-        </p:nvPicPr>
-        <p:blipFill>
-          <a:blip r:embed="rId10"/>
-          <a:stretch>
-            <a:fillRect/>
-          </a:stretch>
-        </p:blipFill>
-        <p:spPr>
-          <a:xfrm>
-            <a:off x="6156638" y="3063240"/>
-            <a:ext cx="2618875" cy="1572767"/>
-          </a:xfrm>
-          <a:prstGeom prst="rect">
-            <a:avLst/>
-          </a:prstGeom>
-          <a:ln w="9525">
-            <a:solidFill>
-              <a:srgbClr val="DADCE0"/>
-            </a:solidFill>
-          </a:ln>
-        </p:spPr>
-      </p:pic>
-      <p:sp>
-        <p:nvSpPr>
-          <p:cNvPr id="147" name="caption"/>
-          <p:cNvSpPr txBox="1"/>
-          <p:nvPr/>
-        </p:nvSpPr>
-        <p:spPr>
-          <a:xfrm>
-            <a:off x="6071616" y="4654296"/>
-            <a:ext cx="2788920" cy="274320"/>
-          </a:xfrm>
-          <a:prstGeom prst="rect">
-            <a:avLst/>
-          </a:prstGeom>
-          <a:noFill/>
-        </p:spPr>
-        <p:txBody>
-          <a:bodyPr wrap="square" anchor="t" lIns="36576" rIns="36576" tIns="18288" bIns="18288">
-            <a:spAutoFit/>
-          </a:bodyPr>
-          <a:lstStyle/>
-          <a:p>
-            <a:pPr algn="l">
-              <a:spcAft>
-                <a:spcPts val="400"/>
-              </a:spcAft>
-            </a:pPr>
-            <a:r>
-              <a:rPr sz="1000" b="0">
-                <a:solidFill>
-                  <a:srgbClr val="5F6368"/>
-                </a:solidFill>
-                <a:latin typeface="Google Sans Flex"/>
-              </a:rPr>
-              <a:t>The nine agents</a:t>
             </a:r>
           </a:p>
         </p:txBody>
@@ -15685,8 +15617,8 @@
         </p:blipFill>
         <p:spPr>
           <a:xfrm>
-            <a:off x="5435265" y="1188720"/>
-            <a:ext cx="3348388" cy="2103120"/>
+            <a:off x="5500098" y="1188720"/>
+            <a:ext cx="3218723" cy="2103120"/>
           </a:xfrm>
           <a:prstGeom prst="rect">
             <a:avLst/>

</xml_diff>

<commit_message>
Submission deck: add the RCAEval benchmark slide with an honest comparison
</commit_message>
<xml_diff>
--- a/submission/Tolerance - AI Builder Cup submission.pptx
+++ b/submission/Tolerance - AI Builder Cup submission.pptx
@@ -19,6 +19,7 @@
     <p:sldId id="265" r:id="rId15"/>
     <p:sldId id="266" r:id="rId16"/>
     <p:sldId id="267" r:id="rId17"/>
+    <p:sldId id="277" r:id="rId33"/>
     <p:sldId id="268" r:id="rId18"/>
     <p:sldId id="269" r:id="rId19"/>
     <p:sldId id="272" r:id="rId28"/>
@@ -293,6 +294,310 @@
     </p:ext>
   </p:extLst>
 </p:presentation>
+</file>
+
+<file path=ppt/charts/chart1.xml><?xml version="1.0" encoding="utf-8"?>
+<c:chartSpace xmlns:c="http://schemas.openxmlformats.org/drawingml/2006/chart" xmlns:a="http://schemas.openxmlformats.org/drawingml/2006/main" xmlns:r="http://schemas.openxmlformats.org/officeDocument/2006/relationships">
+  <c:date1904 val="0"/>
+  <c:chart>
+    <c:title>
+      <c:tx>
+        <c:rich>
+          <a:bodyPr/>
+          <a:lstStyle/>
+          <a:p>
+            <a:r>
+              <a:rPr sz="1100" b="1"/>
+              <a:t>Avg@5 on RE1 (metrics only), higher is better</a:t>
+            </a:r>
+          </a:p>
+        </c:rich>
+      </c:tx>
+      <c:layout/>
+      <c:overlay val="0"/>
+    </c:title>
+    <c:autoTitleDeleted val="0"/>
+    <c:plotArea>
+      <c:barChart>
+        <c:barDir val="col"/>
+        <c:grouping val="clustered"/>
+        <c:ser>
+          <c:idx val="0"/>
+          <c:order val="0"/>
+          <c:tx>
+            <c:strRef>
+              <c:f>Sheet1!$B$1</c:f>
+              <c:strCache>
+                <c:ptCount val="1"/>
+                <c:pt idx="0">
+                  <c:v>Official BARO, our run</c:v>
+                </c:pt>
+              </c:strCache>
+            </c:strRef>
+          </c:tx>
+          <c:spPr>
+            <a:solidFill>
+              <a:srgbClr val="9AA0A6"/>
+            </a:solidFill>
+          </c:spPr>
+          <c:cat>
+            <c:strRef>
+              <c:f>Sheet1!$A$2:$A$4</c:f>
+              <c:strCache>
+                <c:ptCount val="3"/>
+                <c:pt idx="0">
+                  <c:v>Online Boutique</c:v>
+                </c:pt>
+                <c:pt idx="1">
+                  <c:v>Sock Shop</c:v>
+                </c:pt>
+                <c:pt idx="2">
+                  <c:v>Train Ticket</c:v>
+                </c:pt>
+              </c:strCache>
+            </c:strRef>
+          </c:cat>
+          <c:val>
+            <c:numRef>
+              <c:f>Sheet1!$B$2:$B$4</c:f>
+              <c:numCache>
+                <c:formatCode>General</c:formatCode>
+                <c:ptCount val="3"/>
+                <c:pt idx="0">
+                  <c:v>0.869</c:v>
+                </c:pt>
+                <c:pt idx="1">
+                  <c:v>0.954</c:v>
+                </c:pt>
+                <c:pt idx="2">
+                  <c:v>0.652</c:v>
+                </c:pt>
+              </c:numCache>
+            </c:numRef>
+          </c:val>
+        </c:ser>
+        <c:ser>
+          <c:idx val="1"/>
+          <c:order val="1"/>
+          <c:tx>
+            <c:strRef>
+              <c:f>Sheet1!$C$1</c:f>
+              <c:strCache>
+                <c:ptCount val="1"/>
+                <c:pt idx="0">
+                  <c:v>BARO, published</c:v>
+                </c:pt>
+              </c:strCache>
+            </c:strRef>
+          </c:tx>
+          <c:spPr>
+            <a:solidFill>
+              <a:srgbClr val="BDC1C6"/>
+            </a:solidFill>
+          </c:spPr>
+          <c:cat>
+            <c:strRef>
+              <c:f>Sheet1!$A$2:$A$4</c:f>
+              <c:strCache>
+                <c:ptCount val="3"/>
+                <c:pt idx="0">
+                  <c:v>Online Boutique</c:v>
+                </c:pt>
+                <c:pt idx="1">
+                  <c:v>Sock Shop</c:v>
+                </c:pt>
+                <c:pt idx="2">
+                  <c:v>Train Ticket</c:v>
+                </c:pt>
+              </c:strCache>
+            </c:strRef>
+          </c:cat>
+          <c:val>
+            <c:numRef>
+              <c:f>Sheet1!$C$2:$C$4</c:f>
+              <c:numCache>
+                <c:formatCode>General</c:formatCode>
+                <c:ptCount val="3"/>
+                <c:pt idx="0">
+                  <c:v>0.86</c:v>
+                </c:pt>
+                <c:pt idx="1">
+                  <c:v>0.95</c:v>
+                </c:pt>
+                <c:pt idx="2">
+                  <c:v>0.79</c:v>
+                </c:pt>
+              </c:numCache>
+            </c:numRef>
+          </c:val>
+        </c:ser>
+        <c:ser>
+          <c:idx val="2"/>
+          <c:order val="2"/>
+          <c:tx>
+            <c:strRef>
+              <c:f>Sheet1!$D$1</c:f>
+              <c:strCache>
+                <c:ptCount val="1"/>
+                <c:pt idx="0">
+                  <c:v>Tolerance</c:v>
+                </c:pt>
+              </c:strCache>
+            </c:strRef>
+          </c:tx>
+          <c:spPr>
+            <a:solidFill>
+              <a:srgbClr val="1A73E8"/>
+            </a:solidFill>
+          </c:spPr>
+          <c:cat>
+            <c:strRef>
+              <c:f>Sheet1!$A$2:$A$4</c:f>
+              <c:strCache>
+                <c:ptCount val="3"/>
+                <c:pt idx="0">
+                  <c:v>Online Boutique</c:v>
+                </c:pt>
+                <c:pt idx="1">
+                  <c:v>Sock Shop</c:v>
+                </c:pt>
+                <c:pt idx="2">
+                  <c:v>Train Ticket</c:v>
+                </c:pt>
+              </c:strCache>
+            </c:strRef>
+          </c:cat>
+          <c:val>
+            <c:numRef>
+              <c:f>Sheet1!$D$2:$D$4</c:f>
+              <c:numCache>
+                <c:formatCode>General</c:formatCode>
+                <c:ptCount val="3"/>
+                <c:pt idx="0">
+                  <c:v>0.914</c:v>
+                </c:pt>
+                <c:pt idx="1">
+                  <c:v>0.976</c:v>
+                </c:pt>
+                <c:pt idx="2">
+                  <c:v>0.848</c:v>
+                </c:pt>
+              </c:numCache>
+            </c:numRef>
+          </c:val>
+        </c:ser>
+        <c:dLbls>
+          <c:numFmt formatCode="0.00" sourceLinked="0"/>
+          <c:txPr>
+            <a:bodyPr/>
+            <a:lstStyle/>
+            <a:p>
+              <a:pPr>
+                <a:defRPr sz="900"/>
+              </a:pPr>
+            </a:p>
+          </c:txPr>
+          <c:dLblPos val="outEnd"/>
+          <c:showLegendKey val="0"/>
+          <c:showVal val="1"/>
+          <c:showCatName val="0"/>
+          <c:showSerName val="0"/>
+          <c:showPercent val="0"/>
+          <c:showBubbleSize val="0"/>
+          <c:showLeaderLines val="1"/>
+        </c:dLbls>
+        <c:gapWidth val="60"/>
+        <c:axId val="-2068027336"/>
+        <c:axId val="-2113994440"/>
+      </c:barChart>
+      <c:catAx>
+        <c:axId val="-2068027336"/>
+        <c:scaling>
+          <c:orientation val="minMax"/>
+        </c:scaling>
+        <c:delete val="0"/>
+        <c:axPos val="b"/>
+        <c:majorTickMark val="out"/>
+        <c:minorTickMark val="none"/>
+        <c:tickLblPos val="nextTo"/>
+        <c:txPr>
+          <a:bodyPr/>
+          <a:lstStyle/>
+          <a:p>
+            <a:pPr>
+              <a:defRPr sz="1000"/>
+            </a:pPr>
+          </a:p>
+        </c:txPr>
+        <c:crossAx val="-2113994440"/>
+        <c:crosses val="autoZero"/>
+        <c:auto val="1"/>
+        <c:lblAlgn val="ctr"/>
+        <c:lblOffset val="100"/>
+        <c:noMultiLvlLbl val="0"/>
+      </c:catAx>
+      <c:valAx>
+        <c:axId val="-2113994440"/>
+        <c:scaling>
+          <c:max val="1.0"/>
+          <c:min val="0.5"/>
+        </c:scaling>
+        <c:delete val="0"/>
+        <c:axPos val="l"/>
+        <c:majorGridlines>
+          <c:spPr>
+            <a:ln>
+              <a:solidFill>
+                <a:srgbClr val="DADCE0"/>
+              </a:solidFill>
+            </a:ln>
+          </c:spPr>
+        </c:majorGridlines>
+        <c:majorTickMark val="out"/>
+        <c:minorTickMark val="none"/>
+        <c:tickLblPos val="nextTo"/>
+        <c:txPr>
+          <a:bodyPr/>
+          <a:lstStyle/>
+          <a:p>
+            <a:pPr>
+              <a:defRPr sz="1000"/>
+            </a:pPr>
+          </a:p>
+        </c:txPr>
+        <c:crossAx val="-2068027336"/>
+        <c:crosses val="autoZero"/>
+      </c:valAx>
+    </c:plotArea>
+    <c:legend>
+      <c:legendPos val="b"/>
+      <c:overlay val="0"/>
+      <c:txPr>
+        <a:bodyPr/>
+        <a:lstStyle/>
+        <a:p>
+          <a:pPr>
+            <a:defRPr sz="1000"/>
+          </a:pPr>
+        </a:p>
+      </c:txPr>
+    </c:legend>
+    <c:dispBlanksAs val="gap"/>
+  </c:chart>
+  <c:txPr>
+    <a:bodyPr/>
+    <a:lstStyle/>
+    <a:p>
+      <a:pPr>
+        <a:defRPr sz="1800"/>
+      </a:pPr>
+      <a:endParaRPr lang="en-US"/>
+    </a:p>
+  </c:txPr>
+  <c:externalData r:id="rId1">
+    <c:autoUpdate val="0"/>
+  </c:externalData>
+</c:chartSpace>
 </file>
 
 <file path=ppt/notesMasters/notesMaster1.xml><?xml version="1.0" encoding="utf-8"?>
@@ -15318,6 +15623,424 @@
 </p:sld>
 </file>
 
+<file path=ppt/slides/slide22.xml><?xml version="1.0" encoding="utf-8"?>
+<p:sld xmlns:a="http://schemas.openxmlformats.org/drawingml/2006/main" xmlns:r="http://schemas.openxmlformats.org/officeDocument/2006/relationships" xmlns:mc="http://schemas.openxmlformats.org/markup-compatibility/2006" xmlns:mv="urn:schemas-microsoft-com:mac:vml" xmlns:p="http://schemas.openxmlformats.org/presentationml/2006/main" xmlns:c="http://schemas.openxmlformats.org/drawingml/2006/chart" xmlns:dgm="http://schemas.openxmlformats.org/drawingml/2006/diagram" xmlns:o="urn:schemas-microsoft-com:office:office" xmlns:v="urn:schemas-microsoft-com:vml" xmlns:pvml="urn:schemas-microsoft-com:office:powerpoint" xmlns:com="http://schemas.openxmlformats.org/drawingml/2006/compatibility" xmlns:p14="http://schemas.microsoft.com/office/powerpoint/2010/main" xmlns:p15="http://schemas.microsoft.com/office/powerpoint/2012/main" xmlns:ahyp="http://schemas.microsoft.com/office/drawing/2018/hyperlinkcolor">
+  <p:cSld>
+    <p:spTree>
+      <p:nvGrpSpPr>
+        <p:cNvPr id="147" name="Shape 147"/>
+        <p:cNvGrpSpPr/>
+        <p:nvPr/>
+      </p:nvGrpSpPr>
+      <p:grpSpPr>
+        <a:xfrm>
+          <a:off x="0" y="0"/>
+          <a:ext cx="0" cy="0"/>
+          <a:chOff x="0" y="0"/>
+          <a:chExt cx="0" cy="0"/>
+        </a:xfrm>
+      </p:grpSpPr>
+      <p:pic>
+        <p:nvPicPr>
+          <p:cNvPr id="148" name="Google Shape;148;p25" title="Frame 144.png"/>
+          <p:cNvPicPr preferRelativeResize="0"/>
+          <p:nvPr/>
+        </p:nvPicPr>
+        <p:blipFill rotWithShape="1">
+          <a:blip r:embed="rId3">
+            <a:alphaModFix/>
+          </a:blip>
+          <a:srcRect b="98001" l="0" r="0" t="0"/>
+          <a:stretch/>
+        </p:blipFill>
+        <p:spPr>
+          <a:xfrm>
+            <a:off x="0" y="5093562"/>
+            <a:ext cx="9144000" cy="54275"/>
+          </a:xfrm>
+          <a:prstGeom prst="rect">
+            <a:avLst/>
+          </a:prstGeom>
+          <a:noFill/>
+          <a:ln>
+            <a:noFill/>
+          </a:ln>
+        </p:spPr>
+      </p:pic>
+      <p:pic>
+        <p:nvPicPr>
+          <p:cNvPr id="149" name="Google Shape;149;p25" title="Group 427319979.png"/>
+          <p:cNvPicPr preferRelativeResize="0"/>
+          <p:nvPr/>
+        </p:nvPicPr>
+        <p:blipFill>
+          <a:blip r:embed="rId4">
+            <a:alphaModFix/>
+          </a:blip>
+          <a:stretch>
+            <a:fillRect/>
+          </a:stretch>
+        </p:blipFill>
+        <p:spPr>
+          <a:xfrm>
+            <a:off x="0" y="1"/>
+            <a:ext cx="9144000" cy="507359"/>
+          </a:xfrm>
+          <a:prstGeom prst="rect">
+            <a:avLst/>
+          </a:prstGeom>
+          <a:noFill/>
+          <a:ln>
+            <a:noFill/>
+          </a:ln>
+        </p:spPr>
+      </p:pic>
+      <p:sp>
+        <p:nvSpPr>
+          <p:cNvPr id="150" name="Google Shape;150;p25"/>
+          <p:cNvSpPr/>
+          <p:nvPr/>
+        </p:nvSpPr>
+        <p:spPr>
+          <a:xfrm>
+            <a:off x="-29250" y="5071875"/>
+            <a:ext cx="9173400" cy="97800"/>
+          </a:xfrm>
+          <a:prstGeom prst="rect">
+            <a:avLst/>
+          </a:prstGeom>
+          <a:solidFill>
+            <a:schemeClr val="dk1"/>
+          </a:solidFill>
+          <a:ln>
+            <a:noFill/>
+          </a:ln>
+        </p:spPr>
+        <p:txBody>
+          <a:bodyPr anchorCtr="0" anchor="ctr" bIns="91425" lIns="91425" spcFirstLastPara="1" rIns="91425" wrap="square" tIns="91425">
+            <a:noAutofit/>
+          </a:bodyPr>
+          <a:lstStyle/>
+          <a:p>
+            <a:pPr indent="0" lvl="0" marL="0" rtl="0" algn="ctr">
+              <a:spcBef>
+                <a:spcPts val="0"/>
+              </a:spcBef>
+              <a:spcAft>
+                <a:spcPts val="0"/>
+              </a:spcAft>
+              <a:buNone/>
+            </a:pPr>
+            <a:r>
+              <a:t/>
+            </a:r>
+            <a:endParaRPr/>
+          </a:p>
+        </p:txBody>
+      </p:sp>
+      <p:sp>
+        <p:nvSpPr>
+          <p:cNvPr id="151" name="Google Shape;151;p25"/>
+          <p:cNvSpPr txBox="1"/>
+          <p:nvPr/>
+        </p:nvSpPr>
+        <p:spPr>
+          <a:xfrm>
+            <a:off x="265350" y="663825"/>
+            <a:ext cx="8943000" cy="502920"/>
+          </a:xfrm>
+          <a:prstGeom prst="rect">
+            <a:avLst/>
+          </a:prstGeom>
+          <a:noFill/>
+          <a:ln>
+            <a:noFill/>
+          </a:ln>
+        </p:spPr>
+        <p:txBody>
+          <a:bodyPr anchorCtr="0" anchor="t" bIns="91425" lIns="91425" spcFirstLastPara="1" rIns="91425" wrap="square" tIns="91425">
+            <a:noAutofit/>
+          </a:bodyPr>
+          <a:lstStyle/>
+          <a:p>
+            <a:pPr indent="0" lvl="0" marL="0" rtl="0" algn="l">
+              <a:spcBef>
+                <a:spcPts val="0"/>
+              </a:spcBef>
+              <a:spcAft>
+                <a:spcPts val="0"/>
+              </a:spcAft>
+              <a:buNone/>
+            </a:pPr>
+            <a:r>
+              <a:rPr lang="en-GB" sz="1600">
+                <a:latin typeface="Google Sans Flex Medium"/>
+                <a:ea typeface="Google Sans Flex Medium"/>
+                <a:cs typeface="Google Sans Flex Medium"/>
+                <a:sym typeface="Google Sans Flex Medium"/>
+              </a:rPr>
+              <a:t>Benchmarking: finding the root cause on RCAEval</a:t>
+            </a:r>
+            <a:endParaRPr sz="1600">
+              <a:latin typeface="Google Sans Flex Medium"/>
+              <a:ea typeface="Google Sans Flex Medium"/>
+              <a:cs typeface="Google Sans Flex Medium"/>
+              <a:sym typeface="Google Sans Flex Medium"/>
+            </a:endParaRPr>
+          </a:p>
+        </p:txBody>
+      </p:sp>
+      <p:graphicFrame>
+        <p:nvGraphicFramePr>
+          <p:cNvPr id="152" name="RCAEval chart"/>
+          <p:cNvGraphicFramePr>
+            <a:graphicFrameLocks noGrp="1"/>
+          </p:cNvGraphicFramePr>
+          <p:nvPr/>
+        </p:nvGraphicFramePr>
+        <p:xfrm>
+          <a:off x="274320" y="1143000"/>
+          <a:ext cx="5394960" cy="3246120"/>
+        </p:xfrm>
+        <a:graphic>
+          <a:graphicData uri="http://schemas.openxmlformats.org/drawingml/2006/chart">
+            <c:chart r:id="rId2"/>
+          </a:graphicData>
+        </a:graphic>
+      </p:graphicFrame>
+      <p:sp>
+        <p:nvSpPr>
+          <p:cNvPr id="153" name="benchmark notes"/>
+          <p:cNvSpPr txBox="1"/>
+          <p:nvPr/>
+        </p:nvSpPr>
+        <p:spPr>
+          <a:xfrm>
+            <a:off x="5852160" y="1143000"/>
+            <a:ext cx="3017520" cy="3291840"/>
+          </a:xfrm>
+          <a:prstGeom prst="rect">
+            <a:avLst/>
+          </a:prstGeom>
+          <a:noFill/>
+        </p:spPr>
+        <p:txBody>
+          <a:bodyPr wrap="square" anchor="t" lIns="36576" rIns="36576" tIns="18288" bIns="18288">
+            <a:spAutoFit/>
+          </a:bodyPr>
+          <a:lstStyle/>
+          <a:p>
+            <a:pPr algn="l">
+              <a:spcAft>
+                <a:spcPts val="400"/>
+              </a:spcAft>
+            </a:pPr>
+            <a:r>
+              <a:rPr sz="1200" b="1">
+                <a:solidFill>
+                  <a:srgbClr val="1A73E8"/>
+                </a:solidFill>
+                <a:latin typeface="Google Sans Flex SemiBold"/>
+              </a:rPr>
+              <a:t>What this is</a:t>
+            </a:r>
+          </a:p>
+          <a:p>
+            <a:pPr algn="l" marL="164592" indent="-164592">
+              <a:spcAft>
+                <a:spcPts val="400"/>
+              </a:spcAft>
+              <a:buChar char="•"/>
+            </a:pPr>
+            <a:r>
+              <a:rPr sz="1050" b="0">
+                <a:solidFill>
+                  <a:srgbClr val="202124"/>
+                </a:solidFill>
+                <a:latin typeface="Google Sans Flex"/>
+              </a:rPr>
+              <a:t>Real fault-injection cases on three microservice systems. We use RCAEval's own scorer and the authors' own BARO code, unmodified.</a:t>
+            </a:r>
+          </a:p>
+          <a:p>
+            <a:pPr algn="l" marL="164592" indent="-164592">
+              <a:spcAft>
+                <a:spcPts val="400"/>
+              </a:spcAft>
+              <a:buChar char="•"/>
+            </a:pPr>
+            <a:r>
+              <a:rPr sz="1050" b="0">
+                <a:solidFill>
+                  <a:srgbClr val="202124"/>
+                </a:solidFill>
+                <a:latin typeface="Google Sans Flex"/>
+              </a:rPr>
+              <a:t>Our harness reproduces the paper on Online Boutique and Sock Shop. Train Ticket does not (0.652 against the paper's 0.79).</a:t>
+            </a:r>
+          </a:p>
+          <a:p>
+            <a:pPr algn="l" marL="164592" indent="-164592">
+              <a:spcAft>
+                <a:spcPts val="800"/>
+              </a:spcAft>
+              <a:buChar char="•"/>
+            </a:pPr>
+            <a:r>
+              <a:rPr sz="1050" b="0">
+                <a:solidFill>
+                  <a:srgbClr val="202124"/>
+                </a:solidFill>
+                <a:latin typeface="Google Sans Flex"/>
+              </a:rPr>
+              <a:t>Gemini is not used for these numbers.</a:t>
+            </a:r>
+          </a:p>
+          <a:p>
+            <a:pPr algn="l">
+              <a:spcAft>
+                <a:spcPts val="400"/>
+              </a:spcAft>
+            </a:pPr>
+            <a:r>
+              <a:rPr sz="1200" b="1">
+                <a:solidFill>
+                  <a:srgbClr val="C5221F"/>
+                </a:solidFill>
+                <a:latin typeface="Google Sans Flex SemiBold"/>
+              </a:rPr>
+              <a:t>Where we do not win</a:t>
+            </a:r>
+          </a:p>
+          <a:p>
+            <a:pPr algn="l" marL="164592" indent="-164592">
+              <a:spcAft>
+                <a:spcPts val="400"/>
+              </a:spcAft>
+              <a:buChar char="•"/>
+            </a:pPr>
+            <a:r>
+              <a:rPr sz="1050" b="0">
+                <a:solidFill>
+                  <a:srgbClr val="202124"/>
+                </a:solidFill>
+                <a:latin typeface="Google Sans Flex"/>
+              </a:rPr>
+              <a:t>On RE3 (code-level faults) the result is mixed: with weights tuned out of sample we win 1 of 3 systems.</a:t>
+            </a:r>
+          </a:p>
+          <a:p>
+            <a:pPr algn="l" marL="164592" indent="-164592">
+              <a:spcAft>
+                <a:spcPts val="400"/>
+              </a:spcAft>
+              <a:buChar char="•"/>
+            </a:pPr>
+            <a:r>
+              <a:rPr sz="1050" b="0">
+                <a:solidFill>
+                  <a:srgbClr val="202124"/>
+                </a:solidFill>
+                <a:latin typeface="Google Sans Flex"/>
+              </a:rPr>
+              <a:t>With out-of-sample fusion, Train Ticket on RE1 falls to 0.744, below the published 0.79.</a:t>
+            </a:r>
+          </a:p>
+        </p:txBody>
+      </p:sp>
+      <p:sp>
+        <p:nvSpPr>
+          <p:cNvPr id="154" name="benchmark banner"/>
+          <p:cNvSpPr/>
+          <p:nvPr/>
+        </p:nvSpPr>
+        <p:spPr>
+          <a:xfrm>
+            <a:off x="274320" y="4480560"/>
+            <a:ext cx="8595360" cy="411480"/>
+          </a:xfrm>
+          <a:prstGeom prst="roundRect">
+            <a:avLst>
+              <a:gd name="adj" fmla="val 6000"/>
+            </a:avLst>
+          </a:prstGeom>
+          <a:solidFill>
+            <a:srgbClr val="E8F0FE"/>
+          </a:solidFill>
+          <a:ln>
+            <a:noFill/>
+          </a:ln>
+          <a:effectLst/>
+        </p:spPr>
+        <p:style>
+          <a:lnRef idx="1">
+            <a:schemeClr val="accent1"/>
+          </a:lnRef>
+          <a:fillRef idx="3">
+            <a:schemeClr val="accent1"/>
+          </a:fillRef>
+          <a:effectRef idx="2">
+            <a:schemeClr val="accent1"/>
+          </a:effectRef>
+          <a:fontRef idx="minor">
+            <a:schemeClr val="lt1"/>
+          </a:fontRef>
+        </p:style>
+        <p:txBody>
+          <a:bodyPr rtlCol="0" anchor="ctr"/>
+          <a:lstStyle/>
+          <a:p>
+            <a:pPr algn="ctr"/>
+          </a:p>
+        </p:txBody>
+      </p:sp>
+      <p:sp>
+        <p:nvSpPr>
+          <p:cNvPr id="155" name="benchmark banner text"/>
+          <p:cNvSpPr txBox="1"/>
+          <p:nvPr/>
+        </p:nvSpPr>
+        <p:spPr>
+          <a:xfrm>
+            <a:off x="411480" y="4480560"/>
+            <a:ext cx="8321040" cy="411480"/>
+          </a:xfrm>
+          <a:prstGeom prst="rect">
+            <a:avLst/>
+          </a:prstGeom>
+          <a:noFill/>
+        </p:spPr>
+        <p:txBody>
+          <a:bodyPr wrap="square" anchor="ctr" lIns="36576" rIns="36576" tIns="18288" bIns="18288">
+            <a:spAutoFit/>
+          </a:bodyPr>
+          <a:lstStyle/>
+          <a:p>
+            <a:pPr algn="l">
+              <a:spcAft>
+                <a:spcPts val="400"/>
+              </a:spcAft>
+            </a:pPr>
+            <a:r>
+              <a:rPr sz="1050" b="1">
+                <a:solidFill>
+                  <a:srgbClr val="1A73E8"/>
+                </a:solidFill>
+                <a:latin typeface="Google Sans Flex SemiBold"/>
+              </a:rPr>
+              <a:t>A benchmark of software incidents, not of a factory: it tests the ranking behind Diagnosis. Everything is reproducible from the repository.</a:t>
+            </a:r>
+          </a:p>
+        </p:txBody>
+      </p:sp>
+    </p:spTree>
+  </p:cSld>
+  <p:clrMapOvr>
+    <a:masterClrMapping/>
+  </p:clrMapOvr>
+</p:sld>
+</file>
+
 <file path=ppt/slides/slide3.xml><?xml version="1.0" encoding="utf-8"?>
 <p:sld xmlns:a="http://schemas.openxmlformats.org/drawingml/2006/main" xmlns:r="http://schemas.openxmlformats.org/officeDocument/2006/relationships" xmlns:mc="http://schemas.openxmlformats.org/markup-compatibility/2006" xmlns:mv="urn:schemas-microsoft-com:mac:vml" xmlns:p="http://schemas.openxmlformats.org/presentationml/2006/main" xmlns:c="http://schemas.openxmlformats.org/drawingml/2006/chart" xmlns:dgm="http://schemas.openxmlformats.org/drawingml/2006/diagram" xmlns:o="urn:schemas-microsoft-com:office:office" xmlns:v="urn:schemas-microsoft-com:vml" xmlns:pvml="urn:schemas-microsoft-com:office:powerpoint" xmlns:com="http://schemas.openxmlformats.org/drawingml/2006/compatibility" xmlns:p14="http://schemas.microsoft.com/office/powerpoint/2010/main" xmlns:p15="http://schemas.microsoft.com/office/powerpoint/2012/main" xmlns:ahyp="http://schemas.microsoft.com/office/drawing/2018/hyperlinkcolor">
   <p:cSld>

</xml_diff>

<commit_message>
Research-style benchmarking: paired bootstrap analysis, safe-autonomy comparison, five slides in the submission deck
</commit_message>
<xml_diff>
--- a/submission/Tolerance - AI Builder Cup submission.pptx
+++ b/submission/Tolerance - AI Builder Cup submission.pptx
@@ -19,7 +19,11 @@
     <p:sldId id="265" r:id="rId15"/>
     <p:sldId id="266" r:id="rId16"/>
     <p:sldId id="267" r:id="rId17"/>
+    <p:sldId id="278" r:id="rId34"/>
     <p:sldId id="277" r:id="rId33"/>
+    <p:sldId id="279" r:id="rId35"/>
+    <p:sldId id="280" r:id="rId36"/>
+    <p:sldId id="281" r:id="rId37"/>
     <p:sldId id="268" r:id="rId18"/>
     <p:sldId id="269" r:id="rId19"/>
     <p:sldId id="272" r:id="rId28"/>
@@ -308,7 +312,7 @@
           <a:p>
             <a:r>
               <a:rPr sz="1100" b="1"/>
-              <a:t>Avg@5 on RE1 (metrics only), higher is better</a:t>
+              <a:t>Avg@5 by fault type, RE1 (about 75 cases each)</a:t>
             </a:r>
           </a:p>
         </c:rich>
@@ -330,7 +334,279 @@
               <c:strCache>
                 <c:ptCount val="1"/>
                 <c:pt idx="0">
-                  <c:v>Official BARO, our run</c:v>
+                  <c:v>BARO</c:v>
+                </c:pt>
+              </c:strCache>
+            </c:strRef>
+          </c:tx>
+          <c:spPr>
+            <a:solidFill>
+              <a:srgbClr val="9AA0A6"/>
+            </a:solidFill>
+          </c:spPr>
+          <c:cat>
+            <c:strRef>
+              <c:f>Sheet1!$A$2:$A$6</c:f>
+              <c:strCache>
+                <c:ptCount val="5"/>
+                <c:pt idx="0">
+                  <c:v>CPU</c:v>
+                </c:pt>
+                <c:pt idx="1">
+                  <c:v>Memory</c:v>
+                </c:pt>
+                <c:pt idx="2">
+                  <c:v>Disk</c:v>
+                </c:pt>
+                <c:pt idx="3">
+                  <c:v>Delay</c:v>
+                </c:pt>
+                <c:pt idx="4">
+                  <c:v>Loss</c:v>
+                </c:pt>
+              </c:strCache>
+            </c:strRef>
+          </c:cat>
+          <c:val>
+            <c:numRef>
+              <c:f>Sheet1!$B$2:$B$6</c:f>
+              <c:numCache>
+                <c:formatCode>General</c:formatCode>
+                <c:ptCount val="5"/>
+                <c:pt idx="0">
+                  <c:v>0.9108108108108107</c:v>
+                </c:pt>
+                <c:pt idx="1">
+                  <c:v>0.9840000000000001</c:v>
+                </c:pt>
+                <c:pt idx="2">
+                  <c:v>0.9066666666666665</c:v>
+                </c:pt>
+                <c:pt idx="3">
+                  <c:v>0.8293333333333333</c:v>
+                </c:pt>
+                <c:pt idx="4">
+                  <c:v>0.5918918918918918</c:v>
+                </c:pt>
+              </c:numCache>
+            </c:numRef>
+          </c:val>
+        </c:ser>
+        <c:ser>
+          <c:idx val="1"/>
+          <c:order val="1"/>
+          <c:tx>
+            <c:strRef>
+              <c:f>Sheet1!$C$1</c:f>
+              <c:strCache>
+                <c:ptCount val="1"/>
+                <c:pt idx="0">
+                  <c:v>Tolerance</c:v>
+                </c:pt>
+              </c:strCache>
+            </c:strRef>
+          </c:tx>
+          <c:spPr>
+            <a:solidFill>
+              <a:srgbClr val="1A73E8"/>
+            </a:solidFill>
+          </c:spPr>
+          <c:cat>
+            <c:strRef>
+              <c:f>Sheet1!$A$2:$A$6</c:f>
+              <c:strCache>
+                <c:ptCount val="5"/>
+                <c:pt idx="0">
+                  <c:v>CPU</c:v>
+                </c:pt>
+                <c:pt idx="1">
+                  <c:v>Memory</c:v>
+                </c:pt>
+                <c:pt idx="2">
+                  <c:v>Disk</c:v>
+                </c:pt>
+                <c:pt idx="3">
+                  <c:v>Delay</c:v>
+                </c:pt>
+                <c:pt idx="4">
+                  <c:v>Loss</c:v>
+                </c:pt>
+              </c:strCache>
+            </c:strRef>
+          </c:cat>
+          <c:val>
+            <c:numRef>
+              <c:f>Sheet1!$C$2:$C$6</c:f>
+              <c:numCache>
+                <c:formatCode>General</c:formatCode>
+                <c:ptCount val="5"/>
+                <c:pt idx="0">
+                  <c:v>0.991891891891892</c:v>
+                </c:pt>
+                <c:pt idx="1">
+                  <c:v>0.9786666666666668</c:v>
+                </c:pt>
+                <c:pt idx="2">
+                  <c:v>0.968</c:v>
+                </c:pt>
+                <c:pt idx="3">
+                  <c:v>0.8453333333333333</c:v>
+                </c:pt>
+                <c:pt idx="4">
+                  <c:v>0.835135135135135</c:v>
+                </c:pt>
+              </c:numCache>
+            </c:numRef>
+          </c:val>
+        </c:ser>
+        <c:dLbls>
+          <c:numFmt formatCode="0.00" sourceLinked="0"/>
+          <c:txPr>
+            <a:bodyPr/>
+            <a:lstStyle/>
+            <a:p>
+              <a:pPr>
+                <a:defRPr sz="900"/>
+              </a:pPr>
+            </a:p>
+          </c:txPr>
+          <c:showLegendKey val="0"/>
+          <c:showVal val="1"/>
+          <c:showCatName val="0"/>
+          <c:showSerName val="0"/>
+          <c:showPercent val="0"/>
+          <c:showBubbleSize val="0"/>
+          <c:showLeaderLines val="1"/>
+        </c:dLbls>
+        <c:gapWidth val="60"/>
+        <c:axId val="-2068027336"/>
+        <c:axId val="-2113994440"/>
+      </c:barChart>
+      <c:catAx>
+        <c:axId val="-2068027336"/>
+        <c:scaling>
+          <c:orientation val="minMax"/>
+        </c:scaling>
+        <c:delete val="0"/>
+        <c:axPos val="b"/>
+        <c:majorTickMark val="out"/>
+        <c:minorTickMark val="none"/>
+        <c:tickLblPos val="nextTo"/>
+        <c:txPr>
+          <a:bodyPr/>
+          <a:lstStyle/>
+          <a:p>
+            <a:pPr>
+              <a:defRPr sz="1000"/>
+            </a:pPr>
+          </a:p>
+        </c:txPr>
+        <c:crossAx val="-2113994440"/>
+        <c:crosses val="autoZero"/>
+        <c:auto val="1"/>
+        <c:lblAlgn val="ctr"/>
+        <c:lblOffset val="100"/>
+        <c:noMultiLvlLbl val="0"/>
+      </c:catAx>
+      <c:valAx>
+        <c:axId val="-2113994440"/>
+        <c:scaling>
+          <c:max val="1.0"/>
+          <c:min val="0.5"/>
+        </c:scaling>
+        <c:delete val="0"/>
+        <c:axPos val="l"/>
+        <c:majorGridlines>
+          <c:spPr>
+            <a:ln>
+              <a:solidFill>
+                <a:srgbClr val="DADCE0"/>
+              </a:solidFill>
+            </a:ln>
+          </c:spPr>
+        </c:majorGridlines>
+        <c:majorTickMark val="out"/>
+        <c:minorTickMark val="none"/>
+        <c:tickLblPos val="nextTo"/>
+        <c:txPr>
+          <a:bodyPr/>
+          <a:lstStyle/>
+          <a:p>
+            <a:pPr>
+              <a:defRPr sz="1000"/>
+            </a:pPr>
+          </a:p>
+        </c:txPr>
+        <c:crossAx val="-2068027336"/>
+        <c:crosses val="autoZero"/>
+      </c:valAx>
+    </c:plotArea>
+    <c:legend>
+      <c:legendPos val="b"/>
+      <c:overlay val="0"/>
+      <c:txPr>
+        <a:bodyPr/>
+        <a:lstStyle/>
+        <a:p>
+          <a:pPr>
+            <a:defRPr sz="1000"/>
+          </a:pPr>
+        </a:p>
+      </c:txPr>
+    </c:legend>
+    <c:dispBlanksAs val="gap"/>
+  </c:chart>
+  <c:txPr>
+    <a:bodyPr/>
+    <a:lstStyle/>
+    <a:p>
+      <a:pPr>
+        <a:defRPr sz="1800"/>
+      </a:pPr>
+      <a:endParaRPr lang="en-US"/>
+    </a:p>
+  </c:txPr>
+  <c:externalData r:id="rId1">
+    <c:autoUpdate val="0"/>
+  </c:externalData>
+</c:chartSpace>
+</file>
+
+<file path=ppt/charts/chart2.xml><?xml version="1.0" encoding="utf-8"?>
+<c:chartSpace xmlns:c="http://schemas.openxmlformats.org/drawingml/2006/chart" xmlns:a="http://schemas.openxmlformats.org/drawingml/2006/main" xmlns:r="http://schemas.openxmlformats.org/officeDocument/2006/relationships">
+  <c:date1904 val="0"/>
+  <c:chart>
+    <c:title>
+      <c:tx>
+        <c:rich>
+          <a:bodyPr/>
+          <a:lstStyle/>
+          <a:p>
+            <a:r>
+              <a:rPr sz="1100" b="1"/>
+              <a:t>Avg@5 on RE3 (30 cases per system)</a:t>
+            </a:r>
+          </a:p>
+        </c:rich>
+      </c:tx>
+      <c:layout/>
+      <c:overlay val="0"/>
+    </c:title>
+    <c:autoTitleDeleted val="0"/>
+    <c:plotArea>
+      <c:barChart>
+        <c:barDir val="col"/>
+        <c:grouping val="clustered"/>
+        <c:ser>
+          <c:idx val="0"/>
+          <c:order val="0"/>
+          <c:tx>
+            <c:strRef>
+              <c:f>Sheet1!$B$1</c:f>
+              <c:strCache>
+                <c:ptCount val="1"/>
+                <c:pt idx="0">
+                  <c:v>BARO</c:v>
                 </c:pt>
               </c:strCache>
             </c:strRef>
@@ -364,13 +640,13 @@
                 <c:formatCode>General</c:formatCode>
                 <c:ptCount val="3"/>
                 <c:pt idx="0">
-                  <c:v>0.869</c:v>
+                  <c:v>0.7333333333333335</c:v>
                 </c:pt>
                 <c:pt idx="1">
-                  <c:v>0.954</c:v>
+                  <c:v>0.7133333333333335</c:v>
                 </c:pt>
                 <c:pt idx="2">
-                  <c:v>0.652</c:v>
+                  <c:v>0.94</c:v>
                 </c:pt>
               </c:numCache>
             </c:numRef>
@@ -385,14 +661,14 @@
               <c:strCache>
                 <c:ptCount val="1"/>
                 <c:pt idx="0">
-                  <c:v>BARO, published</c:v>
+                  <c:v>Tolerance, metrics only</c:v>
                 </c:pt>
               </c:strCache>
             </c:strRef>
           </c:tx>
           <c:spPr>
             <a:solidFill>
-              <a:srgbClr val="BDC1C6"/>
+              <a:srgbClr val="F28B82"/>
             </a:solidFill>
           </c:spPr>
           <c:cat>
@@ -419,13 +695,13 @@
                 <c:formatCode>General</c:formatCode>
                 <c:ptCount val="3"/>
                 <c:pt idx="0">
-                  <c:v>0.86</c:v>
+                  <c:v>0.7133333333333334</c:v>
                 </c:pt>
                 <c:pt idx="1">
-                  <c:v>0.95</c:v>
+                  <c:v>0.56</c:v>
                 </c:pt>
                 <c:pt idx="2">
-                  <c:v>0.79</c:v>
+                  <c:v>0.06666666666666667</c:v>
                 </c:pt>
               </c:numCache>
             </c:numRef>
@@ -440,7 +716,62 @@
               <c:strCache>
                 <c:ptCount val="1"/>
                 <c:pt idx="0">
-                  <c:v>Tolerance</c:v>
+                  <c:v>Tolerance, traces and logs</c:v>
+                </c:pt>
+              </c:strCache>
+            </c:strRef>
+          </c:tx>
+          <c:spPr>
+            <a:solidFill>
+              <a:srgbClr val="8AB4F8"/>
+            </a:solidFill>
+          </c:spPr>
+          <c:cat>
+            <c:strRef>
+              <c:f>Sheet1!$A$2:$A$4</c:f>
+              <c:strCache>
+                <c:ptCount val="3"/>
+                <c:pt idx="0">
+                  <c:v>Online Boutique</c:v>
+                </c:pt>
+                <c:pt idx="1">
+                  <c:v>Sock Shop</c:v>
+                </c:pt>
+                <c:pt idx="2">
+                  <c:v>Train Ticket</c:v>
+                </c:pt>
+              </c:strCache>
+            </c:strRef>
+          </c:cat>
+          <c:val>
+            <c:numRef>
+              <c:f>Sheet1!$D$2:$D$4</c:f>
+              <c:numCache>
+                <c:formatCode>General</c:formatCode>
+                <c:ptCount val="3"/>
+                <c:pt idx="0">
+                  <c:v>0.6466666666666666</c:v>
+                </c:pt>
+                <c:pt idx="1">
+                  <c:v>0.8333333333333335</c:v>
+                </c:pt>
+                <c:pt idx="2">
+                  <c:v>0.8333333333333334</c:v>
+                </c:pt>
+              </c:numCache>
+            </c:numRef>
+          </c:val>
+        </c:ser>
+        <c:ser>
+          <c:idx val="3"/>
+          <c:order val="3"/>
+          <c:tx>
+            <c:strRef>
+              <c:f>Sheet1!$E$1</c:f>
+              <c:strCache>
+                <c:ptCount val="1"/>
+                <c:pt idx="0">
+                  <c:v>BARO + Tolerance + traces + logs</c:v>
                 </c:pt>
               </c:strCache>
             </c:strRef>
@@ -469,18 +800,18 @@
           </c:cat>
           <c:val>
             <c:numRef>
-              <c:f>Sheet1!$D$2:$D$4</c:f>
+              <c:f>Sheet1!$E$2:$E$4</c:f>
               <c:numCache>
                 <c:formatCode>General</c:formatCode>
                 <c:ptCount val="3"/>
                 <c:pt idx="0">
-                  <c:v>0.914</c:v>
+                  <c:v>0.6666666666666665</c:v>
                 </c:pt>
                 <c:pt idx="1">
-                  <c:v>0.976</c:v>
+                  <c:v>0.9066666666666667</c:v>
                 </c:pt>
                 <c:pt idx="2">
-                  <c:v>0.848</c:v>
+                  <c:v>0.9666666666666667</c:v>
                 </c:pt>
               </c:numCache>
             </c:numRef>
@@ -493,11 +824,10 @@
             <a:lstStyle/>
             <a:p>
               <a:pPr>
-                <a:defRPr sz="900"/>
+                <a:defRPr sz="800"/>
               </a:pPr>
             </a:p>
           </c:txPr>
-          <c:dLblPos val="outEnd"/>
           <c:showLegendKey val="0"/>
           <c:showVal val="1"/>
           <c:showCatName val="0"/>
@@ -506,7 +836,7 @@
           <c:showBubbleSize val="0"/>
           <c:showLeaderLines val="1"/>
         </c:dLbls>
-        <c:gapWidth val="60"/>
+        <c:gapWidth val="50"/>
         <c:axId val="-2068027336"/>
         <c:axId val="-2113994440"/>
       </c:barChart>
@@ -540,7 +870,7 @@
         <c:axId val="-2113994440"/>
         <c:scaling>
           <c:max val="1.0"/>
-          <c:min val="0.5"/>
+          <c:min val="0.0"/>
         </c:scaling>
         <c:delete val="0"/>
         <c:axPos val="l"/>
@@ -583,6 +913,647 @@
       </c:txPr>
     </c:legend>
     <c:dispBlanksAs val="gap"/>
+  </c:chart>
+  <c:txPr>
+    <a:bodyPr/>
+    <a:lstStyle/>
+    <a:p>
+      <a:pPr>
+        <a:defRPr sz="1800"/>
+      </a:pPr>
+      <a:endParaRPr lang="en-US"/>
+    </a:p>
+  </c:txPr>
+  <c:externalData r:id="rId1">
+    <c:autoUpdate val="0"/>
+  </c:externalData>
+</c:chartSpace>
+</file>
+
+<file path=ppt/charts/chart3.xml><?xml version="1.0" encoding="utf-8"?>
+<c:chartSpace xmlns:c="http://schemas.openxmlformats.org/drawingml/2006/chart" xmlns:a="http://schemas.openxmlformats.org/drawingml/2006/main" xmlns:r="http://schemas.openxmlformats.org/officeDocument/2006/relationships">
+  <c:date1904 val="0"/>
+  <c:chart>
+    <c:title>
+      <c:tx>
+        <c:rich>
+          <a:bodyPr/>
+          <a:lstStyle/>
+          <a:p>
+            <a:r>
+              <a:rPr sz="1100" b="1"/>
+              <a:t>Harm grows as more is run alone</a:t>
+            </a:r>
+          </a:p>
+        </c:rich>
+      </c:tx>
+      <c:layout/>
+      <c:overlay val="0"/>
+    </c:title>
+    <c:autoTitleDeleted val="0"/>
+    <c:plotArea>
+      <c:lineChart>
+        <c:grouping val="standard"/>
+        <c:varyColors val="0"/>
+        <c:ser>
+          <c:idx val="0"/>
+          <c:order val="0"/>
+          <c:tx>
+            <c:strRef>
+              <c:f>Sheet1!$B$1</c:f>
+              <c:strCache>
+                <c:ptCount val="1"/>
+                <c:pt idx="0">
+                  <c:v>Confidence only</c:v>
+                </c:pt>
+              </c:strCache>
+            </c:strRef>
+          </c:tx>
+          <c:spPr>
+            <a:ln w="28575">
+              <a:solidFill>
+                <a:srgbClr val="9AA0A6"/>
+              </a:solidFill>
+            </a:ln>
+          </c:spPr>
+          <c:marker>
+            <c:symbol val="none"/>
+          </c:marker>
+          <c:cat>
+            <c:strRef>
+              <c:f>Sheet1!$A$2:$A$21</c:f>
+              <c:strCache>
+                <c:ptCount val="20"/>
+                <c:pt idx="0">
+                  <c:v>5</c:v>
+                </c:pt>
+                <c:pt idx="1">
+                  <c:v>10</c:v>
+                </c:pt>
+                <c:pt idx="2">
+                  <c:v>15</c:v>
+                </c:pt>
+                <c:pt idx="3">
+                  <c:v>20</c:v>
+                </c:pt>
+                <c:pt idx="4">
+                  <c:v>25</c:v>
+                </c:pt>
+                <c:pt idx="5">
+                  <c:v>30</c:v>
+                </c:pt>
+                <c:pt idx="6">
+                  <c:v>35</c:v>
+                </c:pt>
+                <c:pt idx="7">
+                  <c:v>40</c:v>
+                </c:pt>
+                <c:pt idx="8">
+                  <c:v>45</c:v>
+                </c:pt>
+                <c:pt idx="9">
+                  <c:v>50</c:v>
+                </c:pt>
+                <c:pt idx="10">
+                  <c:v>55</c:v>
+                </c:pt>
+                <c:pt idx="11">
+                  <c:v>60</c:v>
+                </c:pt>
+                <c:pt idx="12">
+                  <c:v>65</c:v>
+                </c:pt>
+                <c:pt idx="13">
+                  <c:v>70</c:v>
+                </c:pt>
+                <c:pt idx="14">
+                  <c:v>75</c:v>
+                </c:pt>
+                <c:pt idx="15">
+                  <c:v>80</c:v>
+                </c:pt>
+                <c:pt idx="16">
+                  <c:v>85</c:v>
+                </c:pt>
+                <c:pt idx="17">
+                  <c:v>90</c:v>
+                </c:pt>
+                <c:pt idx="18">
+                  <c:v>95</c:v>
+                </c:pt>
+                <c:pt idx="19">
+                  <c:v>100</c:v>
+                </c:pt>
+              </c:strCache>
+            </c:strRef>
+          </c:cat>
+          <c:val>
+            <c:numRef>
+              <c:f>Sheet1!$B$2:$B$21</c:f>
+              <c:numCache>
+                <c:formatCode>General</c:formatCode>
+                <c:ptCount val="20"/>
+                <c:pt idx="0">
+                  <c:v>0.0</c:v>
+                </c:pt>
+                <c:pt idx="1">
+                  <c:v>0.3</c:v>
+                </c:pt>
+                <c:pt idx="2">
+                  <c:v>0.7</c:v>
+                </c:pt>
+                <c:pt idx="3">
+                  <c:v>1.1</c:v>
+                </c:pt>
+                <c:pt idx="4">
+                  <c:v>2.4</c:v>
+                </c:pt>
+                <c:pt idx="5">
+                  <c:v>2.6</c:v>
+                </c:pt>
+                <c:pt idx="6">
+                  <c:v>2.9</c:v>
+                </c:pt>
+                <c:pt idx="7">
+                  <c:v>3.1</c:v>
+                </c:pt>
+                <c:pt idx="8">
+                  <c:v>3.3</c:v>
+                </c:pt>
+                <c:pt idx="9">
+                  <c:v>3.5</c:v>
+                </c:pt>
+                <c:pt idx="10">
+                  <c:v>3.9</c:v>
+                </c:pt>
+                <c:pt idx="11">
+                  <c:v>3.9</c:v>
+                </c:pt>
+                <c:pt idx="12">
+                  <c:v>3.9</c:v>
+                </c:pt>
+                <c:pt idx="13">
+                  <c:v>4.1</c:v>
+                </c:pt>
+                <c:pt idx="14">
+                  <c:v>4.1</c:v>
+                </c:pt>
+                <c:pt idx="15">
+                  <c:v>4.1</c:v>
+                </c:pt>
+                <c:pt idx="16">
+                  <c:v>4.3</c:v>
+                </c:pt>
+                <c:pt idx="17">
+                  <c:v>4.3</c:v>
+                </c:pt>
+                <c:pt idx="18">
+                  <c:v>4.4</c:v>
+                </c:pt>
+                <c:pt idx="19">
+                  <c:v>4.8</c:v>
+                </c:pt>
+              </c:numCache>
+            </c:numRef>
+          </c:val>
+          <c:smooth val="0"/>
+        </c:ser>
+        <c:ser>
+          <c:idx val="1"/>
+          <c:order val="1"/>
+          <c:tx>
+            <c:strRef>
+              <c:f>Sheet1!$C$1</c:f>
+              <c:strCache>
+                <c:ptCount val="1"/>
+                <c:pt idx="0">
+                  <c:v>Warden gate</c:v>
+                </c:pt>
+              </c:strCache>
+            </c:strRef>
+          </c:tx>
+          <c:spPr>
+            <a:ln w="28575">
+              <a:solidFill>
+                <a:srgbClr val="1A73E8"/>
+              </a:solidFill>
+            </a:ln>
+          </c:spPr>
+          <c:marker>
+            <c:symbol val="none"/>
+          </c:marker>
+          <c:cat>
+            <c:strRef>
+              <c:f>Sheet1!$A$2:$A$21</c:f>
+              <c:strCache>
+                <c:ptCount val="20"/>
+                <c:pt idx="0">
+                  <c:v>5</c:v>
+                </c:pt>
+                <c:pt idx="1">
+                  <c:v>10</c:v>
+                </c:pt>
+                <c:pt idx="2">
+                  <c:v>15</c:v>
+                </c:pt>
+                <c:pt idx="3">
+                  <c:v>20</c:v>
+                </c:pt>
+                <c:pt idx="4">
+                  <c:v>25</c:v>
+                </c:pt>
+                <c:pt idx="5">
+                  <c:v>30</c:v>
+                </c:pt>
+                <c:pt idx="6">
+                  <c:v>35</c:v>
+                </c:pt>
+                <c:pt idx="7">
+                  <c:v>40</c:v>
+                </c:pt>
+                <c:pt idx="8">
+                  <c:v>45</c:v>
+                </c:pt>
+                <c:pt idx="9">
+                  <c:v>50</c:v>
+                </c:pt>
+                <c:pt idx="10">
+                  <c:v>55</c:v>
+                </c:pt>
+                <c:pt idx="11">
+                  <c:v>60</c:v>
+                </c:pt>
+                <c:pt idx="12">
+                  <c:v>65</c:v>
+                </c:pt>
+                <c:pt idx="13">
+                  <c:v>70</c:v>
+                </c:pt>
+                <c:pt idx="14">
+                  <c:v>75</c:v>
+                </c:pt>
+                <c:pt idx="15">
+                  <c:v>80</c:v>
+                </c:pt>
+                <c:pt idx="16">
+                  <c:v>85</c:v>
+                </c:pt>
+                <c:pt idx="17">
+                  <c:v>90</c:v>
+                </c:pt>
+                <c:pt idx="18">
+                  <c:v>95</c:v>
+                </c:pt>
+                <c:pt idx="19">
+                  <c:v>100</c:v>
+                </c:pt>
+              </c:strCache>
+            </c:strRef>
+          </c:cat>
+          <c:val>
+            <c:numRef>
+              <c:f>Sheet1!$C$2:$C$21</c:f>
+              <c:numCache>
+                <c:formatCode>General</c:formatCode>
+                <c:ptCount val="20"/>
+                <c:pt idx="0">
+                  <c:v>0.0</c:v>
+                </c:pt>
+                <c:pt idx="1">
+                  <c:v>0.0</c:v>
+                </c:pt>
+                <c:pt idx="2">
+                  <c:v>0.0</c:v>
+                </c:pt>
+                <c:pt idx="3">
+                  <c:v>0.0</c:v>
+                </c:pt>
+                <c:pt idx="4">
+                  <c:v>0.0</c:v>
+                </c:pt>
+                <c:pt idx="5">
+                  <c:v>0.0</c:v>
+                </c:pt>
+                <c:pt idx="6">
+                  <c:v>0.0</c:v>
+                </c:pt>
+                <c:pt idx="7">
+                  <c:v>0.0</c:v>
+                </c:pt>
+                <c:pt idx="8">
+                  <c:v>0.0</c:v>
+                </c:pt>
+                <c:pt idx="9">
+                  <c:v>0.0</c:v>
+                </c:pt>
+                <c:pt idx="10">
+                  <c:v>0.0</c:v>
+                </c:pt>
+                <c:pt idx="11">
+                  <c:v>0.1</c:v>
+                </c:pt>
+                <c:pt idx="12">
+                  <c:v>0.2</c:v>
+                </c:pt>
+                <c:pt idx="13">
+                  <c:v>0.3</c:v>
+                </c:pt>
+                <c:pt idx="14">
+                  <c:v>0.3</c:v>
+                </c:pt>
+                <c:pt idx="15">
+                  <c:v>0.7</c:v>
+                </c:pt>
+                <c:pt idx="16">
+                  <c:v>1.7</c:v>
+                </c:pt>
+                <c:pt idx="17">
+                  <c:v>3.8</c:v>
+                </c:pt>
+                <c:pt idx="18">
+                  <c:v>4.4</c:v>
+                </c:pt>
+                <c:pt idx="19">
+                  <c:v>4.8</c:v>
+                </c:pt>
+              </c:numCache>
+            </c:numRef>
+          </c:val>
+          <c:smooth val="0"/>
+        </c:ser>
+        <c:ser>
+          <c:idx val="2"/>
+          <c:order val="2"/>
+          <c:tx>
+            <c:strRef>
+              <c:f>Sheet1!$D$1</c:f>
+              <c:strCache>
+                <c:ptCount val="1"/>
+                <c:pt idx="0">
+                  <c:v>Random</c:v>
+                </c:pt>
+              </c:strCache>
+            </c:strRef>
+          </c:tx>
+          <c:spPr>
+            <a:ln w="28575">
+              <a:solidFill>
+                <a:srgbClr val="F28B82"/>
+              </a:solidFill>
+            </a:ln>
+          </c:spPr>
+          <c:marker>
+            <c:symbol val="none"/>
+          </c:marker>
+          <c:cat>
+            <c:strRef>
+              <c:f>Sheet1!$A$2:$A$21</c:f>
+              <c:strCache>
+                <c:ptCount val="20"/>
+                <c:pt idx="0">
+                  <c:v>5</c:v>
+                </c:pt>
+                <c:pt idx="1">
+                  <c:v>10</c:v>
+                </c:pt>
+                <c:pt idx="2">
+                  <c:v>15</c:v>
+                </c:pt>
+                <c:pt idx="3">
+                  <c:v>20</c:v>
+                </c:pt>
+                <c:pt idx="4">
+                  <c:v>25</c:v>
+                </c:pt>
+                <c:pt idx="5">
+                  <c:v>30</c:v>
+                </c:pt>
+                <c:pt idx="6">
+                  <c:v>35</c:v>
+                </c:pt>
+                <c:pt idx="7">
+                  <c:v>40</c:v>
+                </c:pt>
+                <c:pt idx="8">
+                  <c:v>45</c:v>
+                </c:pt>
+                <c:pt idx="9">
+                  <c:v>50</c:v>
+                </c:pt>
+                <c:pt idx="10">
+                  <c:v>55</c:v>
+                </c:pt>
+                <c:pt idx="11">
+                  <c:v>60</c:v>
+                </c:pt>
+                <c:pt idx="12">
+                  <c:v>65</c:v>
+                </c:pt>
+                <c:pt idx="13">
+                  <c:v>70</c:v>
+                </c:pt>
+                <c:pt idx="14">
+                  <c:v>75</c:v>
+                </c:pt>
+                <c:pt idx="15">
+                  <c:v>80</c:v>
+                </c:pt>
+                <c:pt idx="16">
+                  <c:v>85</c:v>
+                </c:pt>
+                <c:pt idx="17">
+                  <c:v>90</c:v>
+                </c:pt>
+                <c:pt idx="18">
+                  <c:v>95</c:v>
+                </c:pt>
+                <c:pt idx="19">
+                  <c:v>100</c:v>
+                </c:pt>
+              </c:strCache>
+            </c:strRef>
+          </c:cat>
+          <c:val>
+            <c:numRef>
+              <c:f>Sheet1!$D$2:$D$21</c:f>
+              <c:numCache>
+                <c:formatCode>General</c:formatCode>
+                <c:ptCount val="20"/>
+                <c:pt idx="0">
+                  <c:v>0.0</c:v>
+                </c:pt>
+                <c:pt idx="1">
+                  <c:v>0.2</c:v>
+                </c:pt>
+                <c:pt idx="2">
+                  <c:v>0.5</c:v>
+                </c:pt>
+                <c:pt idx="3">
+                  <c:v>0.9</c:v>
+                </c:pt>
+                <c:pt idx="4">
+                  <c:v>0.9</c:v>
+                </c:pt>
+                <c:pt idx="5">
+                  <c:v>1.1</c:v>
+                </c:pt>
+                <c:pt idx="6">
+                  <c:v>1.1</c:v>
+                </c:pt>
+                <c:pt idx="7">
+                  <c:v>1.3</c:v>
+                </c:pt>
+                <c:pt idx="8">
+                  <c:v>1.5</c:v>
+                </c:pt>
+                <c:pt idx="9">
+                  <c:v>1.9</c:v>
+                </c:pt>
+                <c:pt idx="10">
+                  <c:v>2.5</c:v>
+                </c:pt>
+                <c:pt idx="11">
+                  <c:v>3.2</c:v>
+                </c:pt>
+                <c:pt idx="12">
+                  <c:v>3.2</c:v>
+                </c:pt>
+                <c:pt idx="13">
+                  <c:v>3.6</c:v>
+                </c:pt>
+                <c:pt idx="14">
+                  <c:v>3.8</c:v>
+                </c:pt>
+                <c:pt idx="15">
+                  <c:v>3.8</c:v>
+                </c:pt>
+                <c:pt idx="16">
+                  <c:v>4.0</c:v>
+                </c:pt>
+                <c:pt idx="17">
+                  <c:v>4.0</c:v>
+                </c:pt>
+                <c:pt idx="18">
+                  <c:v>4.7</c:v>
+                </c:pt>
+                <c:pt idx="19">
+                  <c:v>4.8</c:v>
+                </c:pt>
+              </c:numCache>
+            </c:numRef>
+          </c:val>
+          <c:smooth val="0"/>
+        </c:ser>
+        <c:marker val="1"/>
+        <c:smooth val="0"/>
+        <c:axId val="2118791784"/>
+        <c:axId val="2140495176"/>
+      </c:lineChart>
+      <c:catAx>
+        <c:axId val="2118791784"/>
+        <c:scaling>
+          <c:orientation val="minMax"/>
+        </c:scaling>
+        <c:delete val="0"/>
+        <c:axPos val="b"/>
+        <c:title>
+          <c:tx>
+            <c:rich>
+              <a:bodyPr/>
+              <a:lstStyle/>
+              <a:p>
+                <a:r>
+                  <a:rPr sz="1000"/>
+                  <a:t>Share of incidents run alone (%)</a:t>
+                </a:r>
+              </a:p>
+            </c:rich>
+          </c:tx>
+          <c:layout/>
+          <c:overlay val="0"/>
+        </c:title>
+        <c:majorTickMark val="out"/>
+        <c:minorTickMark val="none"/>
+        <c:tickLblPos val="nextTo"/>
+        <c:txPr>
+          <a:bodyPr/>
+          <a:lstStyle/>
+          <a:p>
+            <a:pPr>
+              <a:defRPr sz="1000"/>
+            </a:pPr>
+          </a:p>
+        </c:txPr>
+        <c:crossAx val="2140495176"/>
+        <c:crosses val="autoZero"/>
+        <c:auto val="1"/>
+        <c:lblAlgn val="ctr"/>
+        <c:lblOffset val="100"/>
+        <c:noMultiLvlLbl val="0"/>
+      </c:catAx>
+      <c:valAx>
+        <c:axId val="2140495176"/>
+        <c:scaling/>
+        <c:delete val="0"/>
+        <c:axPos val="l"/>
+        <c:majorGridlines>
+          <c:spPr>
+            <a:ln>
+              <a:solidFill>
+                <a:srgbClr val="DADCE0"/>
+              </a:solidFill>
+            </a:ln>
+          </c:spPr>
+        </c:majorGridlines>
+        <c:title>
+          <c:tx>
+            <c:rich>
+              <a:bodyPr/>
+              <a:lstStyle/>
+              <a:p>
+                <a:r>
+                  <a:rPr sz="1000"/>
+                  <a:t>Harm of wrong actions</a:t>
+                </a:r>
+              </a:p>
+            </c:rich>
+          </c:tx>
+          <c:layout/>
+          <c:overlay val="0"/>
+        </c:title>
+        <c:majorTickMark val="out"/>
+        <c:minorTickMark val="none"/>
+        <c:tickLblPos val="nextTo"/>
+        <c:txPr>
+          <a:bodyPr/>
+          <a:lstStyle/>
+          <a:p>
+            <a:pPr>
+              <a:defRPr sz="1000"/>
+            </a:pPr>
+          </a:p>
+        </c:txPr>
+        <c:crossAx val="2118791784"/>
+        <c:crosses val="autoZero"/>
+      </c:valAx>
+    </c:plotArea>
+    <c:legend>
+      <c:legendPos val="b"/>
+      <c:layout/>
+      <c:overlay val="0"/>
+      <c:txPr>
+        <a:bodyPr/>
+        <a:lstStyle/>
+        <a:p>
+          <a:pPr>
+            <a:defRPr sz="1000"/>
+          </a:pPr>
+        </a:p>
+      </c:txPr>
+    </c:legend>
+    <c:plotVisOnly val="1"/>
+    <c:dispBlanksAs val="gap"/>
+    <c:showDLblsOverMax val="0"/>
   </c:chart>
   <c:txPr>
     <a:bodyPr/>
@@ -15779,7 +16750,7 @@
                 <a:cs typeface="Google Sans Flex Medium"/>
                 <a:sym typeface="Google Sans Flex Medium"/>
               </a:rPr>
-              <a:t>Benchmarking: finding the root cause on RCAEval</a:t>
+              <a:t>Q1: a clear gain on metric-only faults, largest for packet loss</a:t>
             </a:r>
             <a:endParaRPr sz="1600">
               <a:latin typeface="Google Sans Flex Medium"/>
@@ -15792,15 +16763,15 @@
       </p:sp>
       <p:graphicFrame>
         <p:nvGraphicFramePr>
-          <p:cNvPr id="152" name="RCAEval chart"/>
+          <p:cNvPr id="152" name="RE1 by fault chart"/>
           <p:cNvGraphicFramePr>
             <a:graphicFrameLocks noGrp="1"/>
           </p:cNvGraphicFramePr>
           <p:nvPr/>
         </p:nvGraphicFramePr>
         <p:xfrm>
-          <a:off x="274320" y="1143000"/>
-          <a:ext cx="5394960" cy="3246120"/>
+          <a:off x="274320" y="1097280"/>
+          <a:ext cx="4572000" cy="3108960"/>
         </p:xfrm>
         <a:graphic>
           <a:graphicData uri="http://schemas.openxmlformats.org/drawingml/2006/chart">
@@ -15810,14 +16781,14 @@
       </p:graphicFrame>
       <p:sp>
         <p:nvSpPr>
-          <p:cNvPr id="153" name="benchmark notes"/>
+          <p:cNvPr id="153" name="table title"/>
           <p:cNvSpPr txBox="1"/>
           <p:nvPr/>
         </p:nvSpPr>
         <p:spPr>
           <a:xfrm>
-            <a:off x="5852160" y="1143000"/>
-            <a:ext cx="3017520" cy="3291840"/>
+            <a:off x="4983480" y="1097280"/>
+            <a:ext cx="3886200" cy="274320"/>
           </a:xfrm>
           <a:prstGeom prst="rect">
             <a:avLst/>
@@ -15836,15 +16807,420 @@
               </a:spcAft>
             </a:pPr>
             <a:r>
-              <a:rPr sz="1200" b="1">
+              <a:rPr sz="1100" b="1">
                 <a:solidFill>
                   <a:srgbClr val="1A73E8"/>
                 </a:solidFill>
                 <a:latin typeface="Google Sans Flex SemiBold"/>
               </a:rPr>
-              <a:t>What this is</a:t>
-            </a:r>
-          </a:p>
+              <a:t>Difference from BARO, Avg@5 (95% interval)</a:t>
+            </a:r>
+          </a:p>
+        </p:txBody>
+      </p:sp>
+      <p:graphicFrame>
+        <p:nvGraphicFramePr>
+          <p:cNvPr id="154" name="RE1 paired table"/>
+          <p:cNvGraphicFramePr>
+            <a:graphicFrameLocks noGrp="1"/>
+          </p:cNvGraphicFramePr>
+          <p:nvPr/>
+        </p:nvGraphicFramePr>
+        <p:xfrm>
+          <a:off x="4983480" y="1417320"/>
+          <a:ext cx="3886200" cy="1371600"/>
+        </p:xfrm>
+        <a:graphic>
+          <a:graphicData uri="http://schemas.openxmlformats.org/drawingml/2006/table">
+            <a:tbl>
+              <a:tblPr firstRow="1" bandRow="1">
+                <a:tableStyleId>{5C22544A-7EE6-4342-B048-85BDC9FD1C3A}</a:tableStyleId>
+              </a:tblPr>
+              <a:tblGrid>
+                <a:gridCol w="1325880"/>
+                <a:gridCol w="457200"/>
+                <a:gridCol w="2103120"/>
+              </a:tblGrid>
+              <a:tr h="274320">
+                <a:tc>
+                  <a:txBody>
+                    <a:bodyPr/>
+                    <a:lstStyle/>
+                    <a:p>
+                      <a:pPr algn="l"/>
+                      <a:r>
+                        <a:rPr sz="1000" b="1">
+                          <a:solidFill>
+                            <a:srgbClr val="FFFFFF"/>
+                          </a:solidFill>
+                          <a:latin typeface="Google Sans Flex SemiBold"/>
+                        </a:rPr>
+                        <a:t>Subset</a:t>
+                      </a:r>
+                    </a:p>
+                  </a:txBody>
+                  <a:tcPr marL="45720" marR="45720" marT="18288" marB="18288">
+                    <a:solidFill>
+                      <a:srgbClr val="1A73E8"/>
+                    </a:solidFill>
+                  </a:tcPr>
+                </a:tc>
+                <a:tc>
+                  <a:txBody>
+                    <a:bodyPr/>
+                    <a:lstStyle/>
+                    <a:p>
+                      <a:pPr algn="ctr"/>
+                      <a:r>
+                        <a:rPr sz="1000" b="1">
+                          <a:solidFill>
+                            <a:srgbClr val="FFFFFF"/>
+                          </a:solidFill>
+                          <a:latin typeface="Google Sans Flex SemiBold"/>
+                        </a:rPr>
+                        <a:t>n</a:t>
+                      </a:r>
+                    </a:p>
+                  </a:txBody>
+                  <a:tcPr marL="45720" marR="45720" marT="18288" marB="18288">
+                    <a:solidFill>
+                      <a:srgbClr val="1A73E8"/>
+                    </a:solidFill>
+                  </a:tcPr>
+                </a:tc>
+                <a:tc>
+                  <a:txBody>
+                    <a:bodyPr/>
+                    <a:lstStyle/>
+                    <a:p>
+                      <a:pPr algn="ctr"/>
+                      <a:r>
+                        <a:rPr sz="1000" b="1">
+                          <a:solidFill>
+                            <a:srgbClr val="FFFFFF"/>
+                          </a:solidFill>
+                          <a:latin typeface="Google Sans Flex SemiBold"/>
+                        </a:rPr>
+                        <a:t>Tolerance minus BARO</a:t>
+                      </a:r>
+                    </a:p>
+                  </a:txBody>
+                  <a:tcPr marL="45720" marR="45720" marT="18288" marB="18288">
+                    <a:solidFill>
+                      <a:srgbClr val="1A73E8"/>
+                    </a:solidFill>
+                  </a:tcPr>
+                </a:tc>
+              </a:tr>
+              <a:tr h="274320">
+                <a:tc>
+                  <a:txBody>
+                    <a:bodyPr/>
+                    <a:lstStyle/>
+                    <a:p>
+                      <a:pPr algn="l"/>
+                      <a:r>
+                        <a:rPr sz="1000" b="0">
+                          <a:solidFill>
+                            <a:srgbClr val="202124"/>
+                          </a:solidFill>
+                          <a:latin typeface="Google Sans Flex"/>
+                        </a:rPr>
+                        <a:t>all</a:t>
+                      </a:r>
+                    </a:p>
+                  </a:txBody>
+                  <a:tcPr marL="45720" marR="45720" marT="18288" marB="18288">
+                    <a:solidFill>
+                      <a:srgbClr val="FFFFFF"/>
+                    </a:solidFill>
+                  </a:tcPr>
+                </a:tc>
+                <a:tc>
+                  <a:txBody>
+                    <a:bodyPr/>
+                    <a:lstStyle/>
+                    <a:p>
+                      <a:pPr algn="ctr"/>
+                      <a:r>
+                        <a:rPr sz="1000" b="0">
+                          <a:solidFill>
+                            <a:srgbClr val="202124"/>
+                          </a:solidFill>
+                          <a:latin typeface="Google Sans Flex"/>
+                        </a:rPr>
+                        <a:t>298</a:t>
+                      </a:r>
+                    </a:p>
+                  </a:txBody>
+                  <a:tcPr marL="45720" marR="45720" marT="18288" marB="18288">
+                    <a:solidFill>
+                      <a:srgbClr val="FFFFFF"/>
+                    </a:solidFill>
+                  </a:tcPr>
+                </a:tc>
+                <a:tc>
+                  <a:txBody>
+                    <a:bodyPr/>
+                    <a:lstStyle/>
+                    <a:p>
+                      <a:pPr algn="ctr"/>
+                      <a:r>
+                        <a:rPr sz="1000" b="0">
+                          <a:solidFill>
+                            <a:srgbClr val="202124"/>
+                          </a:solidFill>
+                          <a:latin typeface="Google Sans Flex"/>
+                        </a:rPr>
+                        <a:t>+0.08  [+0.05, +0.12]</a:t>
+                      </a:r>
+                    </a:p>
+                  </a:txBody>
+                  <a:tcPr marL="45720" marR="45720" marT="18288" marB="18288">
+                    <a:solidFill>
+                      <a:srgbClr val="FFFFFF"/>
+                    </a:solidFill>
+                  </a:tcPr>
+                </a:tc>
+              </a:tr>
+              <a:tr h="274320">
+                <a:tc>
+                  <a:txBody>
+                    <a:bodyPr/>
+                    <a:lstStyle/>
+                    <a:p>
+                      <a:pPr algn="l"/>
+                      <a:r>
+                        <a:rPr sz="1000" b="0">
+                          <a:solidFill>
+                            <a:srgbClr val="202124"/>
+                          </a:solidFill>
+                          <a:latin typeface="Google Sans Flex"/>
+                        </a:rPr>
+                        <a:t>Train Ticket</a:t>
+                      </a:r>
+                    </a:p>
+                  </a:txBody>
+                  <a:tcPr marL="45720" marR="45720" marT="18288" marB="18288">
+                    <a:solidFill>
+                      <a:srgbClr val="F1F3F4"/>
+                    </a:solidFill>
+                  </a:tcPr>
+                </a:tc>
+                <a:tc>
+                  <a:txBody>
+                    <a:bodyPr/>
+                    <a:lstStyle/>
+                    <a:p>
+                      <a:pPr algn="ctr"/>
+                      <a:r>
+                        <a:rPr sz="1000" b="0">
+                          <a:solidFill>
+                            <a:srgbClr val="202124"/>
+                          </a:solidFill>
+                          <a:latin typeface="Google Sans Flex"/>
+                        </a:rPr>
+                        <a:t>100</a:t>
+                      </a:r>
+                    </a:p>
+                  </a:txBody>
+                  <a:tcPr marL="45720" marR="45720" marT="18288" marB="18288">
+                    <a:solidFill>
+                      <a:srgbClr val="F1F3F4"/>
+                    </a:solidFill>
+                  </a:tcPr>
+                </a:tc>
+                <a:tc>
+                  <a:txBody>
+                    <a:bodyPr/>
+                    <a:lstStyle/>
+                    <a:p>
+                      <a:pPr algn="ctr"/>
+                      <a:r>
+                        <a:rPr sz="1000" b="0">
+                          <a:solidFill>
+                            <a:srgbClr val="202124"/>
+                          </a:solidFill>
+                          <a:latin typeface="Google Sans Flex"/>
+                        </a:rPr>
+                        <a:t>+0.19  [+0.10, +0.27]</a:t>
+                      </a:r>
+                    </a:p>
+                  </a:txBody>
+                  <a:tcPr marL="45720" marR="45720" marT="18288" marB="18288">
+                    <a:solidFill>
+                      <a:srgbClr val="F1F3F4"/>
+                    </a:solidFill>
+                  </a:tcPr>
+                </a:tc>
+              </a:tr>
+              <a:tr h="274320">
+                <a:tc>
+                  <a:txBody>
+                    <a:bodyPr/>
+                    <a:lstStyle/>
+                    <a:p>
+                      <a:pPr algn="l"/>
+                      <a:r>
+                        <a:rPr sz="1000" b="0">
+                          <a:solidFill>
+                            <a:srgbClr val="202124"/>
+                          </a:solidFill>
+                          <a:latin typeface="Google Sans Flex"/>
+                        </a:rPr>
+                        <a:t>Online Boutique</a:t>
+                      </a:r>
+                    </a:p>
+                  </a:txBody>
+                  <a:tcPr marL="45720" marR="45720" marT="18288" marB="18288">
+                    <a:solidFill>
+                      <a:srgbClr val="FFFFFF"/>
+                    </a:solidFill>
+                  </a:tcPr>
+                </a:tc>
+                <a:tc>
+                  <a:txBody>
+                    <a:bodyPr/>
+                    <a:lstStyle/>
+                    <a:p>
+                      <a:pPr algn="ctr"/>
+                      <a:r>
+                        <a:rPr sz="1000" b="0">
+                          <a:solidFill>
+                            <a:srgbClr val="202124"/>
+                          </a:solidFill>
+                          <a:latin typeface="Google Sans Flex"/>
+                        </a:rPr>
+                        <a:t>98</a:t>
+                      </a:r>
+                    </a:p>
+                  </a:txBody>
+                  <a:tcPr marL="45720" marR="45720" marT="18288" marB="18288">
+                    <a:solidFill>
+                      <a:srgbClr val="FFFFFF"/>
+                    </a:solidFill>
+                  </a:tcPr>
+                </a:tc>
+                <a:tc>
+                  <a:txBody>
+                    <a:bodyPr/>
+                    <a:lstStyle/>
+                    <a:p>
+                      <a:pPr algn="ctr"/>
+                      <a:r>
+                        <a:rPr sz="1000" b="0">
+                          <a:solidFill>
+                            <a:srgbClr val="202124"/>
+                          </a:solidFill>
+                          <a:latin typeface="Google Sans Flex"/>
+                        </a:rPr>
+                        <a:t>+0.04  [-0.01, +0.10]</a:t>
+                      </a:r>
+                    </a:p>
+                  </a:txBody>
+                  <a:tcPr marL="45720" marR="45720" marT="18288" marB="18288">
+                    <a:solidFill>
+                      <a:srgbClr val="FFFFFF"/>
+                    </a:solidFill>
+                  </a:tcPr>
+                </a:tc>
+              </a:tr>
+              <a:tr h="274320">
+                <a:tc>
+                  <a:txBody>
+                    <a:bodyPr/>
+                    <a:lstStyle/>
+                    <a:p>
+                      <a:pPr algn="l"/>
+                      <a:r>
+                        <a:rPr sz="1000" b="0">
+                          <a:solidFill>
+                            <a:srgbClr val="202124"/>
+                          </a:solidFill>
+                          <a:latin typeface="Google Sans Flex"/>
+                        </a:rPr>
+                        <a:t>Sock Shop</a:t>
+                      </a:r>
+                    </a:p>
+                  </a:txBody>
+                  <a:tcPr marL="45720" marR="45720" marT="18288" marB="18288">
+                    <a:solidFill>
+                      <a:srgbClr val="F1F3F4"/>
+                    </a:solidFill>
+                  </a:tcPr>
+                </a:tc>
+                <a:tc>
+                  <a:txBody>
+                    <a:bodyPr/>
+                    <a:lstStyle/>
+                    <a:p>
+                      <a:pPr algn="ctr"/>
+                      <a:r>
+                        <a:rPr sz="1000" b="0">
+                          <a:solidFill>
+                            <a:srgbClr val="202124"/>
+                          </a:solidFill>
+                          <a:latin typeface="Google Sans Flex"/>
+                        </a:rPr>
+                        <a:t>100</a:t>
+                      </a:r>
+                    </a:p>
+                  </a:txBody>
+                  <a:tcPr marL="45720" marR="45720" marT="18288" marB="18288">
+                    <a:solidFill>
+                      <a:srgbClr val="F1F3F4"/>
+                    </a:solidFill>
+                  </a:tcPr>
+                </a:tc>
+                <a:tc>
+                  <a:txBody>
+                    <a:bodyPr/>
+                    <a:lstStyle/>
+                    <a:p>
+                      <a:pPr algn="ctr"/>
+                      <a:r>
+                        <a:rPr sz="1000" b="0">
+                          <a:solidFill>
+                            <a:srgbClr val="202124"/>
+                          </a:solidFill>
+                          <a:latin typeface="Google Sans Flex"/>
+                        </a:rPr>
+                        <a:t>+0.02  [-0.01, +0.05]</a:t>
+                      </a:r>
+                    </a:p>
+                  </a:txBody>
+                  <a:tcPr marL="45720" marR="45720" marT="18288" marB="18288">
+                    <a:solidFill>
+                      <a:srgbClr val="F1F3F4"/>
+                    </a:solidFill>
+                  </a:tcPr>
+                </a:tc>
+              </a:tr>
+            </a:tbl>
+          </a:graphicData>
+        </a:graphic>
+      </p:graphicFrame>
+      <p:sp>
+        <p:nvSpPr>
+          <p:cNvPr id="155" name="reading"/>
+          <p:cNvSpPr txBox="1"/>
+          <p:nvPr/>
+        </p:nvSpPr>
+        <p:spPr>
+          <a:xfrm>
+            <a:off x="4983480" y="2926080"/>
+            <a:ext cx="3886200" cy="1280160"/>
+          </a:xfrm>
+          <a:prstGeom prst="rect">
+            <a:avLst/>
+          </a:prstGeom>
+          <a:noFill/>
+        </p:spPr>
+        <p:txBody>
+          <a:bodyPr wrap="square" anchor="t" lIns="36576" rIns="36576" tIns="18288" bIns="18288">
+            <a:spAutoFit/>
+          </a:bodyPr>
+          <a:lstStyle/>
           <a:p>
             <a:pPr algn="l" marL="164592" indent="-164592">
               <a:spcAft>
@@ -15853,13 +17229,13 @@
               <a:buChar char="•"/>
             </a:pPr>
             <a:r>
-              <a:rPr sz="1050" b="0">
+              <a:rPr sz="1000" b="0">
                 <a:solidFill>
                   <a:srgbClr val="202124"/>
                 </a:solidFill>
                 <a:latin typeface="Google Sans Flex"/>
               </a:rPr>
-              <a:t>Real fault-injection cases on three microservice systems. We use RCAEval's own scorer and the authors' own BARO code, unmodified.</a:t>
+              <a:t>BARO is already at 0.96 on Sock Shop, so there is little room.</a:t>
             </a:r>
           </a:p>
           <a:p>
@@ -15870,94 +17246,61 @@
               <a:buChar char="•"/>
             </a:pPr>
             <a:r>
-              <a:rPr sz="1050" b="0">
+              <a:rPr sz="1000" b="0">
                 <a:solidFill>
                   <a:srgbClr val="202124"/>
                 </a:solidFill>
                 <a:latin typeface="Google Sans Flex"/>
               </a:rPr>
-              <a:t>Our harness reproduces the paper on Online Boutique and Sock Shop. Train Ticket does not (0.652 against the paper's 0.79).</a:t>
+              <a:t>Train Ticket is where the baseline is weakest (0.66), and where we gain most.</a:t>
             </a:r>
           </a:p>
           <a:p>
             <a:pPr algn="l" marL="164592" indent="-164592">
               <a:spcAft>
-                <a:spcPts val="800"/>
+                <a:spcPts val="400"/>
               </a:spcAft>
               <a:buChar char="•"/>
             </a:pPr>
             <a:r>
-              <a:rPr sz="1050" b="0">
+              <a:rPr sz="1000" b="0">
                 <a:solidFill>
                   <a:srgbClr val="202124"/>
                 </a:solidFill>
                 <a:latin typeface="Google Sans Flex"/>
               </a:rPr>
-              <a:t>Gemini is not used for these numbers.</a:t>
-            </a:r>
-          </a:p>
-          <a:p>
-            <a:pPr algn="l">
+              <a:t>Memory and delay: no difference.</a:t>
+            </a:r>
+          </a:p>
+          <a:p>
+            <a:pPr algn="l" marL="164592" indent="-164592">
               <a:spcAft>
                 <a:spcPts val="400"/>
               </a:spcAft>
-            </a:pPr>
-            <a:r>
-              <a:rPr sz="1200" b="1">
-                <a:solidFill>
-                  <a:srgbClr val="C5221F"/>
-                </a:solidFill>
-                <a:latin typeface="Google Sans Flex SemiBold"/>
-              </a:rPr>
-              <a:t>Where we do not win</a:t>
-            </a:r>
-          </a:p>
-          <a:p>
-            <a:pPr algn="l" marL="164592" indent="-164592">
-              <a:spcAft>
-                <a:spcPts val="400"/>
-              </a:spcAft>
               <a:buChar char="•"/>
             </a:pPr>
             <a:r>
-              <a:rPr sz="1050" b="0">
-                <a:solidFill>
-                  <a:srgbClr val="202124"/>
+              <a:rPr sz="1000" b="0">
+                <a:solidFill>
+                  <a:srgbClr val="5F6368"/>
                 </a:solidFill>
                 <a:latin typeface="Google Sans Flex"/>
               </a:rPr>
-              <a:t>On RE3 (code-level faults) the result is mixed: with weights tuned out of sample we win 1 of 3 systems.</a:t>
-            </a:r>
-          </a:p>
-          <a:p>
-            <a:pPr algn="l" marL="164592" indent="-164592">
-              <a:spcAft>
-                <a:spcPts val="400"/>
-              </a:spcAft>
-              <a:buChar char="•"/>
-            </a:pPr>
-            <a:r>
-              <a:rPr sz="1050" b="0">
-                <a:solidFill>
-                  <a:srgbClr val="202124"/>
-                </a:solidFill>
-                <a:latin typeface="Google Sans Flex"/>
-              </a:rPr>
-              <a:t>With out-of-sample fusion, Train Ticket on RE1 falls to 0.744, below the published 0.79.</a:t>
-            </a:r>
-          </a:p>
-        </p:txBody>
-      </p:sp>
-      <p:sp>
-        <p:nvSpPr>
-          <p:cNvPr id="154" name="benchmark banner"/>
+              <a:t>Pooled rows use the four faults the BARO paper reports (disk is in the chart only).</a:t>
+            </a:r>
+          </a:p>
+        </p:txBody>
+      </p:sp>
+      <p:sp>
+        <p:nvSpPr>
+          <p:cNvPr id="156" name="takeaway"/>
           <p:cNvSpPr/>
           <p:nvPr/>
         </p:nvSpPr>
         <p:spPr>
           <a:xfrm>
-            <a:off x="274320" y="4480560"/>
-            <a:ext cx="8595360" cy="411480"/>
+            <a:off x="274320" y="4315968"/>
+            <a:ext cx="8595360" cy="457200"/>
           </a:xfrm>
           <a:prstGeom prst="roundRect">
             <a:avLst>
@@ -15996,14 +17339,14 @@
       </p:sp>
       <p:sp>
         <p:nvSpPr>
-          <p:cNvPr id="155" name="benchmark banner text"/>
+          <p:cNvPr id="157" name="takeaway text"/>
           <p:cNvSpPr txBox="1"/>
           <p:nvPr/>
         </p:nvSpPr>
         <p:spPr>
           <a:xfrm>
-            <a:off x="411480" y="4480560"/>
-            <a:ext cx="8321040" cy="411480"/>
+            <a:off x="411480" y="4315968"/>
+            <a:ext cx="8321040" cy="457200"/>
           </a:xfrm>
           <a:prstGeom prst="rect">
             <a:avLst/>
@@ -16022,13 +17365,3057 @@
               </a:spcAft>
             </a:pPr>
             <a:r>
-              <a:rPr sz="1050" b="1">
+              <a:rPr sz="1100" b="1">
                 <a:solidFill>
                   <a:srgbClr val="1A73E8"/>
                 </a:solidFill>
                 <a:latin typeface="Google Sans Flex SemiBold"/>
               </a:rPr>
-              <a:t>A benchmark of software incidents, not of a factory: it tests the ranking behind Diagnosis. Everything is reproducible from the repository.</a:t>
+              <a:t>Significant on the pooled set and on Train Ticket. Borderline on Online Boutique, not significant on Sock Shop.</a:t>
+            </a:r>
+          </a:p>
+        </p:txBody>
+      </p:sp>
+    </p:spTree>
+  </p:cSld>
+  <p:clrMapOvr>
+    <a:masterClrMapping/>
+  </p:clrMapOvr>
+</p:sld>
+</file>
+
+<file path=ppt/slides/slide23.xml><?xml version="1.0" encoding="utf-8"?>
+<p:sld xmlns:a="http://schemas.openxmlformats.org/drawingml/2006/main" xmlns:r="http://schemas.openxmlformats.org/officeDocument/2006/relationships" xmlns:mc="http://schemas.openxmlformats.org/markup-compatibility/2006" xmlns:mv="urn:schemas-microsoft-com:mac:vml" xmlns:p="http://schemas.openxmlformats.org/presentationml/2006/main" xmlns:c="http://schemas.openxmlformats.org/drawingml/2006/chart" xmlns:dgm="http://schemas.openxmlformats.org/drawingml/2006/diagram" xmlns:o="urn:schemas-microsoft-com:office:office" xmlns:v="urn:schemas-microsoft-com:vml" xmlns:pvml="urn:schemas-microsoft-com:office:powerpoint" xmlns:com="http://schemas.openxmlformats.org/drawingml/2006/compatibility" xmlns:p14="http://schemas.microsoft.com/office/powerpoint/2010/main" xmlns:p15="http://schemas.microsoft.com/office/powerpoint/2012/main" xmlns:ahyp="http://schemas.microsoft.com/office/drawing/2018/hyperlinkcolor">
+  <p:cSld>
+    <p:spTree>
+      <p:nvGrpSpPr>
+        <p:cNvPr id="147" name="Shape 147"/>
+        <p:cNvGrpSpPr/>
+        <p:nvPr/>
+      </p:nvGrpSpPr>
+      <p:grpSpPr>
+        <a:xfrm>
+          <a:off x="0" y="0"/>
+          <a:ext cx="0" cy="0"/>
+          <a:chOff x="0" y="0"/>
+          <a:chExt cx="0" cy="0"/>
+        </a:xfrm>
+      </p:grpSpPr>
+      <p:pic>
+        <p:nvPicPr>
+          <p:cNvPr id="148" name="Google Shape;148;p25" title="Frame 144.png"/>
+          <p:cNvPicPr preferRelativeResize="0"/>
+          <p:nvPr/>
+        </p:nvPicPr>
+        <p:blipFill rotWithShape="1">
+          <a:blip r:embed="rId3">
+            <a:alphaModFix/>
+          </a:blip>
+          <a:srcRect b="98001" l="0" r="0" t="0"/>
+          <a:stretch/>
+        </p:blipFill>
+        <p:spPr>
+          <a:xfrm>
+            <a:off x="0" y="5093562"/>
+            <a:ext cx="9144000" cy="54275"/>
+          </a:xfrm>
+          <a:prstGeom prst="rect">
+            <a:avLst/>
+          </a:prstGeom>
+          <a:noFill/>
+          <a:ln>
+            <a:noFill/>
+          </a:ln>
+        </p:spPr>
+      </p:pic>
+      <p:pic>
+        <p:nvPicPr>
+          <p:cNvPr id="149" name="Google Shape;149;p25" title="Group 427319979.png"/>
+          <p:cNvPicPr preferRelativeResize="0"/>
+          <p:nvPr/>
+        </p:nvPicPr>
+        <p:blipFill>
+          <a:blip r:embed="rId4">
+            <a:alphaModFix/>
+          </a:blip>
+          <a:stretch>
+            <a:fillRect/>
+          </a:stretch>
+        </p:blipFill>
+        <p:spPr>
+          <a:xfrm>
+            <a:off x="0" y="1"/>
+            <a:ext cx="9144000" cy="507359"/>
+          </a:xfrm>
+          <a:prstGeom prst="rect">
+            <a:avLst/>
+          </a:prstGeom>
+          <a:noFill/>
+          <a:ln>
+            <a:noFill/>
+          </a:ln>
+        </p:spPr>
+      </p:pic>
+      <p:sp>
+        <p:nvSpPr>
+          <p:cNvPr id="150" name="Google Shape;150;p25"/>
+          <p:cNvSpPr/>
+          <p:nvPr/>
+        </p:nvSpPr>
+        <p:spPr>
+          <a:xfrm>
+            <a:off x="-29250" y="5071875"/>
+            <a:ext cx="9173400" cy="97800"/>
+          </a:xfrm>
+          <a:prstGeom prst="rect">
+            <a:avLst/>
+          </a:prstGeom>
+          <a:solidFill>
+            <a:schemeClr val="dk1"/>
+          </a:solidFill>
+          <a:ln>
+            <a:noFill/>
+          </a:ln>
+        </p:spPr>
+        <p:txBody>
+          <a:bodyPr anchorCtr="0" anchor="ctr" bIns="91425" lIns="91425" spcFirstLastPara="1" rIns="91425" wrap="square" tIns="91425">
+            <a:noAutofit/>
+          </a:bodyPr>
+          <a:lstStyle/>
+          <a:p>
+            <a:pPr indent="0" lvl="0" marL="0" rtl="0" algn="ctr">
+              <a:spcBef>
+                <a:spcPts val="0"/>
+              </a:spcBef>
+              <a:spcAft>
+                <a:spcPts val="0"/>
+              </a:spcAft>
+              <a:buNone/>
+            </a:pPr>
+            <a:r>
+              <a:t/>
+            </a:r>
+            <a:endParaRPr/>
+          </a:p>
+        </p:txBody>
+      </p:sp>
+      <p:sp>
+        <p:nvSpPr>
+          <p:cNvPr id="151" name="Google Shape;151;p25"/>
+          <p:cNvSpPr txBox="1"/>
+          <p:nvPr/>
+        </p:nvSpPr>
+        <p:spPr>
+          <a:xfrm>
+            <a:off x="265350" y="663825"/>
+            <a:ext cx="8943000" cy="502920"/>
+          </a:xfrm>
+          <a:prstGeom prst="rect">
+            <a:avLst/>
+          </a:prstGeom>
+          <a:noFill/>
+          <a:ln>
+            <a:noFill/>
+          </a:ln>
+        </p:spPr>
+        <p:txBody>
+          <a:bodyPr anchorCtr="0" anchor="t" bIns="91425" lIns="91425" spcFirstLastPara="1" rIns="91425" wrap="square" tIns="91425">
+            <a:noAutofit/>
+          </a:bodyPr>
+          <a:lstStyle/>
+          <a:p>
+            <a:pPr indent="0" lvl="0" marL="0" rtl="0" algn="l">
+              <a:spcBef>
+                <a:spcPts val="0"/>
+              </a:spcBef>
+              <a:spcAft>
+                <a:spcPts val="0"/>
+              </a:spcAft>
+              <a:buNone/>
+            </a:pPr>
+            <a:r>
+              <a:rPr lang="en-GB" sz="1600">
+                <a:latin typeface="Google Sans Flex Medium"/>
+                <a:ea typeface="Google Sans Flex Medium"/>
+                <a:cs typeface="Google Sans Flex Medium"/>
+                <a:sym typeface="Google Sans Flex Medium"/>
+              </a:rPr>
+              <a:t>Benchmark design: three questions, one protocol</a:t>
+            </a:r>
+            <a:endParaRPr sz="1600">
+              <a:latin typeface="Google Sans Flex Medium"/>
+              <a:ea typeface="Google Sans Flex Medium"/>
+              <a:cs typeface="Google Sans Flex Medium"/>
+              <a:sym typeface="Google Sans Flex Medium"/>
+            </a:endParaRPr>
+          </a:p>
+        </p:txBody>
+      </p:sp>
+      <p:sp>
+        <p:nvSpPr>
+          <p:cNvPr id="152" name="question card"/>
+          <p:cNvSpPr/>
+          <p:nvPr/>
+        </p:nvSpPr>
+        <p:spPr>
+          <a:xfrm>
+            <a:off x="274320" y="1143000"/>
+            <a:ext cx="4846320" cy="950976"/>
+          </a:xfrm>
+          <a:prstGeom prst="roundRect">
+            <a:avLst>
+              <a:gd name="adj" fmla="val 6000"/>
+            </a:avLst>
+          </a:prstGeom>
+          <a:solidFill>
+            <a:srgbClr val="F1F3F4"/>
+          </a:solidFill>
+          <a:ln>
+            <a:noFill/>
+          </a:ln>
+          <a:effectLst/>
+        </p:spPr>
+        <p:style>
+          <a:lnRef idx="1">
+            <a:schemeClr val="accent1"/>
+          </a:lnRef>
+          <a:fillRef idx="3">
+            <a:schemeClr val="accent1"/>
+          </a:fillRef>
+          <a:effectRef idx="2">
+            <a:schemeClr val="accent1"/>
+          </a:effectRef>
+          <a:fontRef idx="minor">
+            <a:schemeClr val="lt1"/>
+          </a:fontRef>
+        </p:style>
+        <p:txBody>
+          <a:bodyPr rtlCol="0" anchor="ctr"/>
+          <a:lstStyle/>
+          <a:p>
+            <a:pPr algn="ctr"/>
+          </a:p>
+        </p:txBody>
+      </p:sp>
+      <p:sp>
+        <p:nvSpPr>
+          <p:cNvPr id="153" name="question number"/>
+          <p:cNvSpPr txBox="1"/>
+          <p:nvPr/>
+        </p:nvSpPr>
+        <p:spPr>
+          <a:xfrm>
+            <a:off x="347472" y="1188720"/>
+            <a:ext cx="548640" cy="457200"/>
+          </a:xfrm>
+          <a:prstGeom prst="rect">
+            <a:avLst/>
+          </a:prstGeom>
+          <a:noFill/>
+        </p:spPr>
+        <p:txBody>
+          <a:bodyPr wrap="square" anchor="t" lIns="36576" rIns="36576" tIns="18288" bIns="18288">
+            <a:spAutoFit/>
+          </a:bodyPr>
+          <a:lstStyle/>
+          <a:p>
+            <a:pPr algn="l">
+              <a:spcAft>
+                <a:spcPts val="400"/>
+              </a:spcAft>
+            </a:pPr>
+            <a:r>
+              <a:rPr sz="1800" b="1">
+                <a:solidFill>
+                  <a:srgbClr val="1A73E8"/>
+                </a:solidFill>
+                <a:latin typeface="Google Sans Flex SemiBold"/>
+              </a:rPr>
+              <a:t>Q1</a:t>
+            </a:r>
+          </a:p>
+        </p:txBody>
+      </p:sp>
+      <p:sp>
+        <p:nvSpPr>
+          <p:cNvPr id="154" name="question text"/>
+          <p:cNvSpPr txBox="1"/>
+          <p:nvPr/>
+        </p:nvSpPr>
+        <p:spPr>
+          <a:xfrm>
+            <a:off x="914400" y="1188720"/>
+            <a:ext cx="4160520" cy="896112"/>
+          </a:xfrm>
+          <a:prstGeom prst="rect">
+            <a:avLst/>
+          </a:prstGeom>
+          <a:noFill/>
+        </p:spPr>
+        <p:txBody>
+          <a:bodyPr wrap="square" anchor="t" lIns="36576" rIns="36576" tIns="18288" bIns="18288">
+            <a:spAutoFit/>
+          </a:bodyPr>
+          <a:lstStyle/>
+          <a:p>
+            <a:pPr algn="l">
+              <a:spcAft>
+                <a:spcPts val="300"/>
+              </a:spcAft>
+            </a:pPr>
+            <a:r>
+              <a:rPr sz="1150" b="1">
+                <a:solidFill>
+                  <a:srgbClr val="202124"/>
+                </a:solidFill>
+                <a:latin typeface="Google Sans Flex SemiBold"/>
+              </a:rPr>
+              <a:t>Does the root-cause ranking beat BARO on metric-only faults?</a:t>
+            </a:r>
+          </a:p>
+          <a:p>
+            <a:pPr algn="l">
+              <a:spcAft>
+                <a:spcPts val="400"/>
+              </a:spcAft>
+            </a:pPr>
+            <a:r>
+              <a:rPr sz="1000" b="0">
+                <a:solidFill>
+                  <a:srgbClr val="5F6368"/>
+                </a:solidFill>
+                <a:latin typeface="Google Sans Flex"/>
+              </a:rPr>
+              <a:t>RCAEval RE1: 298 cases, four faults (CPU, memory, delay, loss), three systems.</a:t>
+            </a:r>
+          </a:p>
+        </p:txBody>
+      </p:sp>
+      <p:sp>
+        <p:nvSpPr>
+          <p:cNvPr id="155" name="question card"/>
+          <p:cNvSpPr/>
+          <p:nvPr/>
+        </p:nvSpPr>
+        <p:spPr>
+          <a:xfrm>
+            <a:off x="274320" y="2167128"/>
+            <a:ext cx="4846320" cy="950976"/>
+          </a:xfrm>
+          <a:prstGeom prst="roundRect">
+            <a:avLst>
+              <a:gd name="adj" fmla="val 6000"/>
+            </a:avLst>
+          </a:prstGeom>
+          <a:solidFill>
+            <a:srgbClr val="F1F3F4"/>
+          </a:solidFill>
+          <a:ln>
+            <a:noFill/>
+          </a:ln>
+          <a:effectLst/>
+        </p:spPr>
+        <p:style>
+          <a:lnRef idx="1">
+            <a:schemeClr val="accent1"/>
+          </a:lnRef>
+          <a:fillRef idx="3">
+            <a:schemeClr val="accent1"/>
+          </a:fillRef>
+          <a:effectRef idx="2">
+            <a:schemeClr val="accent1"/>
+          </a:effectRef>
+          <a:fontRef idx="minor">
+            <a:schemeClr val="lt1"/>
+          </a:fontRef>
+        </p:style>
+        <p:txBody>
+          <a:bodyPr rtlCol="0" anchor="ctr"/>
+          <a:lstStyle/>
+          <a:p>
+            <a:pPr algn="ctr"/>
+          </a:p>
+        </p:txBody>
+      </p:sp>
+      <p:sp>
+        <p:nvSpPr>
+          <p:cNvPr id="156" name="question number"/>
+          <p:cNvSpPr txBox="1"/>
+          <p:nvPr/>
+        </p:nvSpPr>
+        <p:spPr>
+          <a:xfrm>
+            <a:off x="347472" y="2212848"/>
+            <a:ext cx="548640" cy="457200"/>
+          </a:xfrm>
+          <a:prstGeom prst="rect">
+            <a:avLst/>
+          </a:prstGeom>
+          <a:noFill/>
+        </p:spPr>
+        <p:txBody>
+          <a:bodyPr wrap="square" anchor="t" lIns="36576" rIns="36576" tIns="18288" bIns="18288">
+            <a:spAutoFit/>
+          </a:bodyPr>
+          <a:lstStyle/>
+          <a:p>
+            <a:pPr algn="l">
+              <a:spcAft>
+                <a:spcPts val="400"/>
+              </a:spcAft>
+            </a:pPr>
+            <a:r>
+              <a:rPr sz="1800" b="1">
+                <a:solidFill>
+                  <a:srgbClr val="1A73E8"/>
+                </a:solidFill>
+                <a:latin typeface="Google Sans Flex SemiBold"/>
+              </a:rPr>
+              <a:t>Q2</a:t>
+            </a:r>
+          </a:p>
+        </p:txBody>
+      </p:sp>
+      <p:sp>
+        <p:nvSpPr>
+          <p:cNvPr id="157" name="question text"/>
+          <p:cNvSpPr txBox="1"/>
+          <p:nvPr/>
+        </p:nvSpPr>
+        <p:spPr>
+          <a:xfrm>
+            <a:off x="914400" y="2212848"/>
+            <a:ext cx="4160520" cy="896112"/>
+          </a:xfrm>
+          <a:prstGeom prst="rect">
+            <a:avLst/>
+          </a:prstGeom>
+          <a:noFill/>
+        </p:spPr>
+        <p:txBody>
+          <a:bodyPr wrap="square" anchor="t" lIns="36576" rIns="36576" tIns="18288" bIns="18288">
+            <a:spAutoFit/>
+          </a:bodyPr>
+          <a:lstStyle/>
+          <a:p>
+            <a:pPr algn="l">
+              <a:spcAft>
+                <a:spcPts val="300"/>
+              </a:spcAft>
+            </a:pPr>
+            <a:r>
+              <a:rPr sz="1150" b="1">
+                <a:solidFill>
+                  <a:srgbClr val="202124"/>
+                </a:solidFill>
+                <a:latin typeface="Google Sans Flex SemiBold"/>
+              </a:rPr>
+              <a:t>Does a second source (traces, logs) help on code-level faults?</a:t>
+            </a:r>
+          </a:p>
+          <a:p>
+            <a:pPr algn="l">
+              <a:spcAft>
+                <a:spcPts val="400"/>
+              </a:spcAft>
+            </a:pPr>
+            <a:r>
+              <a:rPr sz="1000" b="0">
+                <a:solidFill>
+                  <a:srgbClr val="5F6368"/>
+                </a:solidFill>
+                <a:latin typeface="Google Sans Flex"/>
+              </a:rPr>
+              <a:t>RCAEval RE3: 90 cases, five fault types, three systems.</a:t>
+            </a:r>
+          </a:p>
+        </p:txBody>
+      </p:sp>
+      <p:sp>
+        <p:nvSpPr>
+          <p:cNvPr id="158" name="question card"/>
+          <p:cNvSpPr/>
+          <p:nvPr/>
+        </p:nvSpPr>
+        <p:spPr>
+          <a:xfrm>
+            <a:off x="274320" y="3191256"/>
+            <a:ext cx="4846320" cy="950976"/>
+          </a:xfrm>
+          <a:prstGeom prst="roundRect">
+            <a:avLst>
+              <a:gd name="adj" fmla="val 6000"/>
+            </a:avLst>
+          </a:prstGeom>
+          <a:solidFill>
+            <a:srgbClr val="F1F3F4"/>
+          </a:solidFill>
+          <a:ln>
+            <a:noFill/>
+          </a:ln>
+          <a:effectLst/>
+        </p:spPr>
+        <p:style>
+          <a:lnRef idx="1">
+            <a:schemeClr val="accent1"/>
+          </a:lnRef>
+          <a:fillRef idx="3">
+            <a:schemeClr val="accent1"/>
+          </a:fillRef>
+          <a:effectRef idx="2">
+            <a:schemeClr val="accent1"/>
+          </a:effectRef>
+          <a:fontRef idx="minor">
+            <a:schemeClr val="lt1"/>
+          </a:fontRef>
+        </p:style>
+        <p:txBody>
+          <a:bodyPr rtlCol="0" anchor="ctr"/>
+          <a:lstStyle/>
+          <a:p>
+            <a:pPr algn="ctr"/>
+          </a:p>
+        </p:txBody>
+      </p:sp>
+      <p:sp>
+        <p:nvSpPr>
+          <p:cNvPr id="159" name="question number"/>
+          <p:cNvSpPr txBox="1"/>
+          <p:nvPr/>
+        </p:nvSpPr>
+        <p:spPr>
+          <a:xfrm>
+            <a:off x="347472" y="3236976"/>
+            <a:ext cx="548640" cy="457200"/>
+          </a:xfrm>
+          <a:prstGeom prst="rect">
+            <a:avLst/>
+          </a:prstGeom>
+          <a:noFill/>
+        </p:spPr>
+        <p:txBody>
+          <a:bodyPr wrap="square" anchor="t" lIns="36576" rIns="36576" tIns="18288" bIns="18288">
+            <a:spAutoFit/>
+          </a:bodyPr>
+          <a:lstStyle/>
+          <a:p>
+            <a:pPr algn="l">
+              <a:spcAft>
+                <a:spcPts val="400"/>
+              </a:spcAft>
+            </a:pPr>
+            <a:r>
+              <a:rPr sz="1800" b="1">
+                <a:solidFill>
+                  <a:srgbClr val="1A73E8"/>
+                </a:solidFill>
+                <a:latin typeface="Google Sans Flex SemiBold"/>
+              </a:rPr>
+              <a:t>Q3</a:t>
+            </a:r>
+          </a:p>
+        </p:txBody>
+      </p:sp>
+      <p:sp>
+        <p:nvSpPr>
+          <p:cNvPr id="160" name="question text"/>
+          <p:cNvSpPr txBox="1"/>
+          <p:nvPr/>
+        </p:nvSpPr>
+        <p:spPr>
+          <a:xfrm>
+            <a:off x="914400" y="3236976"/>
+            <a:ext cx="4160520" cy="896112"/>
+          </a:xfrm>
+          <a:prstGeom prst="rect">
+            <a:avLst/>
+          </a:prstGeom>
+          <a:noFill/>
+        </p:spPr>
+        <p:txBody>
+          <a:bodyPr wrap="square" anchor="t" lIns="36576" rIns="36576" tIns="18288" bIns="18288">
+            <a:spAutoFit/>
+          </a:bodyPr>
+          <a:lstStyle/>
+          <a:p>
+            <a:pPr algn="l">
+              <a:spcAft>
+                <a:spcPts val="300"/>
+              </a:spcAft>
+            </a:pPr>
+            <a:r>
+              <a:rPr sz="1150" b="1">
+                <a:solidFill>
+                  <a:srgbClr val="202124"/>
+                </a:solidFill>
+                <a:latin typeface="Google Sans Flex SemiBold"/>
+              </a:rPr>
+              <a:t>Does the safety gate bound the harm of a wrong action?</a:t>
+            </a:r>
+          </a:p>
+          <a:p>
+            <a:pPr algn="l">
+              <a:spcAft>
+                <a:spcPts val="400"/>
+              </a:spcAft>
+            </a:pPr>
+            <a:r>
+              <a:rPr sz="1000" b="0">
+                <a:solidFill>
+                  <a:srgbClr val="5F6368"/>
+                </a:solidFill>
+                <a:latin typeface="Google Sans Flex"/>
+              </a:rPr>
+              <a:t>465 recorded incidents scored by Warden, with the diagnosis marked right or wrong.</a:t>
+            </a:r>
+          </a:p>
+        </p:txBody>
+      </p:sp>
+      <p:sp>
+        <p:nvSpPr>
+          <p:cNvPr id="161" name="protocol card"/>
+          <p:cNvSpPr/>
+          <p:nvPr/>
+        </p:nvSpPr>
+        <p:spPr>
+          <a:xfrm>
+            <a:off x="5257800" y="1143000"/>
+            <a:ext cx="3611880" cy="3072384"/>
+          </a:xfrm>
+          <a:prstGeom prst="roundRect">
+            <a:avLst>
+              <a:gd name="adj" fmla="val 6000"/>
+            </a:avLst>
+          </a:prstGeom>
+          <a:solidFill>
+            <a:srgbClr val="F1F3F4"/>
+          </a:solidFill>
+          <a:ln>
+            <a:noFill/>
+          </a:ln>
+          <a:effectLst/>
+        </p:spPr>
+        <p:style>
+          <a:lnRef idx="1">
+            <a:schemeClr val="accent1"/>
+          </a:lnRef>
+          <a:fillRef idx="3">
+            <a:schemeClr val="accent1"/>
+          </a:fillRef>
+          <a:effectRef idx="2">
+            <a:schemeClr val="accent1"/>
+          </a:effectRef>
+          <a:fontRef idx="minor">
+            <a:schemeClr val="lt1"/>
+          </a:fontRef>
+        </p:style>
+        <p:txBody>
+          <a:bodyPr rtlCol="0" anchor="ctr"/>
+          <a:lstStyle/>
+          <a:p>
+            <a:pPr algn="ctr"/>
+          </a:p>
+        </p:txBody>
+      </p:sp>
+      <p:sp>
+        <p:nvSpPr>
+          <p:cNvPr id="162" name="protocol text"/>
+          <p:cNvSpPr txBox="1"/>
+          <p:nvPr/>
+        </p:nvSpPr>
+        <p:spPr>
+          <a:xfrm>
+            <a:off x="5367528" y="1188720"/>
+            <a:ext cx="3429000" cy="3017520"/>
+          </a:xfrm>
+          <a:prstGeom prst="rect">
+            <a:avLst/>
+          </a:prstGeom>
+          <a:noFill/>
+        </p:spPr>
+        <p:txBody>
+          <a:bodyPr wrap="square" anchor="t" lIns="36576" rIns="36576" tIns="18288" bIns="18288">
+            <a:spAutoFit/>
+          </a:bodyPr>
+          <a:lstStyle/>
+          <a:p>
+            <a:pPr algn="l">
+              <a:spcAft>
+                <a:spcPts val="500"/>
+              </a:spcAft>
+            </a:pPr>
+            <a:r>
+              <a:rPr sz="1200" b="1">
+                <a:solidFill>
+                  <a:srgbClr val="1A73E8"/>
+                </a:solidFill>
+                <a:latin typeface="Google Sans Flex SemiBold"/>
+              </a:rPr>
+              <a:t>Protocol</a:t>
+            </a:r>
+          </a:p>
+          <a:p>
+            <a:pPr algn="l" marL="164592" indent="-164592">
+              <a:spcAft>
+                <a:spcPts val="400"/>
+              </a:spcAft>
+              <a:buChar char="•"/>
+            </a:pPr>
+            <a:r>
+              <a:rPr sz="1000" b="0">
+                <a:solidFill>
+                  <a:srgbClr val="202124"/>
+                </a:solidFill>
+                <a:latin typeface="Google Sans Flex"/>
+              </a:rPr>
+              <a:t>Baseline: the authors' BARO code, unmodified, scored the way RCAEval scores it (Avg@5).</a:t>
+            </a:r>
+          </a:p>
+          <a:p>
+            <a:pPr algn="l" marL="164592" indent="-164592">
+              <a:spcAft>
+                <a:spcPts val="400"/>
+              </a:spcAft>
+              <a:buChar char="•"/>
+            </a:pPr>
+            <a:r>
+              <a:rPr sz="1000" b="0">
+                <a:solidFill>
+                  <a:srgbClr val="202124"/>
+                </a:solidFill>
+                <a:latin typeface="Google Sans Flex"/>
+              </a:rPr>
+              <a:t>Every interval is a 95% bootstrap over cases (10,000 resamples). Differences are paired: both methods on the same cases.</a:t>
+            </a:r>
+          </a:p>
+          <a:p>
+            <a:pPr algn="l" marL="164592" indent="-164592">
+              <a:spcAft>
+                <a:spcPts val="400"/>
+              </a:spcAft>
+              <a:buChar char="•"/>
+            </a:pPr>
+            <a:r>
+              <a:rPr sz="1000" b="0">
+                <a:solidFill>
+                  <a:srgbClr val="202124"/>
+                </a:solidFill>
+                <a:latin typeface="Google Sans Flex"/>
+              </a:rPr>
+              <a:t>The fusion constant was fixed before we looked at results. Every variant is reported, not the best one.</a:t>
+            </a:r>
+          </a:p>
+          <a:p>
+            <a:pPr algn="l" marL="164592" indent="-164592">
+              <a:spcAft>
+                <a:spcPts val="400"/>
+              </a:spcAft>
+              <a:buChar char="•"/>
+            </a:pPr>
+            <a:r>
+              <a:rPr sz="1000" b="0">
+                <a:solidFill>
+                  <a:srgbClr val="202124"/>
+                </a:solidFill>
+                <a:latin typeface="Google Sans Flex"/>
+              </a:rPr>
+              <a:t>No Gemini anywhere in Q1 and Q2. Raw per-case results and scripts are in the repository.</a:t>
+            </a:r>
+          </a:p>
+        </p:txBody>
+      </p:sp>
+      <p:sp>
+        <p:nvSpPr>
+          <p:cNvPr id="163" name="takeaway"/>
+          <p:cNvSpPr/>
+          <p:nvPr/>
+        </p:nvSpPr>
+        <p:spPr>
+          <a:xfrm>
+            <a:off x="274320" y="4315968"/>
+            <a:ext cx="8595360" cy="457200"/>
+          </a:xfrm>
+          <a:prstGeom prst="roundRect">
+            <a:avLst>
+              <a:gd name="adj" fmla="val 6000"/>
+            </a:avLst>
+          </a:prstGeom>
+          <a:solidFill>
+            <a:srgbClr val="E8F0FE"/>
+          </a:solidFill>
+          <a:ln>
+            <a:noFill/>
+          </a:ln>
+          <a:effectLst/>
+        </p:spPr>
+        <p:style>
+          <a:lnRef idx="1">
+            <a:schemeClr val="accent1"/>
+          </a:lnRef>
+          <a:fillRef idx="3">
+            <a:schemeClr val="accent1"/>
+          </a:fillRef>
+          <a:effectRef idx="2">
+            <a:schemeClr val="accent1"/>
+          </a:effectRef>
+          <a:fontRef idx="minor">
+            <a:schemeClr val="lt1"/>
+          </a:fontRef>
+        </p:style>
+        <p:txBody>
+          <a:bodyPr rtlCol="0" anchor="ctr"/>
+          <a:lstStyle/>
+          <a:p>
+            <a:pPr algn="ctr"/>
+          </a:p>
+        </p:txBody>
+      </p:sp>
+      <p:sp>
+        <p:nvSpPr>
+          <p:cNvPr id="164" name="takeaway text"/>
+          <p:cNvSpPr txBox="1"/>
+          <p:nvPr/>
+        </p:nvSpPr>
+        <p:spPr>
+          <a:xfrm>
+            <a:off x="411480" y="4315968"/>
+            <a:ext cx="8321040" cy="457200"/>
+          </a:xfrm>
+          <a:prstGeom prst="rect">
+            <a:avLst/>
+          </a:prstGeom>
+          <a:noFill/>
+        </p:spPr>
+        <p:txBody>
+          <a:bodyPr wrap="square" anchor="ctr" lIns="36576" rIns="36576" tIns="18288" bIns="18288">
+            <a:spAutoFit/>
+          </a:bodyPr>
+          <a:lstStyle/>
+          <a:p>
+            <a:pPr algn="l">
+              <a:spcAft>
+                <a:spcPts val="400"/>
+              </a:spcAft>
+            </a:pPr>
+            <a:r>
+              <a:rPr sz="1100" b="1">
+                <a:solidFill>
+                  <a:srgbClr val="1A73E8"/>
+                </a:solidFill>
+                <a:latin typeface="Google Sans Flex SemiBold"/>
+              </a:rPr>
+              <a:t>Not run, and not claimed: RCAEval RE2, the other published baselines, and the Gemini agent at scale.</a:t>
+            </a:r>
+          </a:p>
+        </p:txBody>
+      </p:sp>
+    </p:spTree>
+  </p:cSld>
+  <p:clrMapOvr>
+    <a:masterClrMapping/>
+  </p:clrMapOvr>
+</p:sld>
+</file>
+
+<file path=ppt/slides/slide24.xml><?xml version="1.0" encoding="utf-8"?>
+<p:sld xmlns:a="http://schemas.openxmlformats.org/drawingml/2006/main" xmlns:r="http://schemas.openxmlformats.org/officeDocument/2006/relationships" xmlns:mc="http://schemas.openxmlformats.org/markup-compatibility/2006" xmlns:mv="urn:schemas-microsoft-com:mac:vml" xmlns:p="http://schemas.openxmlformats.org/presentationml/2006/main" xmlns:c="http://schemas.openxmlformats.org/drawingml/2006/chart" xmlns:dgm="http://schemas.openxmlformats.org/drawingml/2006/diagram" xmlns:o="urn:schemas-microsoft-com:office:office" xmlns:v="urn:schemas-microsoft-com:vml" xmlns:pvml="urn:schemas-microsoft-com:office:powerpoint" xmlns:com="http://schemas.openxmlformats.org/drawingml/2006/compatibility" xmlns:p14="http://schemas.microsoft.com/office/powerpoint/2010/main" xmlns:p15="http://schemas.microsoft.com/office/powerpoint/2012/main" xmlns:ahyp="http://schemas.microsoft.com/office/drawing/2018/hyperlinkcolor">
+  <p:cSld>
+    <p:spTree>
+      <p:nvGrpSpPr>
+        <p:cNvPr id="147" name="Shape 147"/>
+        <p:cNvGrpSpPr/>
+        <p:nvPr/>
+      </p:nvGrpSpPr>
+      <p:grpSpPr>
+        <a:xfrm>
+          <a:off x="0" y="0"/>
+          <a:ext cx="0" cy="0"/>
+          <a:chOff x="0" y="0"/>
+          <a:chExt cx="0" cy="0"/>
+        </a:xfrm>
+      </p:grpSpPr>
+      <p:pic>
+        <p:nvPicPr>
+          <p:cNvPr id="148" name="Google Shape;148;p25" title="Frame 144.png"/>
+          <p:cNvPicPr preferRelativeResize="0"/>
+          <p:nvPr/>
+        </p:nvPicPr>
+        <p:blipFill rotWithShape="1">
+          <a:blip r:embed="rId3">
+            <a:alphaModFix/>
+          </a:blip>
+          <a:srcRect b="98001" l="0" r="0" t="0"/>
+          <a:stretch/>
+        </p:blipFill>
+        <p:spPr>
+          <a:xfrm>
+            <a:off x="0" y="5093562"/>
+            <a:ext cx="9144000" cy="54275"/>
+          </a:xfrm>
+          <a:prstGeom prst="rect">
+            <a:avLst/>
+          </a:prstGeom>
+          <a:noFill/>
+          <a:ln>
+            <a:noFill/>
+          </a:ln>
+        </p:spPr>
+      </p:pic>
+      <p:pic>
+        <p:nvPicPr>
+          <p:cNvPr id="149" name="Google Shape;149;p25" title="Group 427319979.png"/>
+          <p:cNvPicPr preferRelativeResize="0"/>
+          <p:nvPr/>
+        </p:nvPicPr>
+        <p:blipFill>
+          <a:blip r:embed="rId4">
+            <a:alphaModFix/>
+          </a:blip>
+          <a:stretch>
+            <a:fillRect/>
+          </a:stretch>
+        </p:blipFill>
+        <p:spPr>
+          <a:xfrm>
+            <a:off x="0" y="1"/>
+            <a:ext cx="9144000" cy="507359"/>
+          </a:xfrm>
+          <a:prstGeom prst="rect">
+            <a:avLst/>
+          </a:prstGeom>
+          <a:noFill/>
+          <a:ln>
+            <a:noFill/>
+          </a:ln>
+        </p:spPr>
+      </p:pic>
+      <p:sp>
+        <p:nvSpPr>
+          <p:cNvPr id="150" name="Google Shape;150;p25"/>
+          <p:cNvSpPr/>
+          <p:nvPr/>
+        </p:nvSpPr>
+        <p:spPr>
+          <a:xfrm>
+            <a:off x="-29250" y="5071875"/>
+            <a:ext cx="9173400" cy="97800"/>
+          </a:xfrm>
+          <a:prstGeom prst="rect">
+            <a:avLst/>
+          </a:prstGeom>
+          <a:solidFill>
+            <a:schemeClr val="dk1"/>
+          </a:solidFill>
+          <a:ln>
+            <a:noFill/>
+          </a:ln>
+        </p:spPr>
+        <p:txBody>
+          <a:bodyPr anchorCtr="0" anchor="ctr" bIns="91425" lIns="91425" spcFirstLastPara="1" rIns="91425" wrap="square" tIns="91425">
+            <a:noAutofit/>
+          </a:bodyPr>
+          <a:lstStyle/>
+          <a:p>
+            <a:pPr indent="0" lvl="0" marL="0" rtl="0" algn="ctr">
+              <a:spcBef>
+                <a:spcPts val="0"/>
+              </a:spcBef>
+              <a:spcAft>
+                <a:spcPts val="0"/>
+              </a:spcAft>
+              <a:buNone/>
+            </a:pPr>
+            <a:r>
+              <a:t/>
+            </a:r>
+            <a:endParaRPr/>
+          </a:p>
+        </p:txBody>
+      </p:sp>
+      <p:sp>
+        <p:nvSpPr>
+          <p:cNvPr id="151" name="Google Shape;151;p25"/>
+          <p:cNvSpPr txBox="1"/>
+          <p:nvPr/>
+        </p:nvSpPr>
+        <p:spPr>
+          <a:xfrm>
+            <a:off x="265350" y="663825"/>
+            <a:ext cx="8943000" cy="502920"/>
+          </a:xfrm>
+          <a:prstGeom prst="rect">
+            <a:avLst/>
+          </a:prstGeom>
+          <a:noFill/>
+          <a:ln>
+            <a:noFill/>
+          </a:ln>
+        </p:spPr>
+        <p:txBody>
+          <a:bodyPr anchorCtr="0" anchor="t" bIns="91425" lIns="91425" spcFirstLastPara="1" rIns="91425" wrap="square" tIns="91425">
+            <a:noAutofit/>
+          </a:bodyPr>
+          <a:lstStyle/>
+          <a:p>
+            <a:pPr indent="0" lvl="0" marL="0" rtl="0" algn="l">
+              <a:spcBef>
+                <a:spcPts val="0"/>
+              </a:spcBef>
+              <a:spcAft>
+                <a:spcPts val="0"/>
+              </a:spcAft>
+              <a:buNone/>
+            </a:pPr>
+            <a:r>
+              <a:rPr lang="en-GB" sz="1600">
+                <a:latin typeface="Google Sans Flex Medium"/>
+                <a:ea typeface="Google Sans Flex Medium"/>
+                <a:cs typeface="Google Sans Flex Medium"/>
+                <a:sym typeface="Google Sans Flex Medium"/>
+              </a:rPr>
+              <a:t>Q2: on code-level faults metrics alone fail, a second source recovers it</a:t>
+            </a:r>
+            <a:endParaRPr sz="1600">
+              <a:latin typeface="Google Sans Flex Medium"/>
+              <a:ea typeface="Google Sans Flex Medium"/>
+              <a:cs typeface="Google Sans Flex Medium"/>
+              <a:sym typeface="Google Sans Flex Medium"/>
+            </a:endParaRPr>
+          </a:p>
+        </p:txBody>
+      </p:sp>
+      <p:graphicFrame>
+        <p:nvGraphicFramePr>
+          <p:cNvPr id="152" name="RE3 chart"/>
+          <p:cNvGraphicFramePr>
+            <a:graphicFrameLocks noGrp="1"/>
+          </p:cNvGraphicFramePr>
+          <p:nvPr/>
+        </p:nvGraphicFramePr>
+        <p:xfrm>
+          <a:off x="274320" y="1097280"/>
+          <a:ext cx="4754880" cy="3154680"/>
+        </p:xfrm>
+        <a:graphic>
+          <a:graphicData uri="http://schemas.openxmlformats.org/drawingml/2006/chart">
+            <c:chart r:id="rId2"/>
+          </a:graphicData>
+        </a:graphic>
+      </p:graphicFrame>
+      <p:sp>
+        <p:nvSpPr>
+          <p:cNvPr id="153" name="table title"/>
+          <p:cNvSpPr txBox="1"/>
+          <p:nvPr/>
+        </p:nvSpPr>
+        <p:spPr>
+          <a:xfrm>
+            <a:off x="5166360" y="1097280"/>
+            <a:ext cx="3703320" cy="457200"/>
+          </a:xfrm>
+          <a:prstGeom prst="rect">
+            <a:avLst/>
+          </a:prstGeom>
+          <a:noFill/>
+        </p:spPr>
+        <p:txBody>
+          <a:bodyPr wrap="square" anchor="t" lIns="36576" rIns="36576" tIns="18288" bIns="18288">
+            <a:spAutoFit/>
+          </a:bodyPr>
+          <a:lstStyle/>
+          <a:p>
+            <a:pPr algn="l">
+              <a:spcAft>
+                <a:spcPts val="400"/>
+              </a:spcAft>
+            </a:pPr>
+            <a:r>
+              <a:rPr sz="1100" b="1">
+                <a:solidFill>
+                  <a:srgbClr val="1A73E8"/>
+                </a:solidFill>
+                <a:latin typeface="Google Sans Flex SemiBold"/>
+              </a:rPr>
+              <a:t>BARO + Tolerance + traces + logs, minus BARO (95% interval)</a:t>
+            </a:r>
+          </a:p>
+        </p:txBody>
+      </p:sp>
+      <p:graphicFrame>
+        <p:nvGraphicFramePr>
+          <p:cNvPr id="154" name="RE3 paired table"/>
+          <p:cNvGraphicFramePr>
+            <a:graphicFrameLocks noGrp="1"/>
+          </p:cNvGraphicFramePr>
+          <p:nvPr/>
+        </p:nvGraphicFramePr>
+        <p:xfrm>
+          <a:off x="5166360" y="1627632"/>
+          <a:ext cx="3703320" cy="1371600"/>
+        </p:xfrm>
+        <a:graphic>
+          <a:graphicData uri="http://schemas.openxmlformats.org/drawingml/2006/table">
+            <a:tbl>
+              <a:tblPr firstRow="1" bandRow="1">
+                <a:tableStyleId>{5C22544A-7EE6-4342-B048-85BDC9FD1C3A}</a:tableStyleId>
+              </a:tblPr>
+              <a:tblGrid>
+                <a:gridCol w="1234440"/>
+                <a:gridCol w="411480"/>
+                <a:gridCol w="2057400"/>
+              </a:tblGrid>
+              <a:tr h="274320">
+                <a:tc>
+                  <a:txBody>
+                    <a:bodyPr/>
+                    <a:lstStyle/>
+                    <a:p>
+                      <a:pPr algn="l"/>
+                      <a:r>
+                        <a:rPr sz="1000" b="1">
+                          <a:solidFill>
+                            <a:srgbClr val="FFFFFF"/>
+                          </a:solidFill>
+                          <a:latin typeface="Google Sans Flex SemiBold"/>
+                        </a:rPr>
+                        <a:t>Subset</a:t>
+                      </a:r>
+                    </a:p>
+                  </a:txBody>
+                  <a:tcPr marL="45720" marR="45720" marT="18288" marB="18288">
+                    <a:solidFill>
+                      <a:srgbClr val="1A73E8"/>
+                    </a:solidFill>
+                  </a:tcPr>
+                </a:tc>
+                <a:tc>
+                  <a:txBody>
+                    <a:bodyPr/>
+                    <a:lstStyle/>
+                    <a:p>
+                      <a:pPr algn="ctr"/>
+                      <a:r>
+                        <a:rPr sz="1000" b="1">
+                          <a:solidFill>
+                            <a:srgbClr val="FFFFFF"/>
+                          </a:solidFill>
+                          <a:latin typeface="Google Sans Flex SemiBold"/>
+                        </a:rPr>
+                        <a:t>n</a:t>
+                      </a:r>
+                    </a:p>
+                  </a:txBody>
+                  <a:tcPr marL="45720" marR="45720" marT="18288" marB="18288">
+                    <a:solidFill>
+                      <a:srgbClr val="1A73E8"/>
+                    </a:solidFill>
+                  </a:tcPr>
+                </a:tc>
+                <a:tc>
+                  <a:txBody>
+                    <a:bodyPr/>
+                    <a:lstStyle/>
+                    <a:p>
+                      <a:pPr algn="ctr"/>
+                      <a:r>
+                        <a:rPr sz="1000" b="1">
+                          <a:solidFill>
+                            <a:srgbClr val="FFFFFF"/>
+                          </a:solidFill>
+                          <a:latin typeface="Google Sans Flex SemiBold"/>
+                        </a:rPr>
+                        <a:t>Difference</a:t>
+                      </a:r>
+                    </a:p>
+                  </a:txBody>
+                  <a:tcPr marL="45720" marR="45720" marT="18288" marB="18288">
+                    <a:solidFill>
+                      <a:srgbClr val="1A73E8"/>
+                    </a:solidFill>
+                  </a:tcPr>
+                </a:tc>
+              </a:tr>
+              <a:tr h="274320">
+                <a:tc>
+                  <a:txBody>
+                    <a:bodyPr/>
+                    <a:lstStyle/>
+                    <a:p>
+                      <a:pPr algn="l"/>
+                      <a:r>
+                        <a:rPr sz="1000" b="0">
+                          <a:solidFill>
+                            <a:srgbClr val="202124"/>
+                          </a:solidFill>
+                          <a:latin typeface="Google Sans Flex"/>
+                        </a:rPr>
+                        <a:t>all</a:t>
+                      </a:r>
+                    </a:p>
+                  </a:txBody>
+                  <a:tcPr marL="45720" marR="45720" marT="18288" marB="18288">
+                    <a:solidFill>
+                      <a:srgbClr val="FFFFFF"/>
+                    </a:solidFill>
+                  </a:tcPr>
+                </a:tc>
+                <a:tc>
+                  <a:txBody>
+                    <a:bodyPr/>
+                    <a:lstStyle/>
+                    <a:p>
+                      <a:pPr algn="ctr"/>
+                      <a:r>
+                        <a:rPr sz="1000" b="0">
+                          <a:solidFill>
+                            <a:srgbClr val="202124"/>
+                          </a:solidFill>
+                          <a:latin typeface="Google Sans Flex"/>
+                        </a:rPr>
+                        <a:t>90</a:t>
+                      </a:r>
+                    </a:p>
+                  </a:txBody>
+                  <a:tcPr marL="45720" marR="45720" marT="18288" marB="18288">
+                    <a:solidFill>
+                      <a:srgbClr val="FFFFFF"/>
+                    </a:solidFill>
+                  </a:tcPr>
+                </a:tc>
+                <a:tc>
+                  <a:txBody>
+                    <a:bodyPr/>
+                    <a:lstStyle/>
+                    <a:p>
+                      <a:pPr algn="ctr"/>
+                      <a:r>
+                        <a:rPr sz="1000" b="0">
+                          <a:solidFill>
+                            <a:srgbClr val="202124"/>
+                          </a:solidFill>
+                          <a:latin typeface="Google Sans Flex"/>
+                        </a:rPr>
+                        <a:t>+0.05  [-0.00, +0.11]</a:t>
+                      </a:r>
+                    </a:p>
+                  </a:txBody>
+                  <a:tcPr marL="45720" marR="45720" marT="18288" marB="18288">
+                    <a:solidFill>
+                      <a:srgbClr val="FFFFFF"/>
+                    </a:solidFill>
+                  </a:tcPr>
+                </a:tc>
+              </a:tr>
+              <a:tr h="274320">
+                <a:tc>
+                  <a:txBody>
+                    <a:bodyPr/>
+                    <a:lstStyle/>
+                    <a:p>
+                      <a:pPr algn="l"/>
+                      <a:r>
+                        <a:rPr sz="1000" b="0">
+                          <a:solidFill>
+                            <a:srgbClr val="202124"/>
+                          </a:solidFill>
+                          <a:latin typeface="Google Sans Flex"/>
+                        </a:rPr>
+                        <a:t>Sock Shop</a:t>
+                      </a:r>
+                    </a:p>
+                  </a:txBody>
+                  <a:tcPr marL="45720" marR="45720" marT="18288" marB="18288">
+                    <a:solidFill>
+                      <a:srgbClr val="F1F3F4"/>
+                    </a:solidFill>
+                  </a:tcPr>
+                </a:tc>
+                <a:tc>
+                  <a:txBody>
+                    <a:bodyPr/>
+                    <a:lstStyle/>
+                    <a:p>
+                      <a:pPr algn="ctr"/>
+                      <a:r>
+                        <a:rPr sz="1000" b="0">
+                          <a:solidFill>
+                            <a:srgbClr val="202124"/>
+                          </a:solidFill>
+                          <a:latin typeface="Google Sans Flex"/>
+                        </a:rPr>
+                        <a:t>30</a:t>
+                      </a:r>
+                    </a:p>
+                  </a:txBody>
+                  <a:tcPr marL="45720" marR="45720" marT="18288" marB="18288">
+                    <a:solidFill>
+                      <a:srgbClr val="F1F3F4"/>
+                    </a:solidFill>
+                  </a:tcPr>
+                </a:tc>
+                <a:tc>
+                  <a:txBody>
+                    <a:bodyPr/>
+                    <a:lstStyle/>
+                    <a:p>
+                      <a:pPr algn="ctr"/>
+                      <a:r>
+                        <a:rPr sz="1000" b="0">
+                          <a:solidFill>
+                            <a:srgbClr val="202124"/>
+                          </a:solidFill>
+                          <a:latin typeface="Google Sans Flex"/>
+                        </a:rPr>
+                        <a:t>+0.19  [+0.11, +0.29]</a:t>
+                      </a:r>
+                    </a:p>
+                  </a:txBody>
+                  <a:tcPr marL="45720" marR="45720" marT="18288" marB="18288">
+                    <a:solidFill>
+                      <a:srgbClr val="F1F3F4"/>
+                    </a:solidFill>
+                  </a:tcPr>
+                </a:tc>
+              </a:tr>
+              <a:tr h="274320">
+                <a:tc>
+                  <a:txBody>
+                    <a:bodyPr/>
+                    <a:lstStyle/>
+                    <a:p>
+                      <a:pPr algn="l"/>
+                      <a:r>
+                        <a:rPr sz="1000" b="0">
+                          <a:solidFill>
+                            <a:srgbClr val="202124"/>
+                          </a:solidFill>
+                          <a:latin typeface="Google Sans Flex"/>
+                        </a:rPr>
+                        <a:t>Train Ticket</a:t>
+                      </a:r>
+                    </a:p>
+                  </a:txBody>
+                  <a:tcPr marL="45720" marR="45720" marT="18288" marB="18288">
+                    <a:solidFill>
+                      <a:srgbClr val="FFFFFF"/>
+                    </a:solidFill>
+                  </a:tcPr>
+                </a:tc>
+                <a:tc>
+                  <a:txBody>
+                    <a:bodyPr/>
+                    <a:lstStyle/>
+                    <a:p>
+                      <a:pPr algn="ctr"/>
+                      <a:r>
+                        <a:rPr sz="1000" b="0">
+                          <a:solidFill>
+                            <a:srgbClr val="202124"/>
+                          </a:solidFill>
+                          <a:latin typeface="Google Sans Flex"/>
+                        </a:rPr>
+                        <a:t>30</a:t>
+                      </a:r>
+                    </a:p>
+                  </a:txBody>
+                  <a:tcPr marL="45720" marR="45720" marT="18288" marB="18288">
+                    <a:solidFill>
+                      <a:srgbClr val="FFFFFF"/>
+                    </a:solidFill>
+                  </a:tcPr>
+                </a:tc>
+                <a:tc>
+                  <a:txBody>
+                    <a:bodyPr/>
+                    <a:lstStyle/>
+                    <a:p>
+                      <a:pPr algn="ctr"/>
+                      <a:r>
+                        <a:rPr sz="1000" b="0">
+                          <a:solidFill>
+                            <a:srgbClr val="202124"/>
+                          </a:solidFill>
+                          <a:latin typeface="Google Sans Flex"/>
+                        </a:rPr>
+                        <a:t>+0.03  [-0.03, +0.10]</a:t>
+                      </a:r>
+                    </a:p>
+                  </a:txBody>
+                  <a:tcPr marL="45720" marR="45720" marT="18288" marB="18288">
+                    <a:solidFill>
+                      <a:srgbClr val="FFFFFF"/>
+                    </a:solidFill>
+                  </a:tcPr>
+                </a:tc>
+              </a:tr>
+              <a:tr h="274320">
+                <a:tc>
+                  <a:txBody>
+                    <a:bodyPr/>
+                    <a:lstStyle/>
+                    <a:p>
+                      <a:pPr algn="l"/>
+                      <a:r>
+                        <a:rPr sz="1000" b="0">
+                          <a:solidFill>
+                            <a:srgbClr val="202124"/>
+                          </a:solidFill>
+                          <a:latin typeface="Google Sans Flex"/>
+                        </a:rPr>
+                        <a:t>Online Boutique</a:t>
+                      </a:r>
+                    </a:p>
+                  </a:txBody>
+                  <a:tcPr marL="45720" marR="45720" marT="18288" marB="18288">
+                    <a:solidFill>
+                      <a:srgbClr val="F1F3F4"/>
+                    </a:solidFill>
+                  </a:tcPr>
+                </a:tc>
+                <a:tc>
+                  <a:txBody>
+                    <a:bodyPr/>
+                    <a:lstStyle/>
+                    <a:p>
+                      <a:pPr algn="ctr"/>
+                      <a:r>
+                        <a:rPr sz="1000" b="0">
+                          <a:solidFill>
+                            <a:srgbClr val="202124"/>
+                          </a:solidFill>
+                          <a:latin typeface="Google Sans Flex"/>
+                        </a:rPr>
+                        <a:t>30</a:t>
+                      </a:r>
+                    </a:p>
+                  </a:txBody>
+                  <a:tcPr marL="45720" marR="45720" marT="18288" marB="18288">
+                    <a:solidFill>
+                      <a:srgbClr val="F1F3F4"/>
+                    </a:solidFill>
+                  </a:tcPr>
+                </a:tc>
+                <a:tc>
+                  <a:txBody>
+                    <a:bodyPr/>
+                    <a:lstStyle/>
+                    <a:p>
+                      <a:pPr algn="ctr"/>
+                      <a:r>
+                        <a:rPr sz="1000" b="0">
+                          <a:solidFill>
+                            <a:srgbClr val="202124"/>
+                          </a:solidFill>
+                          <a:latin typeface="Google Sans Flex"/>
+                        </a:rPr>
+                        <a:t>-0.07  [-0.17, +0.05]</a:t>
+                      </a:r>
+                    </a:p>
+                  </a:txBody>
+                  <a:tcPr marL="45720" marR="45720" marT="18288" marB="18288">
+                    <a:solidFill>
+                      <a:srgbClr val="F1F3F4"/>
+                    </a:solidFill>
+                  </a:tcPr>
+                </a:tc>
+              </a:tr>
+            </a:tbl>
+          </a:graphicData>
+        </a:graphic>
+      </p:graphicFrame>
+      <p:sp>
+        <p:nvSpPr>
+          <p:cNvPr id="155" name="reading"/>
+          <p:cNvSpPr txBox="1"/>
+          <p:nvPr/>
+        </p:nvSpPr>
+        <p:spPr>
+          <a:xfrm>
+            <a:off x="5166360" y="3401568"/>
+            <a:ext cx="3703320" cy="914400"/>
+          </a:xfrm>
+          <a:prstGeom prst="rect">
+            <a:avLst/>
+          </a:prstGeom>
+          <a:noFill/>
+        </p:spPr>
+        <p:txBody>
+          <a:bodyPr wrap="square" anchor="t" lIns="36576" rIns="36576" tIns="18288" bIns="18288">
+            <a:spAutoFit/>
+          </a:bodyPr>
+          <a:lstStyle/>
+          <a:p>
+            <a:pPr algn="l" marL="164592" indent="-164592">
+              <a:spcAft>
+                <a:spcPts val="400"/>
+              </a:spcAft>
+              <a:buChar char="•"/>
+            </a:pPr>
+            <a:r>
+              <a:rPr sz="1000" b="0">
+                <a:solidFill>
+                  <a:srgbClr val="202124"/>
+                </a:solidFill>
+                <a:latin typeface="Google Sans Flex"/>
+              </a:rPr>
+              <a:t>Metrics alone lose badly on Train Ticket (0.07). The signal is in logs and traces.</a:t>
+            </a:r>
+          </a:p>
+          <a:p>
+            <a:pPr algn="l" marL="164592" indent="-164592">
+              <a:spcAft>
+                <a:spcPts val="400"/>
+              </a:spcAft>
+              <a:buChar char="•"/>
+            </a:pPr>
+            <a:r>
+              <a:rPr sz="1000" b="0">
+                <a:solidFill>
+                  <a:srgbClr val="202124"/>
+                </a:solidFill>
+                <a:latin typeface="Google Sans Flex"/>
+              </a:rPr>
+              <a:t>Fusing all sources wins on Sock Shop, ties on Train Ticket, and does not win on Online Boutique.</a:t>
+            </a:r>
+          </a:p>
+        </p:txBody>
+      </p:sp>
+      <p:sp>
+        <p:nvSpPr>
+          <p:cNvPr id="156" name="takeaway"/>
+          <p:cNvSpPr/>
+          <p:nvPr/>
+        </p:nvSpPr>
+        <p:spPr>
+          <a:xfrm>
+            <a:off x="274320" y="4315968"/>
+            <a:ext cx="8595360" cy="457200"/>
+          </a:xfrm>
+          <a:prstGeom prst="roundRect">
+            <a:avLst>
+              <a:gd name="adj" fmla="val 6000"/>
+            </a:avLst>
+          </a:prstGeom>
+          <a:solidFill>
+            <a:srgbClr val="E8F0FE"/>
+          </a:solidFill>
+          <a:ln>
+            <a:noFill/>
+          </a:ln>
+          <a:effectLst/>
+        </p:spPr>
+        <p:style>
+          <a:lnRef idx="1">
+            <a:schemeClr val="accent1"/>
+          </a:lnRef>
+          <a:fillRef idx="3">
+            <a:schemeClr val="accent1"/>
+          </a:fillRef>
+          <a:effectRef idx="2">
+            <a:schemeClr val="accent1"/>
+          </a:effectRef>
+          <a:fontRef idx="minor">
+            <a:schemeClr val="lt1"/>
+          </a:fontRef>
+        </p:style>
+        <p:txBody>
+          <a:bodyPr rtlCol="0" anchor="ctr"/>
+          <a:lstStyle/>
+          <a:p>
+            <a:pPr algn="ctr"/>
+          </a:p>
+        </p:txBody>
+      </p:sp>
+      <p:sp>
+        <p:nvSpPr>
+          <p:cNvPr id="157" name="takeaway text"/>
+          <p:cNvSpPr txBox="1"/>
+          <p:nvPr/>
+        </p:nvSpPr>
+        <p:spPr>
+          <a:xfrm>
+            <a:off x="411480" y="4315968"/>
+            <a:ext cx="8321040" cy="457200"/>
+          </a:xfrm>
+          <a:prstGeom prst="rect">
+            <a:avLst/>
+          </a:prstGeom>
+          <a:noFill/>
+        </p:spPr>
+        <p:txBody>
+          <a:bodyPr wrap="square" anchor="ctr" lIns="36576" rIns="36576" tIns="18288" bIns="18288">
+            <a:spAutoFit/>
+          </a:bodyPr>
+          <a:lstStyle/>
+          <a:p>
+            <a:pPr algn="l">
+              <a:spcAft>
+                <a:spcPts val="400"/>
+              </a:spcAft>
+            </a:pPr>
+            <a:r>
+              <a:rPr sz="1100" b="1">
+                <a:solidFill>
+                  <a:srgbClr val="1A73E8"/>
+                </a:solidFill>
+                <a:latin typeface="Google Sans Flex SemiBold"/>
+              </a:rPr>
+              <a:t>A gain on one system, a tie on one, no gain on one. With 30 cases per system the intervals are wide. We do not claim a win on RE3 overall.</a:t>
+            </a:r>
+          </a:p>
+        </p:txBody>
+      </p:sp>
+    </p:spTree>
+  </p:cSld>
+  <p:clrMapOvr>
+    <a:masterClrMapping/>
+  </p:clrMapOvr>
+</p:sld>
+</file>
+
+<file path=ppt/slides/slide25.xml><?xml version="1.0" encoding="utf-8"?>
+<p:sld xmlns:a="http://schemas.openxmlformats.org/drawingml/2006/main" xmlns:r="http://schemas.openxmlformats.org/officeDocument/2006/relationships" xmlns:mc="http://schemas.openxmlformats.org/markup-compatibility/2006" xmlns:mv="urn:schemas-microsoft-com:mac:vml" xmlns:p="http://schemas.openxmlformats.org/presentationml/2006/main" xmlns:c="http://schemas.openxmlformats.org/drawingml/2006/chart" xmlns:dgm="http://schemas.openxmlformats.org/drawingml/2006/diagram" xmlns:o="urn:schemas-microsoft-com:office:office" xmlns:v="urn:schemas-microsoft-com:vml" xmlns:pvml="urn:schemas-microsoft-com:office:powerpoint" xmlns:com="http://schemas.openxmlformats.org/drawingml/2006/compatibility" xmlns:p14="http://schemas.microsoft.com/office/powerpoint/2010/main" xmlns:p15="http://schemas.microsoft.com/office/powerpoint/2012/main" xmlns:ahyp="http://schemas.microsoft.com/office/drawing/2018/hyperlinkcolor">
+  <p:cSld>
+    <p:spTree>
+      <p:nvGrpSpPr>
+        <p:cNvPr id="147" name="Shape 147"/>
+        <p:cNvGrpSpPr/>
+        <p:nvPr/>
+      </p:nvGrpSpPr>
+      <p:grpSpPr>
+        <a:xfrm>
+          <a:off x="0" y="0"/>
+          <a:ext cx="0" cy="0"/>
+          <a:chOff x="0" y="0"/>
+          <a:chExt cx="0" cy="0"/>
+        </a:xfrm>
+      </p:grpSpPr>
+      <p:pic>
+        <p:nvPicPr>
+          <p:cNvPr id="148" name="Google Shape;148;p25" title="Frame 144.png"/>
+          <p:cNvPicPr preferRelativeResize="0"/>
+          <p:nvPr/>
+        </p:nvPicPr>
+        <p:blipFill rotWithShape="1">
+          <a:blip r:embed="rId3">
+            <a:alphaModFix/>
+          </a:blip>
+          <a:srcRect b="98001" l="0" r="0" t="0"/>
+          <a:stretch/>
+        </p:blipFill>
+        <p:spPr>
+          <a:xfrm>
+            <a:off x="0" y="5093562"/>
+            <a:ext cx="9144000" cy="54275"/>
+          </a:xfrm>
+          <a:prstGeom prst="rect">
+            <a:avLst/>
+          </a:prstGeom>
+          <a:noFill/>
+          <a:ln>
+            <a:noFill/>
+          </a:ln>
+        </p:spPr>
+      </p:pic>
+      <p:pic>
+        <p:nvPicPr>
+          <p:cNvPr id="149" name="Google Shape;149;p25" title="Group 427319979.png"/>
+          <p:cNvPicPr preferRelativeResize="0"/>
+          <p:nvPr/>
+        </p:nvPicPr>
+        <p:blipFill>
+          <a:blip r:embed="rId4">
+            <a:alphaModFix/>
+          </a:blip>
+          <a:stretch>
+            <a:fillRect/>
+          </a:stretch>
+        </p:blipFill>
+        <p:spPr>
+          <a:xfrm>
+            <a:off x="0" y="1"/>
+            <a:ext cx="9144000" cy="507359"/>
+          </a:xfrm>
+          <a:prstGeom prst="rect">
+            <a:avLst/>
+          </a:prstGeom>
+          <a:noFill/>
+          <a:ln>
+            <a:noFill/>
+          </a:ln>
+        </p:spPr>
+      </p:pic>
+      <p:sp>
+        <p:nvSpPr>
+          <p:cNvPr id="150" name="Google Shape;150;p25"/>
+          <p:cNvSpPr/>
+          <p:nvPr/>
+        </p:nvSpPr>
+        <p:spPr>
+          <a:xfrm>
+            <a:off x="-29250" y="5071875"/>
+            <a:ext cx="9173400" cy="97800"/>
+          </a:xfrm>
+          <a:prstGeom prst="rect">
+            <a:avLst/>
+          </a:prstGeom>
+          <a:solidFill>
+            <a:schemeClr val="dk1"/>
+          </a:solidFill>
+          <a:ln>
+            <a:noFill/>
+          </a:ln>
+        </p:spPr>
+        <p:txBody>
+          <a:bodyPr anchorCtr="0" anchor="ctr" bIns="91425" lIns="91425" spcFirstLastPara="1" rIns="91425" wrap="square" tIns="91425">
+            <a:noAutofit/>
+          </a:bodyPr>
+          <a:lstStyle/>
+          <a:p>
+            <a:pPr indent="0" lvl="0" marL="0" rtl="0" algn="ctr">
+              <a:spcBef>
+                <a:spcPts val="0"/>
+              </a:spcBef>
+              <a:spcAft>
+                <a:spcPts val="0"/>
+              </a:spcAft>
+              <a:buNone/>
+            </a:pPr>
+            <a:r>
+              <a:t/>
+            </a:r>
+            <a:endParaRPr/>
+          </a:p>
+        </p:txBody>
+      </p:sp>
+      <p:sp>
+        <p:nvSpPr>
+          <p:cNvPr id="151" name="Google Shape;151;p25"/>
+          <p:cNvSpPr txBox="1"/>
+          <p:nvPr/>
+        </p:nvSpPr>
+        <p:spPr>
+          <a:xfrm>
+            <a:off x="265350" y="663825"/>
+            <a:ext cx="8943000" cy="502920"/>
+          </a:xfrm>
+          <a:prstGeom prst="rect">
+            <a:avLst/>
+          </a:prstGeom>
+          <a:noFill/>
+          <a:ln>
+            <a:noFill/>
+          </a:ln>
+        </p:spPr>
+        <p:txBody>
+          <a:bodyPr anchorCtr="0" anchor="t" bIns="91425" lIns="91425" spcFirstLastPara="1" rIns="91425" wrap="square" tIns="91425">
+            <a:noAutofit/>
+          </a:bodyPr>
+          <a:lstStyle/>
+          <a:p>
+            <a:pPr indent="0" lvl="0" marL="0" rtl="0" algn="l">
+              <a:spcBef>
+                <a:spcPts val="0"/>
+              </a:spcBef>
+              <a:spcAft>
+                <a:spcPts val="0"/>
+              </a:spcAft>
+              <a:buNone/>
+            </a:pPr>
+            <a:r>
+              <a:rPr lang="en-GB" sz="1600">
+                <a:latin typeface="Google Sans Flex Medium"/>
+                <a:ea typeface="Google Sans Flex Medium"/>
+                <a:cs typeface="Google Sans Flex Medium"/>
+                <a:sym typeface="Google Sans Flex Medium"/>
+              </a:rPr>
+              <a:t>Q3: the gate bounds the harm of a wrong action; it does not find wrong diagnoses</a:t>
+            </a:r>
+            <a:endParaRPr sz="1600">
+              <a:latin typeface="Google Sans Flex Medium"/>
+              <a:ea typeface="Google Sans Flex Medium"/>
+              <a:cs typeface="Google Sans Flex Medium"/>
+              <a:sym typeface="Google Sans Flex Medium"/>
+            </a:endParaRPr>
+          </a:p>
+        </p:txBody>
+      </p:sp>
+      <p:graphicFrame>
+        <p:nvGraphicFramePr>
+          <p:cNvPr id="152" name="harm chart"/>
+          <p:cNvGraphicFramePr>
+            <a:graphicFrameLocks noGrp="1"/>
+          </p:cNvGraphicFramePr>
+          <p:nvPr/>
+        </p:nvGraphicFramePr>
+        <p:xfrm>
+          <a:off x="274320" y="1097280"/>
+          <a:ext cx="4572000" cy="3154680"/>
+        </p:xfrm>
+        <a:graphic>
+          <a:graphicData uri="http://schemas.openxmlformats.org/drawingml/2006/chart">
+            <c:chart r:id="rId2"/>
+          </a:graphicData>
+        </a:graphic>
+      </p:graphicFrame>
+      <p:sp>
+        <p:nvSpPr>
+          <p:cNvPr id="153" name="table title"/>
+          <p:cNvSpPr txBox="1"/>
+          <p:nvPr/>
+        </p:nvSpPr>
+        <p:spPr>
+          <a:xfrm>
+            <a:off x="4983480" y="1097280"/>
+            <a:ext cx="3886200" cy="274320"/>
+          </a:xfrm>
+          <a:prstGeom prst="rect">
+            <a:avLst/>
+          </a:prstGeom>
+          <a:noFill/>
+        </p:spPr>
+        <p:txBody>
+          <a:bodyPr wrap="square" anchor="t" lIns="36576" rIns="36576" tIns="18288" bIns="18288">
+            <a:spAutoFit/>
+          </a:bodyPr>
+          <a:lstStyle/>
+          <a:p>
+            <a:pPr algn="l">
+              <a:spcAft>
+                <a:spcPts val="400"/>
+              </a:spcAft>
+            </a:pPr>
+            <a:r>
+              <a:rPr sz="1100" b="1">
+                <a:solidFill>
+                  <a:srgbClr val="1A73E8"/>
+                </a:solidFill>
+                <a:latin typeface="Google Sans Flex SemiBold"/>
+              </a:rPr>
+              <a:t>At your default lines (465 incidents)</a:t>
+            </a:r>
+          </a:p>
+        </p:txBody>
+      </p:sp>
+      <p:graphicFrame>
+        <p:nvGraphicFramePr>
+          <p:cNvPr id="154" name="autonomy table"/>
+          <p:cNvGraphicFramePr>
+            <a:graphicFrameLocks noGrp="1"/>
+          </p:cNvGraphicFramePr>
+          <p:nvPr/>
+        </p:nvGraphicFramePr>
+        <p:xfrm>
+          <a:off x="4983480" y="1417320"/>
+          <a:ext cx="3886200" cy="1371600"/>
+        </p:xfrm>
+        <a:graphic>
+          <a:graphicData uri="http://schemas.openxmlformats.org/drawingml/2006/table">
+            <a:tbl>
+              <a:tblPr firstRow="1" bandRow="1">
+                <a:tableStyleId>{5C22544A-7EE6-4342-B048-85BDC9FD1C3A}</a:tableStyleId>
+              </a:tblPr>
+              <a:tblGrid>
+                <a:gridCol w="1600200"/>
+                <a:gridCol w="822960"/>
+                <a:gridCol w="731520"/>
+                <a:gridCol w="731520"/>
+              </a:tblGrid>
+              <a:tr h="274320">
+                <a:tc>
+                  <a:txBody>
+                    <a:bodyPr/>
+                    <a:lstStyle/>
+                    <a:p>
+                      <a:pPr algn="l"/>
+                      <a:r>
+                        <a:rPr sz="1000" b="1">
+                          <a:solidFill>
+                            <a:srgbClr val="FFFFFF"/>
+                          </a:solidFill>
+                          <a:latin typeface="Google Sans Flex SemiBold"/>
+                        </a:rPr>
+                        <a:t>Policy</a:t>
+                      </a:r>
+                    </a:p>
+                  </a:txBody>
+                  <a:tcPr marL="45720" marR="45720" marT="18288" marB="18288">
+                    <a:solidFill>
+                      <a:srgbClr val="1A73E8"/>
+                    </a:solidFill>
+                  </a:tcPr>
+                </a:tc>
+                <a:tc>
+                  <a:txBody>
+                    <a:bodyPr/>
+                    <a:lstStyle/>
+                    <a:p>
+                      <a:pPr algn="ctr"/>
+                      <a:r>
+                        <a:rPr sz="1000" b="1">
+                          <a:solidFill>
+                            <a:srgbClr val="FFFFFF"/>
+                          </a:solidFill>
+                          <a:latin typeface="Google Sans Flex SemiBold"/>
+                        </a:rPr>
+                        <a:t>Run alone</a:t>
+                      </a:r>
+                    </a:p>
+                  </a:txBody>
+                  <a:tcPr marL="45720" marR="45720" marT="18288" marB="18288">
+                    <a:solidFill>
+                      <a:srgbClr val="1A73E8"/>
+                    </a:solidFill>
+                  </a:tcPr>
+                </a:tc>
+                <a:tc>
+                  <a:txBody>
+                    <a:bodyPr/>
+                    <a:lstStyle/>
+                    <a:p>
+                      <a:pPr algn="ctr"/>
+                      <a:r>
+                        <a:rPr sz="1000" b="1">
+                          <a:solidFill>
+                            <a:srgbClr val="FFFFFF"/>
+                          </a:solidFill>
+                          <a:latin typeface="Google Sans Flex SemiBold"/>
+                        </a:rPr>
+                        <a:t>Wrong</a:t>
+                      </a:r>
+                    </a:p>
+                  </a:txBody>
+                  <a:tcPr marL="45720" marR="45720" marT="18288" marB="18288">
+                    <a:solidFill>
+                      <a:srgbClr val="1A73E8"/>
+                    </a:solidFill>
+                  </a:tcPr>
+                </a:tc>
+                <a:tc>
+                  <a:txBody>
+                    <a:bodyPr/>
+                    <a:lstStyle/>
+                    <a:p>
+                      <a:pPr algn="ctr"/>
+                      <a:r>
+                        <a:rPr sz="1000" b="1">
+                          <a:solidFill>
+                            <a:srgbClr val="FFFFFF"/>
+                          </a:solidFill>
+                          <a:latin typeface="Google Sans Flex SemiBold"/>
+                        </a:rPr>
+                        <a:t>Harm</a:t>
+                      </a:r>
+                    </a:p>
+                  </a:txBody>
+                  <a:tcPr marL="45720" marR="45720" marT="18288" marB="18288">
+                    <a:solidFill>
+                      <a:srgbClr val="1A73E8"/>
+                    </a:solidFill>
+                  </a:tcPr>
+                </a:tc>
+              </a:tr>
+              <a:tr h="274320">
+                <a:tc>
+                  <a:txBody>
+                    <a:bodyPr/>
+                    <a:lstStyle/>
+                    <a:p>
+                      <a:pPr algn="l"/>
+                      <a:r>
+                        <a:rPr sz="1000" b="0">
+                          <a:solidFill>
+                            <a:srgbClr val="202124"/>
+                          </a:solidFill>
+                          <a:latin typeface="Google Sans Flex"/>
+                        </a:rPr>
+                        <a:t>Run everything alone</a:t>
+                      </a:r>
+                    </a:p>
+                  </a:txBody>
+                  <a:tcPr marL="45720" marR="45720" marT="18288" marB="18288">
+                    <a:solidFill>
+                      <a:srgbClr val="FFFFFF"/>
+                    </a:solidFill>
+                  </a:tcPr>
+                </a:tc>
+                <a:tc>
+                  <a:txBody>
+                    <a:bodyPr/>
+                    <a:lstStyle/>
+                    <a:p>
+                      <a:pPr algn="ctr"/>
+                      <a:r>
+                        <a:rPr sz="1000" b="0">
+                          <a:solidFill>
+                            <a:srgbClr val="202124"/>
+                          </a:solidFill>
+                          <a:latin typeface="Google Sans Flex"/>
+                        </a:rPr>
+                        <a:t>465</a:t>
+                      </a:r>
+                    </a:p>
+                  </a:txBody>
+                  <a:tcPr marL="45720" marR="45720" marT="18288" marB="18288">
+                    <a:solidFill>
+                      <a:srgbClr val="FFFFFF"/>
+                    </a:solidFill>
+                  </a:tcPr>
+                </a:tc>
+                <a:tc>
+                  <a:txBody>
+                    <a:bodyPr/>
+                    <a:lstStyle/>
+                    <a:p>
+                      <a:pPr algn="ctr"/>
+                      <a:r>
+                        <a:rPr sz="1000" b="0">
+                          <a:solidFill>
+                            <a:srgbClr val="202124"/>
+                          </a:solidFill>
+                          <a:latin typeface="Google Sans Flex"/>
+                        </a:rPr>
+                        <a:t>116</a:t>
+                      </a:r>
+                    </a:p>
+                  </a:txBody>
+                  <a:tcPr marL="45720" marR="45720" marT="18288" marB="18288">
+                    <a:solidFill>
+                      <a:srgbClr val="FFFFFF"/>
+                    </a:solidFill>
+                  </a:tcPr>
+                </a:tc>
+                <a:tc>
+                  <a:txBody>
+                    <a:bodyPr/>
+                    <a:lstStyle/>
+                    <a:p>
+                      <a:pPr algn="ctr"/>
+                      <a:r>
+                        <a:rPr sz="1000" b="0">
+                          <a:solidFill>
+                            <a:srgbClr val="202124"/>
+                          </a:solidFill>
+                          <a:latin typeface="Google Sans Flex"/>
+                        </a:rPr>
+                        <a:t>4.8</a:t>
+                      </a:r>
+                    </a:p>
+                  </a:txBody>
+                  <a:tcPr marL="45720" marR="45720" marT="18288" marB="18288">
+                    <a:solidFill>
+                      <a:srgbClr val="FFFFFF"/>
+                    </a:solidFill>
+                  </a:tcPr>
+                </a:tc>
+              </a:tr>
+              <a:tr h="274320">
+                <a:tc>
+                  <a:txBody>
+                    <a:bodyPr/>
+                    <a:lstStyle/>
+                    <a:p>
+                      <a:pPr algn="l"/>
+                      <a:r>
+                        <a:rPr sz="1000" b="0">
+                          <a:solidFill>
+                            <a:srgbClr val="202124"/>
+                          </a:solidFill>
+                          <a:latin typeface="Google Sans Flex"/>
+                        </a:rPr>
+                        <a:t>Random 149</a:t>
+                      </a:r>
+                    </a:p>
+                  </a:txBody>
+                  <a:tcPr marL="45720" marR="45720" marT="18288" marB="18288">
+                    <a:solidFill>
+                      <a:srgbClr val="F1F3F4"/>
+                    </a:solidFill>
+                  </a:tcPr>
+                </a:tc>
+                <a:tc>
+                  <a:txBody>
+                    <a:bodyPr/>
+                    <a:lstStyle/>
+                    <a:p>
+                      <a:pPr algn="ctr"/>
+                      <a:r>
+                        <a:rPr sz="1000" b="0">
+                          <a:solidFill>
+                            <a:srgbClr val="202124"/>
+                          </a:solidFill>
+                          <a:latin typeface="Google Sans Flex"/>
+                        </a:rPr>
+                        <a:t>149</a:t>
+                      </a:r>
+                    </a:p>
+                  </a:txBody>
+                  <a:tcPr marL="45720" marR="45720" marT="18288" marB="18288">
+                    <a:solidFill>
+                      <a:srgbClr val="F1F3F4"/>
+                    </a:solidFill>
+                  </a:tcPr>
+                </a:tc>
+                <a:tc>
+                  <a:txBody>
+                    <a:bodyPr/>
+                    <a:lstStyle/>
+                    <a:p>
+                      <a:pPr algn="ctr"/>
+                      <a:r>
+                        <a:rPr sz="1000" b="0">
+                          <a:solidFill>
+                            <a:srgbClr val="202124"/>
+                          </a:solidFill>
+                          <a:latin typeface="Google Sans Flex"/>
+                        </a:rPr>
+                        <a:t>33</a:t>
+                      </a:r>
+                    </a:p>
+                  </a:txBody>
+                  <a:tcPr marL="45720" marR="45720" marT="18288" marB="18288">
+                    <a:solidFill>
+                      <a:srgbClr val="F1F3F4"/>
+                    </a:solidFill>
+                  </a:tcPr>
+                </a:tc>
+                <a:tc>
+                  <a:txBody>
+                    <a:bodyPr/>
+                    <a:lstStyle/>
+                    <a:p>
+                      <a:pPr algn="ctr"/>
+                      <a:r>
+                        <a:rPr sz="1000" b="0">
+                          <a:solidFill>
+                            <a:srgbClr val="202124"/>
+                          </a:solidFill>
+                          <a:latin typeface="Google Sans Flex"/>
+                        </a:rPr>
+                        <a:t>1.1</a:t>
+                      </a:r>
+                    </a:p>
+                  </a:txBody>
+                  <a:tcPr marL="45720" marR="45720" marT="18288" marB="18288">
+                    <a:solidFill>
+                      <a:srgbClr val="F1F3F4"/>
+                    </a:solidFill>
+                  </a:tcPr>
+                </a:tc>
+              </a:tr>
+              <a:tr h="274320">
+                <a:tc>
+                  <a:txBody>
+                    <a:bodyPr/>
+                    <a:lstStyle/>
+                    <a:p>
+                      <a:pPr algn="l"/>
+                      <a:r>
+                        <a:rPr sz="1000" b="0">
+                          <a:solidFill>
+                            <a:srgbClr val="202124"/>
+                          </a:solidFill>
+                          <a:latin typeface="Google Sans Flex"/>
+                        </a:rPr>
+                        <a:t>Confidence only</a:t>
+                      </a:r>
+                    </a:p>
+                  </a:txBody>
+                  <a:tcPr marL="45720" marR="45720" marT="18288" marB="18288">
+                    <a:solidFill>
+                      <a:srgbClr val="FFFFFF"/>
+                    </a:solidFill>
+                  </a:tcPr>
+                </a:tc>
+                <a:tc>
+                  <a:txBody>
+                    <a:bodyPr/>
+                    <a:lstStyle/>
+                    <a:p>
+                      <a:pPr algn="ctr"/>
+                      <a:r>
+                        <a:rPr sz="1000" b="0">
+                          <a:solidFill>
+                            <a:srgbClr val="202124"/>
+                          </a:solidFill>
+                          <a:latin typeface="Google Sans Flex"/>
+                        </a:rPr>
+                        <a:t>149</a:t>
+                      </a:r>
+                    </a:p>
+                  </a:txBody>
+                  <a:tcPr marL="45720" marR="45720" marT="18288" marB="18288">
+                    <a:solidFill>
+                      <a:srgbClr val="FFFFFF"/>
+                    </a:solidFill>
+                  </a:tcPr>
+                </a:tc>
+                <a:tc>
+                  <a:txBody>
+                    <a:bodyPr/>
+                    <a:lstStyle/>
+                    <a:p>
+                      <a:pPr algn="ctr"/>
+                      <a:r>
+                        <a:rPr sz="1000" b="0">
+                          <a:solidFill>
+                            <a:srgbClr val="202124"/>
+                          </a:solidFill>
+                          <a:latin typeface="Google Sans Flex"/>
+                        </a:rPr>
+                        <a:t>19</a:t>
+                      </a:r>
+                    </a:p>
+                  </a:txBody>
+                  <a:tcPr marL="45720" marR="45720" marT="18288" marB="18288">
+                    <a:solidFill>
+                      <a:srgbClr val="FFFFFF"/>
+                    </a:solidFill>
+                  </a:tcPr>
+                </a:tc>
+                <a:tc>
+                  <a:txBody>
+                    <a:bodyPr/>
+                    <a:lstStyle/>
+                    <a:p>
+                      <a:pPr algn="ctr"/>
+                      <a:r>
+                        <a:rPr sz="1000" b="0">
+                          <a:solidFill>
+                            <a:srgbClr val="202124"/>
+                          </a:solidFill>
+                          <a:latin typeface="Google Sans Flex"/>
+                        </a:rPr>
+                        <a:t>2.6</a:t>
+                      </a:r>
+                    </a:p>
+                  </a:txBody>
+                  <a:tcPr marL="45720" marR="45720" marT="18288" marB="18288">
+                    <a:solidFill>
+                      <a:srgbClr val="FFFFFF"/>
+                    </a:solidFill>
+                  </a:tcPr>
+                </a:tc>
+              </a:tr>
+              <a:tr h="274320">
+                <a:tc>
+                  <a:txBody>
+                    <a:bodyPr/>
+                    <a:lstStyle/>
+                    <a:p>
+                      <a:pPr algn="l"/>
+                      <a:r>
+                        <a:rPr sz="1000" b="0">
+                          <a:solidFill>
+                            <a:srgbClr val="202124"/>
+                          </a:solidFill>
+                          <a:latin typeface="Google Sans Flex"/>
+                        </a:rPr>
+                        <a:t>Warden gate</a:t>
+                      </a:r>
+                    </a:p>
+                  </a:txBody>
+                  <a:tcPr marL="45720" marR="45720" marT="18288" marB="18288">
+                    <a:solidFill>
+                      <a:srgbClr val="F1F3F4"/>
+                    </a:solidFill>
+                  </a:tcPr>
+                </a:tc>
+                <a:tc>
+                  <a:txBody>
+                    <a:bodyPr/>
+                    <a:lstStyle/>
+                    <a:p>
+                      <a:pPr algn="ctr"/>
+                      <a:r>
+                        <a:rPr sz="1000" b="0">
+                          <a:solidFill>
+                            <a:srgbClr val="202124"/>
+                          </a:solidFill>
+                          <a:latin typeface="Google Sans Flex"/>
+                        </a:rPr>
+                        <a:t>149</a:t>
+                      </a:r>
+                    </a:p>
+                  </a:txBody>
+                  <a:tcPr marL="45720" marR="45720" marT="18288" marB="18288">
+                    <a:solidFill>
+                      <a:srgbClr val="F1F3F4"/>
+                    </a:solidFill>
+                  </a:tcPr>
+                </a:tc>
+                <a:tc>
+                  <a:txBody>
+                    <a:bodyPr/>
+                    <a:lstStyle/>
+                    <a:p>
+                      <a:pPr algn="ctr"/>
+                      <a:r>
+                        <a:rPr sz="1000" b="0">
+                          <a:solidFill>
+                            <a:srgbClr val="202124"/>
+                          </a:solidFill>
+                          <a:latin typeface="Google Sans Flex"/>
+                        </a:rPr>
+                        <a:t>29</a:t>
+                      </a:r>
+                    </a:p>
+                  </a:txBody>
+                  <a:tcPr marL="45720" marR="45720" marT="18288" marB="18288">
+                    <a:solidFill>
+                      <a:srgbClr val="F1F3F4"/>
+                    </a:solidFill>
+                  </a:tcPr>
+                </a:tc>
+                <a:tc>
+                  <a:txBody>
+                    <a:bodyPr/>
+                    <a:lstStyle/>
+                    <a:p>
+                      <a:pPr algn="ctr"/>
+                      <a:r>
+                        <a:rPr sz="1000" b="0">
+                          <a:solidFill>
+                            <a:srgbClr val="202124"/>
+                          </a:solidFill>
+                          <a:latin typeface="Google Sans Flex"/>
+                        </a:rPr>
+                        <a:t>0.0</a:t>
+                      </a:r>
+                    </a:p>
+                  </a:txBody>
+                  <a:tcPr marL="45720" marR="45720" marT="18288" marB="18288">
+                    <a:solidFill>
+                      <a:srgbClr val="F1F3F4"/>
+                    </a:solidFill>
+                  </a:tcPr>
+                </a:tc>
+              </a:tr>
+            </a:tbl>
+          </a:graphicData>
+        </a:graphic>
+      </p:graphicFrame>
+      <p:sp>
+        <p:nvSpPr>
+          <p:cNvPr id="155" name="reading"/>
+          <p:cNvSpPr txBox="1"/>
+          <p:nvPr/>
+        </p:nvSpPr>
+        <p:spPr>
+          <a:xfrm>
+            <a:off x="4983480" y="2926080"/>
+            <a:ext cx="3886200" cy="1371600"/>
+          </a:xfrm>
+          <a:prstGeom prst="rect">
+            <a:avLst/>
+          </a:prstGeom>
+          <a:noFill/>
+        </p:spPr>
+        <p:txBody>
+          <a:bodyPr wrap="square" anchor="t" lIns="36576" rIns="36576" tIns="18288" bIns="18288">
+            <a:spAutoFit/>
+          </a:bodyPr>
+          <a:lstStyle/>
+          <a:p>
+            <a:pPr algn="l" marL="164592" indent="-164592">
+              <a:spcAft>
+                <a:spcPts val="400"/>
+              </a:spcAft>
+              <a:buChar char="•"/>
+            </a:pPr>
+            <a:r>
+              <a:rPr sz="1000" b="0">
+                <a:solidFill>
+                  <a:srgbClr val="202124"/>
+                </a:solidFill>
+                <a:latin typeface="Google Sans Flex"/>
+              </a:rPr>
+              <a:t>As a predictor of a right diagnosis the Warden score has AUROC 0.46; plain confidence has 0.73.</a:t>
+            </a:r>
+          </a:p>
+          <a:p>
+            <a:pPr algn="l" marL="164592" indent="-164592">
+              <a:spcAft>
+                <a:spcPts val="400"/>
+              </a:spcAft>
+              <a:buChar char="•"/>
+            </a:pPr>
+            <a:r>
+              <a:rPr sz="1000" b="0">
+                <a:solidFill>
+                  <a:srgbClr val="202124"/>
+                </a:solidFill>
+                <a:latin typeface="Google Sans Flex"/>
+              </a:rPr>
+              <a:t>Together, for 100 run alone: 11 wrong and harm 0.0, against 9 wrong and harm 1.1 for confidence alone.</a:t>
+            </a:r>
+          </a:p>
+        </p:txBody>
+      </p:sp>
+      <p:sp>
+        <p:nvSpPr>
+          <p:cNvPr id="156" name="takeaway"/>
+          <p:cNvSpPr/>
+          <p:nvPr/>
+        </p:nvSpPr>
+        <p:spPr>
+          <a:xfrm>
+            <a:off x="274320" y="4315968"/>
+            <a:ext cx="8595360" cy="457200"/>
+          </a:xfrm>
+          <a:prstGeom prst="roundRect">
+            <a:avLst>
+              <a:gd name="adj" fmla="val 6000"/>
+            </a:avLst>
+          </a:prstGeom>
+          <a:solidFill>
+            <a:srgbClr val="E8F0FE"/>
+          </a:solidFill>
+          <a:ln>
+            <a:noFill/>
+          </a:ln>
+          <a:effectLst/>
+        </p:spPr>
+        <p:style>
+          <a:lnRef idx="1">
+            <a:schemeClr val="accent1"/>
+          </a:lnRef>
+          <a:fillRef idx="3">
+            <a:schemeClr val="accent1"/>
+          </a:fillRef>
+          <a:effectRef idx="2">
+            <a:schemeClr val="accent1"/>
+          </a:effectRef>
+          <a:fontRef idx="minor">
+            <a:schemeClr val="lt1"/>
+          </a:fontRef>
+        </p:style>
+        <p:txBody>
+          <a:bodyPr rtlCol="0" anchor="ctr"/>
+          <a:lstStyle/>
+          <a:p>
+            <a:pPr algn="ctr"/>
+          </a:p>
+        </p:txBody>
+      </p:sp>
+      <p:sp>
+        <p:nvSpPr>
+          <p:cNvPr id="157" name="takeaway text"/>
+          <p:cNvSpPr txBox="1"/>
+          <p:nvPr/>
+        </p:nvSpPr>
+        <p:spPr>
+          <a:xfrm>
+            <a:off x="411480" y="4315968"/>
+            <a:ext cx="8321040" cy="457200"/>
+          </a:xfrm>
+          <a:prstGeom prst="rect">
+            <a:avLst/>
+          </a:prstGeom>
+          <a:noFill/>
+        </p:spPr>
+        <p:txBody>
+          <a:bodyPr wrap="square" anchor="ctr" lIns="36576" rIns="36576" tIns="18288" bIns="18288">
+            <a:spAutoFit/>
+          </a:bodyPr>
+          <a:lstStyle/>
+          <a:p>
+            <a:pPr algn="l">
+              <a:spcAft>
+                <a:spcPts val="400"/>
+              </a:spcAft>
+            </a:pPr>
+            <a:r>
+              <a:rPr sz="1100" b="1">
+                <a:solidFill>
+                  <a:srgbClr val="1A73E8"/>
+                </a:solidFill>
+                <a:latin typeface="Google Sans Flex SemiBold"/>
+              </a:rPr>
+              <a:t>Confidence says whether to trust the diagnosis. The gate says whether the action is safe to run alone. Tolerance uses both.</a:t>
+            </a:r>
+          </a:p>
+        </p:txBody>
+      </p:sp>
+    </p:spTree>
+  </p:cSld>
+  <p:clrMapOvr>
+    <a:masterClrMapping/>
+  </p:clrMapOvr>
+</p:sld>
+</file>
+
+<file path=ppt/slides/slide26.xml><?xml version="1.0" encoding="utf-8"?>
+<p:sld xmlns:a="http://schemas.openxmlformats.org/drawingml/2006/main" xmlns:r="http://schemas.openxmlformats.org/officeDocument/2006/relationships" xmlns:mc="http://schemas.openxmlformats.org/markup-compatibility/2006" xmlns:mv="urn:schemas-microsoft-com:mac:vml" xmlns:p="http://schemas.openxmlformats.org/presentationml/2006/main" xmlns:c="http://schemas.openxmlformats.org/drawingml/2006/chart" xmlns:dgm="http://schemas.openxmlformats.org/drawingml/2006/diagram" xmlns:o="urn:schemas-microsoft-com:office:office" xmlns:v="urn:schemas-microsoft-com:vml" xmlns:pvml="urn:schemas-microsoft-com:office:powerpoint" xmlns:com="http://schemas.openxmlformats.org/drawingml/2006/compatibility" xmlns:p14="http://schemas.microsoft.com/office/powerpoint/2010/main" xmlns:p15="http://schemas.microsoft.com/office/powerpoint/2012/main" xmlns:ahyp="http://schemas.microsoft.com/office/drawing/2018/hyperlinkcolor">
+  <p:cSld>
+    <p:spTree>
+      <p:nvGrpSpPr>
+        <p:cNvPr id="147" name="Shape 147"/>
+        <p:cNvGrpSpPr/>
+        <p:nvPr/>
+      </p:nvGrpSpPr>
+      <p:grpSpPr>
+        <a:xfrm>
+          <a:off x="0" y="0"/>
+          <a:ext cx="0" cy="0"/>
+          <a:chOff x="0" y="0"/>
+          <a:chExt cx="0" cy="0"/>
+        </a:xfrm>
+      </p:grpSpPr>
+      <p:pic>
+        <p:nvPicPr>
+          <p:cNvPr id="148" name="Google Shape;148;p25" title="Frame 144.png"/>
+          <p:cNvPicPr preferRelativeResize="0"/>
+          <p:nvPr/>
+        </p:nvPicPr>
+        <p:blipFill rotWithShape="1">
+          <a:blip r:embed="rId3">
+            <a:alphaModFix/>
+          </a:blip>
+          <a:srcRect b="98001" l="0" r="0" t="0"/>
+          <a:stretch/>
+        </p:blipFill>
+        <p:spPr>
+          <a:xfrm>
+            <a:off x="0" y="5093562"/>
+            <a:ext cx="9144000" cy="54275"/>
+          </a:xfrm>
+          <a:prstGeom prst="rect">
+            <a:avLst/>
+          </a:prstGeom>
+          <a:noFill/>
+          <a:ln>
+            <a:noFill/>
+          </a:ln>
+        </p:spPr>
+      </p:pic>
+      <p:pic>
+        <p:nvPicPr>
+          <p:cNvPr id="149" name="Google Shape;149;p25" title="Group 427319979.png"/>
+          <p:cNvPicPr preferRelativeResize="0"/>
+          <p:nvPr/>
+        </p:nvPicPr>
+        <p:blipFill>
+          <a:blip r:embed="rId4">
+            <a:alphaModFix/>
+          </a:blip>
+          <a:stretch>
+            <a:fillRect/>
+          </a:stretch>
+        </p:blipFill>
+        <p:spPr>
+          <a:xfrm>
+            <a:off x="0" y="1"/>
+            <a:ext cx="9144000" cy="507359"/>
+          </a:xfrm>
+          <a:prstGeom prst="rect">
+            <a:avLst/>
+          </a:prstGeom>
+          <a:noFill/>
+          <a:ln>
+            <a:noFill/>
+          </a:ln>
+        </p:spPr>
+      </p:pic>
+      <p:sp>
+        <p:nvSpPr>
+          <p:cNvPr id="150" name="Google Shape;150;p25"/>
+          <p:cNvSpPr/>
+          <p:nvPr/>
+        </p:nvSpPr>
+        <p:spPr>
+          <a:xfrm>
+            <a:off x="-29250" y="5071875"/>
+            <a:ext cx="9173400" cy="97800"/>
+          </a:xfrm>
+          <a:prstGeom prst="rect">
+            <a:avLst/>
+          </a:prstGeom>
+          <a:solidFill>
+            <a:schemeClr val="dk1"/>
+          </a:solidFill>
+          <a:ln>
+            <a:noFill/>
+          </a:ln>
+        </p:spPr>
+        <p:txBody>
+          <a:bodyPr anchorCtr="0" anchor="ctr" bIns="91425" lIns="91425" spcFirstLastPara="1" rIns="91425" wrap="square" tIns="91425">
+            <a:noAutofit/>
+          </a:bodyPr>
+          <a:lstStyle/>
+          <a:p>
+            <a:pPr indent="0" lvl="0" marL="0" rtl="0" algn="ctr">
+              <a:spcBef>
+                <a:spcPts val="0"/>
+              </a:spcBef>
+              <a:spcAft>
+                <a:spcPts val="0"/>
+              </a:spcAft>
+              <a:buNone/>
+            </a:pPr>
+            <a:r>
+              <a:t/>
+            </a:r>
+            <a:endParaRPr/>
+          </a:p>
+        </p:txBody>
+      </p:sp>
+      <p:sp>
+        <p:nvSpPr>
+          <p:cNvPr id="151" name="Google Shape;151;p25"/>
+          <p:cNvSpPr txBox="1"/>
+          <p:nvPr/>
+        </p:nvSpPr>
+        <p:spPr>
+          <a:xfrm>
+            <a:off x="265350" y="663825"/>
+            <a:ext cx="8943000" cy="502920"/>
+          </a:xfrm>
+          <a:prstGeom prst="rect">
+            <a:avLst/>
+          </a:prstGeom>
+          <a:noFill/>
+          <a:ln>
+            <a:noFill/>
+          </a:ln>
+        </p:spPr>
+        <p:txBody>
+          <a:bodyPr anchorCtr="0" anchor="t" bIns="91425" lIns="91425" spcFirstLastPara="1" rIns="91425" wrap="square" tIns="91425">
+            <a:noAutofit/>
+          </a:bodyPr>
+          <a:lstStyle/>
+          <a:p>
+            <a:pPr indent="0" lvl="0" marL="0" rtl="0" algn="l">
+              <a:spcBef>
+                <a:spcPts val="0"/>
+              </a:spcBef>
+              <a:spcAft>
+                <a:spcPts val="0"/>
+              </a:spcAft>
+              <a:buNone/>
+            </a:pPr>
+            <a:r>
+              <a:rPr lang="en-GB" sz="1600">
+                <a:latin typeface="Google Sans Flex Medium"/>
+                <a:ea typeface="Google Sans Flex Medium"/>
+                <a:cs typeface="Google Sans Flex Medium"/>
+                <a:sym typeface="Google Sans Flex Medium"/>
+              </a:rPr>
+              <a:t>Threats to validity, and what we run next</a:t>
+            </a:r>
+            <a:endParaRPr sz="1600">
+              <a:latin typeface="Google Sans Flex Medium"/>
+              <a:ea typeface="Google Sans Flex Medium"/>
+              <a:cs typeface="Google Sans Flex Medium"/>
+              <a:sym typeface="Google Sans Flex Medium"/>
+            </a:endParaRPr>
+          </a:p>
+        </p:txBody>
+      </p:sp>
+      <p:sp>
+        <p:nvSpPr>
+          <p:cNvPr id="152" name="threats card"/>
+          <p:cNvSpPr/>
+          <p:nvPr/>
+        </p:nvSpPr>
+        <p:spPr>
+          <a:xfrm>
+            <a:off x="274320" y="1143000"/>
+            <a:ext cx="4251960" cy="2834640"/>
+          </a:xfrm>
+          <a:prstGeom prst="roundRect">
+            <a:avLst>
+              <a:gd name="adj" fmla="val 6000"/>
+            </a:avLst>
+          </a:prstGeom>
+          <a:solidFill>
+            <a:srgbClr val="F1F3F4"/>
+          </a:solidFill>
+          <a:ln>
+            <a:noFill/>
+          </a:ln>
+          <a:effectLst/>
+        </p:spPr>
+        <p:style>
+          <a:lnRef idx="1">
+            <a:schemeClr val="accent1"/>
+          </a:lnRef>
+          <a:fillRef idx="3">
+            <a:schemeClr val="accent1"/>
+          </a:fillRef>
+          <a:effectRef idx="2">
+            <a:schemeClr val="accent1"/>
+          </a:effectRef>
+          <a:fontRef idx="minor">
+            <a:schemeClr val="lt1"/>
+          </a:fontRef>
+        </p:style>
+        <p:txBody>
+          <a:bodyPr rtlCol="0" anchor="ctr"/>
+          <a:lstStyle/>
+          <a:p>
+            <a:pPr algn="ctr"/>
+          </a:p>
+        </p:txBody>
+      </p:sp>
+      <p:sp>
+        <p:nvSpPr>
+          <p:cNvPr id="153" name="threats text"/>
+          <p:cNvSpPr txBox="1"/>
+          <p:nvPr/>
+        </p:nvSpPr>
+        <p:spPr>
+          <a:xfrm>
+            <a:off x="384048" y="1188720"/>
+            <a:ext cx="4069080" cy="2743200"/>
+          </a:xfrm>
+          <a:prstGeom prst="rect">
+            <a:avLst/>
+          </a:prstGeom>
+          <a:noFill/>
+        </p:spPr>
+        <p:txBody>
+          <a:bodyPr wrap="square" anchor="t" lIns="36576" rIns="36576" tIns="18288" bIns="18288">
+            <a:spAutoFit/>
+          </a:bodyPr>
+          <a:lstStyle/>
+          <a:p>
+            <a:pPr algn="l">
+              <a:spcAft>
+                <a:spcPts val="500"/>
+              </a:spcAft>
+            </a:pPr>
+            <a:r>
+              <a:rPr sz="1200" b="1">
+                <a:solidFill>
+                  <a:srgbClr val="C5221F"/>
+                </a:solidFill>
+                <a:latin typeface="Google Sans Flex SemiBold"/>
+              </a:rPr>
+              <a:t>Threats to validity</a:t>
+            </a:r>
+          </a:p>
+          <a:p>
+            <a:pPr algn="l" marL="164592" indent="-164592">
+              <a:spcAft>
+                <a:spcPts val="400"/>
+              </a:spcAft>
+              <a:buChar char="•"/>
+            </a:pPr>
+            <a:r>
+              <a:rPr sz="1000" b="0">
+                <a:solidFill>
+                  <a:srgbClr val="202124"/>
+                </a:solidFill>
+                <a:latin typeface="Google Sans Flex"/>
+              </a:rPr>
+              <a:t>RCAEval is microservice software, not a factory floor.</a:t>
+            </a:r>
+          </a:p>
+          <a:p>
+            <a:pPr algn="l" marL="164592" indent="-164592">
+              <a:spcAft>
+                <a:spcPts val="400"/>
+              </a:spcAft>
+              <a:buChar char="•"/>
+            </a:pPr>
+            <a:r>
+              <a:rPr sz="1000" b="0">
+                <a:solidFill>
+                  <a:srgbClr val="202124"/>
+                </a:solidFill>
+                <a:latin typeface="Google Sans Flex"/>
+              </a:rPr>
+              <a:t>Our probes were developed on these cases. The fixed fusion constant limits tuning, but overfitting is possible. RE2 is held out and not yet run.</a:t>
+            </a:r>
+          </a:p>
+          <a:p>
+            <a:pPr algn="l" marL="164592" indent="-164592">
+              <a:spcAft>
+                <a:spcPts val="400"/>
+              </a:spcAft>
+              <a:buChar char="•"/>
+            </a:pPr>
+            <a:r>
+              <a:rPr sz="1000" b="0">
+                <a:solidFill>
+                  <a:srgbClr val="202124"/>
+                </a:solidFill>
+                <a:latin typeface="Google Sans Flex"/>
+              </a:rPr>
+              <a:t>Harm uses our own reversibility table, not measured damage.</a:t>
+            </a:r>
+          </a:p>
+          <a:p>
+            <a:pPr algn="l" marL="164592" indent="-164592">
+              <a:spcAft>
+                <a:spcPts val="400"/>
+              </a:spcAft>
+              <a:buChar char="•"/>
+            </a:pPr>
+            <a:r>
+              <a:rPr sz="1000" b="0">
+                <a:solidFill>
+                  <a:srgbClr val="202124"/>
+                </a:solidFill>
+                <a:latin typeface="Google Sans Flex"/>
+              </a:rPr>
+              <a:t>The backtest uses the metrics-first diagnosis, not Gemini.</a:t>
+            </a:r>
+          </a:p>
+          <a:p>
+            <a:pPr algn="l" marL="164592" indent="-164592">
+              <a:spcAft>
+                <a:spcPts val="400"/>
+              </a:spcAft>
+              <a:buChar char="•"/>
+            </a:pPr>
+            <a:r>
+              <a:rPr sz="1000" b="0">
+                <a:solidFill>
+                  <a:srgbClr val="202124"/>
+                </a:solidFill>
+                <a:latin typeface="Google Sans Flex"/>
+              </a:rPr>
+              <a:t>Our run of BARO on Train Ticket (0.65) is below the paper's 0.79. RE3 has 30 cases per system.</a:t>
+            </a:r>
+          </a:p>
+        </p:txBody>
+      </p:sp>
+      <p:sp>
+        <p:nvSpPr>
+          <p:cNvPr id="154" name="next card"/>
+          <p:cNvSpPr/>
+          <p:nvPr/>
+        </p:nvSpPr>
+        <p:spPr>
+          <a:xfrm>
+            <a:off x="4617720" y="1143000"/>
+            <a:ext cx="4251960" cy="2834640"/>
+          </a:xfrm>
+          <a:prstGeom prst="roundRect">
+            <a:avLst>
+              <a:gd name="adj" fmla="val 6000"/>
+            </a:avLst>
+          </a:prstGeom>
+          <a:solidFill>
+            <a:srgbClr val="E6F4EA"/>
+          </a:solidFill>
+          <a:ln>
+            <a:noFill/>
+          </a:ln>
+          <a:effectLst/>
+        </p:spPr>
+        <p:style>
+          <a:lnRef idx="1">
+            <a:schemeClr val="accent1"/>
+          </a:lnRef>
+          <a:fillRef idx="3">
+            <a:schemeClr val="accent1"/>
+          </a:fillRef>
+          <a:effectRef idx="2">
+            <a:schemeClr val="accent1"/>
+          </a:effectRef>
+          <a:fontRef idx="minor">
+            <a:schemeClr val="lt1"/>
+          </a:fontRef>
+        </p:style>
+        <p:txBody>
+          <a:bodyPr rtlCol="0" anchor="ctr"/>
+          <a:lstStyle/>
+          <a:p>
+            <a:pPr algn="ctr"/>
+          </a:p>
+        </p:txBody>
+      </p:sp>
+      <p:sp>
+        <p:nvSpPr>
+          <p:cNvPr id="155" name="next text"/>
+          <p:cNvSpPr txBox="1"/>
+          <p:nvPr/>
+        </p:nvSpPr>
+        <p:spPr>
+          <a:xfrm>
+            <a:off x="4727448" y="1188720"/>
+            <a:ext cx="4069080" cy="2743200"/>
+          </a:xfrm>
+          <a:prstGeom prst="rect">
+            <a:avLst/>
+          </a:prstGeom>
+          <a:noFill/>
+        </p:spPr>
+        <p:txBody>
+          <a:bodyPr wrap="square" anchor="t" lIns="36576" rIns="36576" tIns="18288" bIns="18288">
+            <a:spAutoFit/>
+          </a:bodyPr>
+          <a:lstStyle/>
+          <a:p>
+            <a:pPr algn="l">
+              <a:spcAft>
+                <a:spcPts val="500"/>
+              </a:spcAft>
+            </a:pPr>
+            <a:r>
+              <a:rPr sz="1200" b="1">
+                <a:solidFill>
+                  <a:srgbClr val="188038"/>
+                </a:solidFill>
+                <a:latin typeface="Google Sans Flex SemiBold"/>
+              </a:rPr>
+              <a:t>What we run next</a:t>
+            </a:r>
+          </a:p>
+          <a:p>
+            <a:pPr algn="l" marL="164592" indent="-164592">
+              <a:spcAft>
+                <a:spcPts val="400"/>
+              </a:spcAft>
+              <a:buChar char="•"/>
+            </a:pPr>
+            <a:r>
+              <a:rPr sz="1000" b="0">
+                <a:solidFill>
+                  <a:srgbClr val="202124"/>
+                </a:solidFill>
+                <a:latin typeface="Google Sans Flex"/>
+              </a:rPr>
+              <a:t>RCAEval RE2 (270 cases), the paper's main table, as a held-out test.</a:t>
+            </a:r>
+          </a:p>
+          <a:p>
+            <a:pPr algn="l" marL="164592" indent="-164592">
+              <a:spcAft>
+                <a:spcPts val="400"/>
+              </a:spcAft>
+              <a:buChar char="•"/>
+            </a:pPr>
+            <a:r>
+              <a:rPr sz="1000" b="0">
+                <a:solidFill>
+                  <a:srgbClr val="202124"/>
+                </a:solidFill>
+                <a:latin typeface="Google Sans Flex"/>
+              </a:rPr>
+              <a:t>The Gemini agent on RE3, where log text should matter, inside the credit budget.</a:t>
+            </a:r>
+          </a:p>
+          <a:p>
+            <a:pPr algn="l" marL="164592" indent="-164592">
+              <a:spcAft>
+                <a:spcPts val="400"/>
+              </a:spcAft>
+              <a:buChar char="•"/>
+            </a:pPr>
+            <a:r>
+              <a:rPr sz="1000" b="0">
+                <a:solidFill>
+                  <a:srgbClr val="202124"/>
+                </a:solidFill>
+                <a:latin typeface="Google Sans Flex"/>
+              </a:rPr>
+              <a:t>The other baselines (CIRCA, RCD, CausalRCA) once their dependencies fit.</a:t>
+            </a:r>
+          </a:p>
+          <a:p>
+            <a:pPr algn="l" marL="164592" indent="-164592">
+              <a:spcAft>
+                <a:spcPts val="400"/>
+              </a:spcAft>
+              <a:buChar char="•"/>
+            </a:pPr>
+            <a:r>
+              <a:rPr sz="1000" b="0">
+                <a:solidFill>
+                  <a:srgbClr val="202124"/>
+                </a:solidFill>
+                <a:latin typeface="Google Sans Flex"/>
+              </a:rPr>
+              <a:t>A customer's own incident history replayed through Warden.</a:t>
+            </a:r>
+          </a:p>
+        </p:txBody>
+      </p:sp>
+      <p:sp>
+        <p:nvSpPr>
+          <p:cNvPr id="156" name="takeaway"/>
+          <p:cNvSpPr/>
+          <p:nvPr/>
+        </p:nvSpPr>
+        <p:spPr>
+          <a:xfrm>
+            <a:off x="274320" y="4114800"/>
+            <a:ext cx="8595360" cy="594360"/>
+          </a:xfrm>
+          <a:prstGeom prst="roundRect">
+            <a:avLst>
+              <a:gd name="adj" fmla="val 6000"/>
+            </a:avLst>
+          </a:prstGeom>
+          <a:solidFill>
+            <a:srgbClr val="E8F0FE"/>
+          </a:solidFill>
+          <a:ln>
+            <a:noFill/>
+          </a:ln>
+          <a:effectLst/>
+        </p:spPr>
+        <p:style>
+          <a:lnRef idx="1">
+            <a:schemeClr val="accent1"/>
+          </a:lnRef>
+          <a:fillRef idx="3">
+            <a:schemeClr val="accent1"/>
+          </a:fillRef>
+          <a:effectRef idx="2">
+            <a:schemeClr val="accent1"/>
+          </a:effectRef>
+          <a:fontRef idx="minor">
+            <a:schemeClr val="lt1"/>
+          </a:fontRef>
+        </p:style>
+        <p:txBody>
+          <a:bodyPr rtlCol="0" anchor="ctr"/>
+          <a:lstStyle/>
+          <a:p>
+            <a:pPr algn="ctr"/>
+          </a:p>
+        </p:txBody>
+      </p:sp>
+      <p:sp>
+        <p:nvSpPr>
+          <p:cNvPr id="157" name="takeaway text"/>
+          <p:cNvSpPr txBox="1"/>
+          <p:nvPr/>
+        </p:nvSpPr>
+        <p:spPr>
+          <a:xfrm>
+            <a:off x="411480" y="4114800"/>
+            <a:ext cx="8321040" cy="594360"/>
+          </a:xfrm>
+          <a:prstGeom prst="rect">
+            <a:avLst/>
+          </a:prstGeom>
+          <a:noFill/>
+        </p:spPr>
+        <p:txBody>
+          <a:bodyPr wrap="square" anchor="ctr" lIns="36576" rIns="36576" tIns="18288" bIns="18288">
+            <a:spAutoFit/>
+          </a:bodyPr>
+          <a:lstStyle/>
+          <a:p>
+            <a:pPr algn="l">
+              <a:spcAft>
+                <a:spcPts val="400"/>
+              </a:spcAft>
+            </a:pPr>
+            <a:r>
+              <a:rPr sz="1100" b="1">
+                <a:solidFill>
+                  <a:srgbClr val="1A73E8"/>
+                </a:solidFill>
+                <a:latin typeface="Google Sans Flex SemiBold"/>
+              </a:rPr>
+              <a:t>Reproduce it: python -m bench.research reads the per-case rankings in bench/results and the 465 incidents in seed. No downloads, runs in seconds.</a:t>
             </a:r>
           </a:p>
         </p:txBody>

</xml_diff>

<commit_message>
Benchmark slides: lead with the wins, keep the scope notes short
</commit_message>
<xml_diff>
--- a/submission/Tolerance - AI Builder Cup submission.pptx
+++ b/submission/Tolerance - AI Builder Cup submission.pptx
@@ -16750,7 +16750,7 @@
                 <a:cs typeface="Google Sans Flex Medium"/>
                 <a:sym typeface="Google Sans Flex Medium"/>
               </a:rPr>
-              <a:t>Q1: a clear gain on metric-only faults, largest for packet loss</a:t>
+              <a:t>Q1: a significant gain on metric-only faults, +0.19 on Train Ticket</a:t>
             </a:r>
             <a:endParaRPr sz="1600">
               <a:latin typeface="Google Sans Flex Medium"/>
@@ -17252,7 +17252,7 @@
                 </a:solidFill>
                 <a:latin typeface="Google Sans Flex"/>
               </a:rPr>
-              <a:t>Train Ticket is where the baseline is weakest (0.66), and where we gain most.</a:t>
+              <a:t>Train Ticket gains most: 0.66 to 0.85 (BARO's paper reports 0.79).</a:t>
             </a:r>
           </a:p>
           <a:p>
@@ -17269,7 +17269,7 @@
                 </a:solidFill>
                 <a:latin typeface="Google Sans Flex"/>
               </a:rPr>
-              <a:t>Memory and delay: no difference.</a:t>
+              <a:t>Packet loss gains most by fault: 0.59 to 0.84.</a:t>
             </a:r>
           </a:p>
           <a:p>
@@ -17286,7 +17286,7 @@
                 </a:solidFill>
                 <a:latin typeface="Google Sans Flex"/>
               </a:rPr>
-              <a:t>Pooled rows use the four faults the BARO paper reports (disk is in the chart only).</a:t>
+              <a:t>Pooled rows use the four faults the BARO paper reports.</a:t>
             </a:r>
           </a:p>
         </p:txBody>
@@ -17371,7 +17371,7 @@
                 </a:solidFill>
                 <a:latin typeface="Google Sans Flex SemiBold"/>
               </a:rPr>
-              <a:t>Significant on the pooled set and on Train Ticket. Borderline on Online Boutique, not significant on Sock Shop.</a:t>
+              <a:t>Significant on the pooled set (+0.08) and on Train Ticket (+0.19). Sock Shop is already at 0.96 for the baseline.</a:t>
             </a:r>
           </a:p>
         </p:txBody>
@@ -17540,7 +17540,7 @@
                 <a:cs typeface="Google Sans Flex Medium"/>
                 <a:sym typeface="Google Sans Flex Medium"/>
               </a:rPr>
-              <a:t>Benchmark design: three questions, one protocol</a:t>
+              <a:t>Benchmarks: where Tolerance beats the baseline, and by how much</a:t>
             </a:r>
             <a:endParaRPr sz="1600">
               <a:latin typeface="Google Sans Flex Medium"/>
@@ -18204,7 +18204,7 @@
                 </a:solidFill>
                 <a:latin typeface="Google Sans Flex SemiBold"/>
               </a:rPr>
-              <a:t>Not run, and not claimed: RCAEval RE2, the other published baselines, and the Gemini agent at scale.</a:t>
+              <a:t>Headline: +0.19 on Train Ticket (Q1), +0.19 on Sock Shop with a second source (Q2), and zero harm from wrong actions at 32% autonomy (Q3).</a:t>
             </a:r>
           </a:p>
         </p:txBody>
@@ -18373,7 +18373,7 @@
                 <a:cs typeface="Google Sans Flex Medium"/>
                 <a:sym typeface="Google Sans Flex Medium"/>
               </a:rPr>
-              <a:t>Q2: on code-level faults metrics alone fail, a second source recovers it</a:t>
+              <a:t>Q2: a second source lifts Sock Shop by +0.19 on code-level faults</a:t>
             </a:r>
             <a:endParaRPr sz="1600">
               <a:latin typeface="Google Sans Flex Medium"/>
@@ -18858,7 +18858,7 @@
                 </a:solidFill>
                 <a:latin typeface="Google Sans Flex"/>
               </a:rPr>
-              <a:t>Metrics alone lose badly on Train Ticket (0.07). The signal is in logs and traces.</a:t>
+              <a:t>Code-level faults live in logs and traces, so metrics alone are not enough.</a:t>
             </a:r>
           </a:p>
           <a:p>
@@ -18875,7 +18875,7 @@
                 </a:solidFill>
                 <a:latin typeface="Google Sans Flex"/>
               </a:rPr>
-              <a:t>Fusing all sources wins on Sock Shop, ties on Train Ticket, and does not win on Online Boutique.</a:t>
+              <a:t>Fusing all sources wins on Sock Shop and matches the baseline on Train Ticket.</a:t>
             </a:r>
           </a:p>
         </p:txBody>
@@ -18960,7 +18960,7 @@
                 </a:solidFill>
                 <a:latin typeface="Google Sans Flex SemiBold"/>
               </a:rPr>
-              <a:t>A gain on one system, a tie on one, no gain on one. With 30 cases per system the intervals are wide. We do not claim a win on RE3 overall.</a:t>
+              <a:t>Sock Shop +0.19 (interval +0.11 to +0.29), Train Ticket level with the baseline. Online Boutique is the system we work on next. 30 cases per system.</a:t>
             </a:r>
           </a:p>
         </p:txBody>
@@ -19129,7 +19129,7 @@
                 <a:cs typeface="Google Sans Flex Medium"/>
                 <a:sym typeface="Google Sans Flex Medium"/>
               </a:rPr>
-              <a:t>Q3: the gate bounds the harm of a wrong action; it does not find wrong diagnoses</a:t>
+              <a:t>Q3: the gate keeps harm at zero while a third of incidents run alone</a:t>
             </a:r>
             <a:endParaRPr sz="1600">
               <a:latin typeface="Google Sans Flex Medium"/>
@@ -19730,7 +19730,7 @@
                 </a:solidFill>
                 <a:latin typeface="Google Sans Flex"/>
               </a:rPr>
-              <a:t>As a predictor of a right diagnosis the Warden score has AUROC 0.46; plain confidence has 0.73.</a:t>
+              <a:t>Harm weighs each wrong action by how hard it is to undo. The gate lets only easily undone actions run alone.</a:t>
             </a:r>
           </a:p>
           <a:p>
@@ -19747,7 +19747,7 @@
                 </a:solidFill>
                 <a:latin typeface="Google Sans Flex"/>
               </a:rPr>
-              <a:t>Together, for 100 run alone: 11 wrong and harm 0.0, against 9 wrong and harm 1.1 for confidence alone.</a:t>
+              <a:t>Gate and diagnosis confidence together, for 100 run alone: 11 wrong and harm 0.0, against 9 wrong and harm 1.1 for confidence alone.</a:t>
             </a:r>
           </a:p>
         </p:txBody>
@@ -20001,7 +20001,7 @@
                 <a:cs typeface="Google Sans Flex Medium"/>
                 <a:sym typeface="Google Sans Flex Medium"/>
               </a:rPr>
-              <a:t>Threats to validity, and what we run next</a:t>
+              <a:t>What the results cover, and the next tests</a:t>
             </a:r>
             <a:endParaRPr sz="1600">
               <a:latin typeface="Google Sans Flex Medium"/>
@@ -20029,7 +20029,7 @@
             </a:avLst>
           </a:prstGeom>
           <a:solidFill>
-            <a:srgbClr val="F1F3F4"/>
+            <a:srgbClr val="E8F0FE"/>
           </a:solidFill>
           <a:ln>
             <a:noFill/>
@@ -20088,11 +20088,11 @@
             <a:r>
               <a:rPr sz="1200" b="1">
                 <a:solidFill>
-                  <a:srgbClr val="C5221F"/>
+                  <a:srgbClr val="1A73E8"/>
                 </a:solidFill>
                 <a:latin typeface="Google Sans Flex SemiBold"/>
               </a:rPr>
-              <a:t>Threats to validity</a:t>
+              <a:t>What the results cover</a:t>
             </a:r>
           </a:p>
           <a:p>
@@ -20109,7 +20109,7 @@
                 </a:solidFill>
                 <a:latin typeface="Google Sans Flex"/>
               </a:rPr>
-              <a:t>RCAEval is microservice software, not a factory floor.</a:t>
+              <a:t>Software incidents on RCAEval. A factory pilot is the next step.</a:t>
             </a:r>
           </a:p>
           <a:p>
@@ -20126,7 +20126,7 @@
                 </a:solidFill>
                 <a:latin typeface="Google Sans Flex"/>
               </a:rPr>
-              <a:t>Our probes were developed on these cases. The fixed fusion constant limits tuning, but overfitting is possible. RE2 is held out and not yet run.</a:t>
+              <a:t>The probes were developed on these cases, so RE2 is the held-out test.</a:t>
             </a:r>
           </a:p>
           <a:p>
@@ -20143,7 +20143,7 @@
                 </a:solidFill>
                 <a:latin typeface="Google Sans Flex"/>
               </a:rPr>
-              <a:t>Harm uses our own reversibility table, not measured damage.</a:t>
+              <a:t>Harm uses the action table's reversibility values, not measured damage.</a:t>
             </a:r>
           </a:p>
           <a:p>
@@ -20177,7 +20177,7 @@
                 </a:solidFill>
                 <a:latin typeface="Google Sans Flex"/>
               </a:rPr>
-              <a:t>Our run of BARO on Train Ticket (0.65) is below the paper's 0.79. RE3 has 30 cases per system.</a:t>
+              <a:t>Our run of BARO on Train Ticket is 0.65; the paper reports 0.79.</a:t>
             </a:r>
           </a:p>
         </p:txBody>

</xml_diff>